<commit_message>
Hoàn thiện giao diện, dữ liệu demo và tài liệu LAMS
Bổ sung trang tác giả, thể loại, bộ lọc bí danh và dữ liệu Catalog demo có nguồn rõ ràng. Nối số liệu Acquisition từ Core sang Insight, cập nhật các hợp đồng API và phần kiểm thử liên quan.

Kiểm tra lại Web và bản EXE Windows với 15 bài E2E mỗi bên; cập nhật báo cáo, slide và hướng dẫn chạy theo phần đã kiểm chứng. Ảnh bìa vẫn chờ duyệt thủ công, tài khoản demo cần người vận hành nhập mật khẩu tại máy.
</commit_message>
<xml_diff>
--- a/ho-so-nop-bai/slide/Bao_cao_LAMS_Thiet_ke_Web_nang_cao.pptx
+++ b/ho-so-nop-bai/slide/Bao_cao_LAMS_Thiet_ke_Web_nang_cao.pptx
@@ -2,27 +2,27 @@
 <file path=ppt/presentation.xml><?xml version="1.0" encoding="utf-8"?>
 <p:presentation xmlns:p="http://schemas.openxmlformats.org/presentationml/2006/main">
   <p:sldMasterIdLst>
-    <p:sldMasterId xmlns:r="http://schemas.openxmlformats.org/officeDocument/2006/relationships" id="2147483648" r:id="Rb779786bd2454e19"/>
+    <p:sldMasterId xmlns:r="http://schemas.openxmlformats.org/officeDocument/2006/relationships" id="2147483648" r:id="R21ace876855f48f7"/>
   </p:sldMasterIdLst>
   <p:notesMasterIdLst>
-    <p:notesMasterId xmlns:r="http://schemas.openxmlformats.org/officeDocument/2006/relationships" r:id="R340f7007b13343fd"/>
+    <p:notesMasterId xmlns:r="http://schemas.openxmlformats.org/officeDocument/2006/relationships" r:id="R50d36946675244ef"/>
   </p:notesMasterIdLst>
   <p:sldIdLst>
-    <p:sldId xmlns:r="http://schemas.openxmlformats.org/officeDocument/2006/relationships" id="256" r:id="R10507158ddc147f3"/>
-    <p:sldId xmlns:r="http://schemas.openxmlformats.org/officeDocument/2006/relationships" id="257" r:id="Rd504eab1e63c4ce6"/>
-    <p:sldId xmlns:r="http://schemas.openxmlformats.org/officeDocument/2006/relationships" id="258" r:id="Rca6cf8d9e95847f6"/>
-    <p:sldId xmlns:r="http://schemas.openxmlformats.org/officeDocument/2006/relationships" id="259" r:id="Ra745f3f488ff4cbc"/>
-    <p:sldId xmlns:r="http://schemas.openxmlformats.org/officeDocument/2006/relationships" id="260" r:id="R7d31ca14dd0f4472"/>
-    <p:sldId xmlns:r="http://schemas.openxmlformats.org/officeDocument/2006/relationships" id="261" r:id="Rda69a5bf427b4858"/>
-    <p:sldId xmlns:r="http://schemas.openxmlformats.org/officeDocument/2006/relationships" id="262" r:id="Rc75ac72e6db04373"/>
-    <p:sldId xmlns:r="http://schemas.openxmlformats.org/officeDocument/2006/relationships" id="263" r:id="Ra26f0c4989194db8"/>
-    <p:sldId xmlns:r="http://schemas.openxmlformats.org/officeDocument/2006/relationships" id="264" r:id="R984b4eaa41d44d6f"/>
-    <p:sldId xmlns:r="http://schemas.openxmlformats.org/officeDocument/2006/relationships" id="265" r:id="R85f68b97f5834548"/>
-    <p:sldId xmlns:r="http://schemas.openxmlformats.org/officeDocument/2006/relationships" id="266" r:id="R615b3f4aa59541c6"/>
-    <p:sldId xmlns:r="http://schemas.openxmlformats.org/officeDocument/2006/relationships" id="267" r:id="Re03db59c0a404e21"/>
-    <p:sldId xmlns:r="http://schemas.openxmlformats.org/officeDocument/2006/relationships" id="268" r:id="R9afba2afddbe4aed"/>
-    <p:sldId xmlns:r="http://schemas.openxmlformats.org/officeDocument/2006/relationships" id="269" r:id="R4c8f90cdd3dc4335"/>
-    <p:sldId xmlns:r="http://schemas.openxmlformats.org/officeDocument/2006/relationships" id="270" r:id="Radb31b732e0e47bc"/>
+    <p:sldId xmlns:r="http://schemas.openxmlformats.org/officeDocument/2006/relationships" id="256" r:id="R966b9922047d4fc8"/>
+    <p:sldId xmlns:r="http://schemas.openxmlformats.org/officeDocument/2006/relationships" id="257" r:id="Rd4218e99c2c44f37"/>
+    <p:sldId xmlns:r="http://schemas.openxmlformats.org/officeDocument/2006/relationships" id="258" r:id="R6cd36de7bca04428"/>
+    <p:sldId xmlns:r="http://schemas.openxmlformats.org/officeDocument/2006/relationships" id="259" r:id="R90d936398830448c"/>
+    <p:sldId xmlns:r="http://schemas.openxmlformats.org/officeDocument/2006/relationships" id="260" r:id="R506554166efe4d26"/>
+    <p:sldId xmlns:r="http://schemas.openxmlformats.org/officeDocument/2006/relationships" id="261" r:id="R24c131b33efd424a"/>
+    <p:sldId xmlns:r="http://schemas.openxmlformats.org/officeDocument/2006/relationships" id="262" r:id="R54098dedacb649c6"/>
+    <p:sldId xmlns:r="http://schemas.openxmlformats.org/officeDocument/2006/relationships" id="263" r:id="R8f60d2072bcc401d"/>
+    <p:sldId xmlns:r="http://schemas.openxmlformats.org/officeDocument/2006/relationships" id="264" r:id="R972192bccb1a4e55"/>
+    <p:sldId xmlns:r="http://schemas.openxmlformats.org/officeDocument/2006/relationships" id="265" r:id="R81c0fe5fc5324454"/>
+    <p:sldId xmlns:r="http://schemas.openxmlformats.org/officeDocument/2006/relationships" id="266" r:id="R8ee0874f8e1e4729"/>
+    <p:sldId xmlns:r="http://schemas.openxmlformats.org/officeDocument/2006/relationships" id="267" r:id="Ra81c48e5f95b4dd5"/>
+    <p:sldId xmlns:r="http://schemas.openxmlformats.org/officeDocument/2006/relationships" id="268" r:id="R7913585ddc084e46"/>
+    <p:sldId xmlns:r="http://schemas.openxmlformats.org/officeDocument/2006/relationships" id="269" r:id="Rc2c591d1d1c14ae4"/>
+    <p:sldId xmlns:r="http://schemas.openxmlformats.org/officeDocument/2006/relationships" id="270" r:id="R96fc249f697044f2"/>
   </p:sldIdLst>
   <p:sldSz cx="12192000" cy="6858000"/>
   <p:notesSz cx="6858000" cy="9144000"/>
@@ -526,7 +526,7 @@
           <a:lstStyle xmlns:a="http://schemas.openxmlformats.org/drawingml/2006/main"/>
           <a:p xmlns:a="http://schemas.openxmlformats.org/drawingml/2006/main">
             <a:r>
-              <a:t>Nguồn: tai-lieu/04-nghiep-vu/tim-kiem-thong-minh.md, PR #28 đã merge vào main 686203b và PR #27 head 6e03c9a. Chưa có API quản trị Alias cho thủ thư, chưa benchmark relevance bằng dữ liệu thật.</a:t>
+              <a:t>Nguồn: tai-lieu/04-nghiep-vu/tim-kiem-thong-minh.md, PR #28 đã merge main. Bộ lọc categoryTerm và API/UI quản trị Alias đang chờ review trong PR #27. Chưa benchmark relevance bằng dữ liệu vận hành.</a:t>
             </a:r>
           </a:p>
         </p:txBody>
@@ -596,7 +596,7 @@
           <a:lstStyle xmlns:a="http://schemas.openxmlformats.org/drawingml/2006/main"/>
           <a:p xmlns:a="http://schemas.openxmlformats.org/drawingml/2006/main">
             <a:r>
-              <a:t>Nguồn: nhánh DEV1 sau 6e03c9a và tai-lieu/04-nghiep-vu/de-xuat-bo-sung-sach.md. Sơ đồ mô tả luồng mục tiêu. API/UI hiện chỉ đọc và quyết định đề xuất đã có; chưa có read projection Core nên chưa tạo đề xuất từ dữ liệu thật. Không dùng số liệu fixture như dữ liệu vận hành.</a:t>
+              <a:t>Nguồn: tai-lieu/05-api-va-event/acquisition-read-contract.md, read projection Core và adapter Insight trên nhánh Tuấn. PostgreSQL integration và contract test kiểm từng lớp, nhưng chưa có E2E tạo đề xuất xuyên hai service trên EXE. APPROVED chỉ là quyết định nội bộ, không đặt mua sách.</a:t>
             </a:r>
           </a:p>
         </p:txBody>
@@ -666,7 +666,7 @@
           <a:lstStyle xmlns:a="http://schemas.openxmlformats.org/drawingml/2006/main"/>
           <a:p xmlns:a="http://schemas.openxmlformats.org/drawingml/2006/main">
             <a:r>
-              <a:t>CI đúng head 6e03c9a: https://github.com/Shuuma4869/He-thong-quan-ly-va-khai-thac-thu-vien/actions/runs/40239139758 . Test counts và E2E trích PR #27 trên cùng head. Đây là bằng chứng phát triển, chưa là chứng nhận production.</a:t>
+              <a:t>5/5 CI và số lượng Core/Insight/Frontend/E2E trong hàng giữa thuộc commit 6e03c9a: https://github.com/Shuuma4869/He-thong-quan-ly-va-khai-thac-thu-vien/actions/runs/40239139758 . Web và EXE E2E 15/15 thuộc working tree ngày 26/10/2026, chưa phải bằng chứng CI của commit cuối.</a:t>
             </a:r>
           </a:p>
         </p:txBody>
@@ -876,7 +876,7 @@
           <a:lstStyle xmlns:a="http://schemas.openxmlformats.org/drawingml/2006/main"/>
           <a:p xmlns:a="http://schemas.openxmlformats.org/drawingml/2006/main">
             <a:r>
-              <a:t>Phân công lấy từ chỉ đạo người dùng và README hiện tại. Đây là ownership Phase 5–7, không tự suy ra tỷ lệ đóng góp hay tình trạng hoàn thành của mọi phần.</a:t>
+              <a:t>Phân công và phương án dự phòng Phase 7 được chủ dự án xác nhận. Toàn giữ tác giả của phần truy vấn kiểm kê và Alias đã bàn giao; Tuấn làm Core Acquisition projection và CSV khi Toàn tạm dừng. Không suy ra tỷ lệ đóng góp.</a:t>
             </a:r>
           </a:p>
         </p:txBody>
@@ -1436,7 +1436,7 @@
           <a:lstStyle xmlns:a="http://schemas.openxmlformats.org/drawingml/2006/main"/>
           <a:p xmlns:a="http://schemas.openxmlformats.org/drawingml/2006/main">
             <a:r>
-              <a:t>Nguồn: tai-lieu/04-nghiep-vu/kiem-ke-ke-sach.md, code InventorySession trên main và PR #25 của Toàn. PR #25 còn review findings tại ngày 26/10/2026. Quét không tự đổi trạng thái BookCopy.</a:t>
+              <a:t>Nguồn: tai-lieu/04-nghiep-vu/kiem-ke-ke-sach.md, code InventorySession và commit của Toàn trong PR #25. Nhánh Tuấn giữ tác giả gốc khi tích hợp. Quét không tự đổi trạng thái BookCopy.</a:t>
             </a:r>
           </a:p>
         </p:txBody>
@@ -1483,7 +1483,7 @@
           <p:cNvPr id="3" name="Title">
             <a:extLst xmlns:a="http://schemas.openxmlformats.org/drawingml/2006/main">
               <a:ext uri="{FF2B5EF4-FFF2-40B4-BE49-F238E27FC236}">
-                <a16:creationId xmlns:a16="http://schemas.microsoft.com/office/drawing/2014/main" id="{76A3DD42-69E0-45F4-B859-6AAF45254756}"/>
+                <a16:creationId xmlns:a16="http://schemas.microsoft.com/office/drawing/2014/main" id="{9223ACB0-ABFF-45FA-8236-83A1BD5BD072}"/>
               </a:ext>
             </a:extLst>
           </p:cNvPr>
@@ -1712,7 +1712,7 @@
           <p:cNvPr id="2" name="Subtitle">
             <a:extLst xmlns:a="http://schemas.openxmlformats.org/drawingml/2006/main">
               <a:ext uri="{FF2B5EF4-FFF2-40B4-BE49-F238E27FC236}">
-                <a16:creationId xmlns:a16="http://schemas.microsoft.com/office/drawing/2014/main" id="{29ED46D0-CD36-42A5-91FA-84B17030CAAF}"/>
+                <a16:creationId xmlns:a16="http://schemas.microsoft.com/office/drawing/2014/main" id="{D6E99E14-9E27-424C-BB41-C60DC8A91061}"/>
               </a:ext>
             </a:extLst>
           </p:cNvPr>
@@ -1958,7 +1958,7 @@
           <p:cNvPr id="2" name="Section title">
             <a:extLst xmlns:a="http://schemas.openxmlformats.org/drawingml/2006/main">
               <a:ext uri="{FF2B5EF4-FFF2-40B4-BE49-F238E27FC236}">
-                <a16:creationId xmlns:a16="http://schemas.microsoft.com/office/drawing/2014/main" id="{0EDCF148-6E7F-41F7-ABAA-2813878C7935}"/>
+                <a16:creationId xmlns:a16="http://schemas.microsoft.com/office/drawing/2014/main" id="{DA8D4911-8749-4F10-BCEB-7065116288EA}"/>
               </a:ext>
             </a:extLst>
           </p:cNvPr>
@@ -2204,7 +2204,7 @@
           <p:cNvPr id="3" name="Title">
             <a:extLst xmlns:a="http://schemas.openxmlformats.org/drawingml/2006/main">
               <a:ext uri="{FF2B5EF4-FFF2-40B4-BE49-F238E27FC236}">
-                <a16:creationId xmlns:a16="http://schemas.microsoft.com/office/drawing/2014/main" id="{398BBE46-F354-43D8-9B37-1B9DFB2BA07E}"/>
+                <a16:creationId xmlns:a16="http://schemas.microsoft.com/office/drawing/2014/main" id="{F2CDC71A-19C2-47BC-8978-7021C975A7C6}"/>
               </a:ext>
             </a:extLst>
           </p:cNvPr>
@@ -2433,7 +2433,7 @@
           <p:cNvPr id="2" name="Body">
             <a:extLst xmlns:a="http://schemas.openxmlformats.org/drawingml/2006/main">
               <a:ext uri="{FF2B5EF4-FFF2-40B4-BE49-F238E27FC236}">
-                <a16:creationId xmlns:a16="http://schemas.microsoft.com/office/drawing/2014/main" id="{E7B95F26-FF5E-4117-914E-8B4A3B8C2AE0}"/>
+                <a16:creationId xmlns:a16="http://schemas.microsoft.com/office/drawing/2014/main" id="{77E7539C-19E4-416A-B9FB-CB7E24C06619}"/>
               </a:ext>
             </a:extLst>
           </p:cNvPr>
@@ -2679,7 +2679,7 @@
           <p:cNvPr id="4" name="Title">
             <a:extLst xmlns:a="http://schemas.openxmlformats.org/drawingml/2006/main">
               <a:ext uri="{FF2B5EF4-FFF2-40B4-BE49-F238E27FC236}">
-                <a16:creationId xmlns:a16="http://schemas.microsoft.com/office/drawing/2014/main" id="{8B0FD062-7ADE-4AD4-AE31-3772A42DCB34}"/>
+                <a16:creationId xmlns:a16="http://schemas.microsoft.com/office/drawing/2014/main" id="{21CD9559-ED80-421E-8677-2890CD98FA37}"/>
               </a:ext>
             </a:extLst>
           </p:cNvPr>
@@ -2908,7 +2908,7 @@
           <p:cNvPr id="2" name="Left column">
             <a:extLst xmlns:a="http://schemas.openxmlformats.org/drawingml/2006/main">
               <a:ext uri="{FF2B5EF4-FFF2-40B4-BE49-F238E27FC236}">
-                <a16:creationId xmlns:a16="http://schemas.microsoft.com/office/drawing/2014/main" id="{3435CCBC-25F6-41B1-9256-5FE355CC3303}"/>
+                <a16:creationId xmlns:a16="http://schemas.microsoft.com/office/drawing/2014/main" id="{C02D3A9F-267B-40E7-A2B3-C1C280677BDD}"/>
               </a:ext>
             </a:extLst>
           </p:cNvPr>
@@ -3137,7 +3137,7 @@
           <p:cNvPr id="3" name="Right column">
             <a:extLst xmlns:a="http://schemas.openxmlformats.org/drawingml/2006/main">
               <a:ext uri="{FF2B5EF4-FFF2-40B4-BE49-F238E27FC236}">
-                <a16:creationId xmlns:a16="http://schemas.microsoft.com/office/drawing/2014/main" id="{BBB5364B-688D-426C-87A6-4634C5283F2E}"/>
+                <a16:creationId xmlns:a16="http://schemas.microsoft.com/office/drawing/2014/main" id="{1CB3C0E8-D3F9-42E3-9540-70348EFC0646}"/>
               </a:ext>
             </a:extLst>
           </p:cNvPr>
@@ -3383,7 +3383,7 @@
           <p:cNvPr id="3" name="Title">
             <a:extLst xmlns:a="http://schemas.openxmlformats.org/drawingml/2006/main">
               <a:ext uri="{FF2B5EF4-FFF2-40B4-BE49-F238E27FC236}">
-                <a16:creationId xmlns:a16="http://schemas.microsoft.com/office/drawing/2014/main" id="{138BEB22-5F78-4CB3-9969-B5A936725A3A}"/>
+                <a16:creationId xmlns:a16="http://schemas.microsoft.com/office/drawing/2014/main" id="{05DD4A31-B98E-4438-B3C2-70CB95F10226}"/>
               </a:ext>
             </a:extLst>
           </p:cNvPr>
@@ -3612,7 +3612,7 @@
           <p:cNvPr id="2" name="Left column">
             <a:extLst xmlns:a="http://schemas.openxmlformats.org/drawingml/2006/main">
               <a:ext uri="{FF2B5EF4-FFF2-40B4-BE49-F238E27FC236}">
-                <a16:creationId xmlns:a16="http://schemas.microsoft.com/office/drawing/2014/main" id="{3DDEC5A5-958E-48FF-B23F-F297296418F1}"/>
+                <a16:creationId xmlns:a16="http://schemas.microsoft.com/office/drawing/2014/main" id="{F25361F2-8883-4D86-B004-13A2BD25587E}"/>
               </a:ext>
             </a:extLst>
           </p:cNvPr>
@@ -3879,12 +3879,12 @@
   </p:cSld>
   <p:clrMap bg1="lt1" tx1="dk1" bg2="lt2" tx2="dk2" accent1="accent1" accent2="accent2" accent3="accent3" accent4="accent4" accent5="accent5" accent6="accent6" hlink="hlink" folHlink="folHlink"/>
   <p:sldLayoutIdLst>
-    <p:sldLayoutId xmlns:r="http://schemas.openxmlformats.org/officeDocument/2006/relationships" id="2147483649" r:id="Rdbedf741e9754474"/>
-    <p:sldLayoutId xmlns:r="http://schemas.openxmlformats.org/officeDocument/2006/relationships" id="2147483650" r:id="Rdf8e625fd44e486d"/>
-    <p:sldLayoutId xmlns:r="http://schemas.openxmlformats.org/officeDocument/2006/relationships" id="2147483651" r:id="Raaeb90775d7d40a4"/>
-    <p:sldLayoutId xmlns:r="http://schemas.openxmlformats.org/officeDocument/2006/relationships" id="2147483652" r:id="Re3e34e6490384b3e"/>
-    <p:sldLayoutId xmlns:r="http://schemas.openxmlformats.org/officeDocument/2006/relationships" id="2147483653" r:id="Rc6438aee6dd9429a"/>
-    <p:sldLayoutId xmlns:r="http://schemas.openxmlformats.org/officeDocument/2006/relationships" id="2147483654" r:id="R6f3a5732cbf94f02"/>
+    <p:sldLayoutId xmlns:r="http://schemas.openxmlformats.org/officeDocument/2006/relationships" id="2147483649" r:id="R132e3162ef2d4f96"/>
+    <p:sldLayoutId xmlns:r="http://schemas.openxmlformats.org/officeDocument/2006/relationships" id="2147483650" r:id="Rbb4e500b24214d67"/>
+    <p:sldLayoutId xmlns:r="http://schemas.openxmlformats.org/officeDocument/2006/relationships" id="2147483651" r:id="Rcd3b61643f8548c3"/>
+    <p:sldLayoutId xmlns:r="http://schemas.openxmlformats.org/officeDocument/2006/relationships" id="2147483652" r:id="Rf70ef917cfc5419b"/>
+    <p:sldLayoutId xmlns:r="http://schemas.openxmlformats.org/officeDocument/2006/relationships" id="2147483653" r:id="R6588319dc2f74eed"/>
+    <p:sldLayoutId xmlns:r="http://schemas.openxmlformats.org/officeDocument/2006/relationships" id="2147483654" r:id="R8aadcbb536374776"/>
   </p:sldLayoutIdLst>
   <p:txStyles>
     <p:titleStyle>
@@ -4435,7 +4435,7 @@
           <p:cNvPr id="9" name="">
             <a:extLst xmlns:a="http://schemas.openxmlformats.org/drawingml/2006/main">
               <a:ext uri="{FF2B5EF4-FFF2-40B4-BE49-F238E27FC236}">
-                <a16:creationId xmlns:a16="http://schemas.microsoft.com/office/drawing/2014/main" id="{58541D04-FB03-4A86-8AEA-C71E5293720B}"/>
+                <a16:creationId xmlns:a16="http://schemas.microsoft.com/office/drawing/2014/main" id="{5B29A6E4-A7E0-4BF5-88EC-264AA43AAAAE}"/>
               </a:ext>
             </a:extLst>
           </p:cNvPr>
@@ -4445,7 +4445,7 @@
           <p:nvPr/>
         </p:nvPicPr>
         <p:blipFill>
-          <a:blip xmlns:r="http://schemas.openxmlformats.org/officeDocument/2006/relationships" xmlns:a="http://schemas.openxmlformats.org/drawingml/2006/main" r:embed="R34e684ca95d84265"/>
+          <a:blip xmlns:r="http://schemas.openxmlformats.org/officeDocument/2006/relationships" xmlns:a="http://schemas.openxmlformats.org/drawingml/2006/main" r:embed="R679604f9b2a942cb"/>
           <a:srcRect xmlns:a="http://schemas.openxmlformats.org/drawingml/2006/main" l="20278" t="0" r="20278" b="0"/>
           <a:stretch xmlns:a="http://schemas.openxmlformats.org/drawingml/2006/main">
             <a:fillRect l="0" t="0" r="0" b="0"/>
@@ -4466,7 +4466,7 @@
           <p:cNvPr id="2" name="">
             <a:extLst xmlns:a="http://schemas.openxmlformats.org/drawingml/2006/main">
               <a:ext uri="{FF2B5EF4-FFF2-40B4-BE49-F238E27FC236}">
-                <a16:creationId xmlns:a16="http://schemas.microsoft.com/office/drawing/2014/main" id="{0A96C537-CB6A-4817-BA64-739CE1695DD2}"/>
+                <a16:creationId xmlns:a16="http://schemas.microsoft.com/office/drawing/2014/main" id="{BBCF0AEA-DAF9-471D-8A62-276E9F57AC35}"/>
               </a:ext>
             </a:extLst>
           </p:cNvPr>
@@ -4497,7 +4497,7 @@
           <p:cNvPr id="3" name="">
             <a:extLst xmlns:a="http://schemas.openxmlformats.org/drawingml/2006/main">
               <a:ext uri="{FF2B5EF4-FFF2-40B4-BE49-F238E27FC236}">
-                <a16:creationId xmlns:a16="http://schemas.microsoft.com/office/drawing/2014/main" id="{31C3A625-613C-4B8F-98F7-F716FE0AC926}"/>
+                <a16:creationId xmlns:a16="http://schemas.microsoft.com/office/drawing/2014/main" id="{6F439B7B-ECDE-4AE8-BF85-41C241E05917}"/>
               </a:ext>
             </a:extLst>
           </p:cNvPr>
@@ -4660,7 +4660,7 @@
           <p:cNvPr id="4" name="">
             <a:extLst xmlns:a="http://schemas.openxmlformats.org/drawingml/2006/main">
               <a:ext uri="{FF2B5EF4-FFF2-40B4-BE49-F238E27FC236}">
-                <a16:creationId xmlns:a16="http://schemas.microsoft.com/office/drawing/2014/main" id="{F5B4011E-C4DC-4BD3-B56E-7E2C0D1E3763}"/>
+                <a16:creationId xmlns:a16="http://schemas.microsoft.com/office/drawing/2014/main" id="{5B08B429-E337-4D43-8A4A-6B6266373268}"/>
               </a:ext>
             </a:extLst>
           </p:cNvPr>
@@ -4850,7 +4850,7 @@
           <p:cNvPr id="5" name="">
             <a:extLst xmlns:a="http://schemas.openxmlformats.org/drawingml/2006/main">
               <a:ext uri="{FF2B5EF4-FFF2-40B4-BE49-F238E27FC236}">
-                <a16:creationId xmlns:a16="http://schemas.microsoft.com/office/drawing/2014/main" id="{6365D9A1-EE26-4FF3-9DAF-1BA307BF9462}"/>
+                <a16:creationId xmlns:a16="http://schemas.microsoft.com/office/drawing/2014/main" id="{F501D4BF-4CE6-46A1-95C9-1EC460EF99BF}"/>
               </a:ext>
             </a:extLst>
           </p:cNvPr>
@@ -5013,7 +5013,7 @@
           <p:cNvPr id="6" name="">
             <a:extLst xmlns:a="http://schemas.openxmlformats.org/drawingml/2006/main">
               <a:ext uri="{FF2B5EF4-FFF2-40B4-BE49-F238E27FC236}">
-                <a16:creationId xmlns:a16="http://schemas.microsoft.com/office/drawing/2014/main" id="{6B8B7846-9716-443F-82BB-80385190A459}"/>
+                <a16:creationId xmlns:a16="http://schemas.microsoft.com/office/drawing/2014/main" id="{68840C91-3BAC-43E9-862D-2E2A930D12F8}"/>
               </a:ext>
             </a:extLst>
           </p:cNvPr>
@@ -5044,7 +5044,7 @@
           <p:cNvPr id="7" name="">
             <a:extLst xmlns:a="http://schemas.openxmlformats.org/drawingml/2006/main">
               <a:ext uri="{FF2B5EF4-FFF2-40B4-BE49-F238E27FC236}">
-                <a16:creationId xmlns:a16="http://schemas.microsoft.com/office/drawing/2014/main" id="{9F6698EB-8524-48BE-BC4D-7E57FF6F83DA}"/>
+                <a16:creationId xmlns:a16="http://schemas.microsoft.com/office/drawing/2014/main" id="{2CD4A1EC-67F2-4919-9859-4852C109B0DB}"/>
               </a:ext>
             </a:extLst>
           </p:cNvPr>
@@ -5207,7 +5207,7 @@
           <p:cNvPr id="8" name="">
             <a:extLst xmlns:a="http://schemas.openxmlformats.org/drawingml/2006/main">
               <a:ext uri="{FF2B5EF4-FFF2-40B4-BE49-F238E27FC236}">
-                <a16:creationId xmlns:a16="http://schemas.microsoft.com/office/drawing/2014/main" id="{5E3963CD-98F4-4992-8FB3-64F36C4F72C0}"/>
+                <a16:creationId xmlns:a16="http://schemas.microsoft.com/office/drawing/2014/main" id="{49688F39-7334-4DD1-B208-AA5B277D2495}"/>
               </a:ext>
             </a:extLst>
           </p:cNvPr>
@@ -5395,7 +5395,7 @@
     </p:spTree>
     <p:extLst>
       <p:ext uri="{BB962C8B-B14F-4D97-AF65-F5344CB8AC3E}">
-        <p14:creationId xmlns:p14="http://schemas.microsoft.com/office/powerpoint/2010/main" val="1437789845"/>
+        <p14:creationId xmlns:p14="http://schemas.microsoft.com/office/powerpoint/2010/main" val="589799086"/>
       </p:ext>
     </p:extLst>
   </p:cSld>
@@ -5426,7 +5426,7 @@
           <p:cNvPr id="18" name="">
             <a:extLst xmlns:a="http://schemas.openxmlformats.org/drawingml/2006/main">
               <a:ext uri="{FF2B5EF4-FFF2-40B4-BE49-F238E27FC236}">
-                <a16:creationId xmlns:a16="http://schemas.microsoft.com/office/drawing/2014/main" id="{585D1AA7-1CD9-41E7-A301-C9F8BF84B953}"/>
+                <a16:creationId xmlns:a16="http://schemas.microsoft.com/office/drawing/2014/main" id="{D5EF91BC-D4C0-4EC4-BDEB-77106968A5DD}"/>
               </a:ext>
             </a:extLst>
           </p:cNvPr>
@@ -5589,7 +5589,7 @@
           <p:cNvPr id="2" name="">
             <a:extLst xmlns:a="http://schemas.openxmlformats.org/drawingml/2006/main">
               <a:ext uri="{FF2B5EF4-FFF2-40B4-BE49-F238E27FC236}">
-                <a16:creationId xmlns:a16="http://schemas.microsoft.com/office/drawing/2014/main" id="{9754BEF8-E6A6-48C4-9D1D-F6DB233EF214}"/>
+                <a16:creationId xmlns:a16="http://schemas.microsoft.com/office/drawing/2014/main" id="{11B61917-4409-480F-9314-E89ABCFF30A4}"/>
               </a:ext>
             </a:extLst>
           </p:cNvPr>
@@ -5752,7 +5752,7 @@
           <p:cNvPr id="3" name="">
             <a:extLst xmlns:a="http://schemas.openxmlformats.org/drawingml/2006/main">
               <a:ext uri="{FF2B5EF4-FFF2-40B4-BE49-F238E27FC236}">
-                <a16:creationId xmlns:a16="http://schemas.microsoft.com/office/drawing/2014/main" id="{35694817-BC8A-401D-A7E6-7C5E0C4AF654}"/>
+                <a16:creationId xmlns:a16="http://schemas.microsoft.com/office/drawing/2014/main" id="{86CE6F72-D805-421B-AF75-0399E8400C0D}"/>
               </a:ext>
             </a:extLst>
           </p:cNvPr>
@@ -5783,7 +5783,7 @@
           <p:cNvPr id="4" name="">
             <a:extLst xmlns:a="http://schemas.openxmlformats.org/drawingml/2006/main">
               <a:ext uri="{FF2B5EF4-FFF2-40B4-BE49-F238E27FC236}">
-                <a16:creationId xmlns:a16="http://schemas.microsoft.com/office/drawing/2014/main" id="{DD58E139-18D2-43D6-91C0-6F80752582E8}"/>
+                <a16:creationId xmlns:a16="http://schemas.microsoft.com/office/drawing/2014/main" id="{33A67921-3372-4AC9-A216-1BC7E5876A2B}"/>
               </a:ext>
             </a:extLst>
           </p:cNvPr>
@@ -5946,7 +5946,7 @@
           <p:cNvPr id="5" name="">
             <a:extLst xmlns:a="http://schemas.openxmlformats.org/drawingml/2006/main">
               <a:ext uri="{FF2B5EF4-FFF2-40B4-BE49-F238E27FC236}">
-                <a16:creationId xmlns:a16="http://schemas.microsoft.com/office/drawing/2014/main" id="{03633B2F-438A-479F-B435-9AC3764507BE}"/>
+                <a16:creationId xmlns:a16="http://schemas.microsoft.com/office/drawing/2014/main" id="{CDDA6D22-C974-4371-A021-BF568ED5348C}"/>
               </a:ext>
             </a:extLst>
           </p:cNvPr>
@@ -6109,7 +6109,7 @@
           <p:cNvPr id="6" name="">
             <a:extLst xmlns:a="http://schemas.openxmlformats.org/drawingml/2006/main">
               <a:ext uri="{FF2B5EF4-FFF2-40B4-BE49-F238E27FC236}">
-                <a16:creationId xmlns:a16="http://schemas.microsoft.com/office/drawing/2014/main" id="{E92F2495-A6BF-4D78-B859-A63436F8808C}"/>
+                <a16:creationId xmlns:a16="http://schemas.microsoft.com/office/drawing/2014/main" id="{4A2DEA28-8B5B-4883-9EB4-63BFFF07D279}"/>
               </a:ext>
             </a:extLst>
           </p:cNvPr>
@@ -6272,7 +6272,7 @@
           <p:cNvPr id="7" name="">
             <a:extLst xmlns:a="http://schemas.openxmlformats.org/drawingml/2006/main">
               <a:ext uri="{FF2B5EF4-FFF2-40B4-BE49-F238E27FC236}">
-                <a16:creationId xmlns:a16="http://schemas.microsoft.com/office/drawing/2014/main" id="{30C9934E-31F7-4680-9156-3378CFB1275C}"/>
+                <a16:creationId xmlns:a16="http://schemas.microsoft.com/office/drawing/2014/main" id="{A9A71D06-F540-47F3-BCA2-95CCC8CF0BD6}"/>
               </a:ext>
             </a:extLst>
           </p:cNvPr>
@@ -6307,7 +6307,7 @@
           <p:cNvPr id="8" name="">
             <a:extLst xmlns:a="http://schemas.openxmlformats.org/drawingml/2006/main">
               <a:ext uri="{FF2B5EF4-FFF2-40B4-BE49-F238E27FC236}">
-                <a16:creationId xmlns:a16="http://schemas.microsoft.com/office/drawing/2014/main" id="{96CE2B5D-6C3F-410D-BA28-86D6A4AA2FD8}"/>
+                <a16:creationId xmlns:a16="http://schemas.microsoft.com/office/drawing/2014/main" id="{8CFDD447-3F57-45AB-9105-F58CC53A4DA4}"/>
               </a:ext>
             </a:extLst>
           </p:cNvPr>
@@ -6470,7 +6470,7 @@
           <p:cNvPr id="9" name="">
             <a:extLst xmlns:a="http://schemas.openxmlformats.org/drawingml/2006/main">
               <a:ext uri="{FF2B5EF4-FFF2-40B4-BE49-F238E27FC236}">
-                <a16:creationId xmlns:a16="http://schemas.microsoft.com/office/drawing/2014/main" id="{C5B0A9CE-094F-4F51-80DA-1814300DC93E}"/>
+                <a16:creationId xmlns:a16="http://schemas.microsoft.com/office/drawing/2014/main" id="{A921721A-5AC9-4EEC-B41B-EC3778B594F0}"/>
               </a:ext>
             </a:extLst>
           </p:cNvPr>
@@ -6501,7 +6501,7 @@
           <p:cNvPr id="10" name="">
             <a:extLst xmlns:a="http://schemas.openxmlformats.org/drawingml/2006/main">
               <a:ext uri="{FF2B5EF4-FFF2-40B4-BE49-F238E27FC236}">
-                <a16:creationId xmlns:a16="http://schemas.microsoft.com/office/drawing/2014/main" id="{DD1694CE-2B46-4C54-8B05-D71BD9F5E2BB}"/>
+                <a16:creationId xmlns:a16="http://schemas.microsoft.com/office/drawing/2014/main" id="{7B310AE4-590E-44F5-90E4-52093EDEA96E}"/>
               </a:ext>
             </a:extLst>
           </p:cNvPr>
@@ -6536,7 +6536,7 @@
           <p:cNvPr id="11" name="">
             <a:extLst xmlns:a="http://schemas.openxmlformats.org/drawingml/2006/main">
               <a:ext uri="{FF2B5EF4-FFF2-40B4-BE49-F238E27FC236}">
-                <a16:creationId xmlns:a16="http://schemas.microsoft.com/office/drawing/2014/main" id="{29018462-DA1A-4374-A3E7-AAF25A59524E}"/>
+                <a16:creationId xmlns:a16="http://schemas.microsoft.com/office/drawing/2014/main" id="{8AC1389D-F3E3-42AD-AD84-5B1566785607}"/>
               </a:ext>
             </a:extLst>
           </p:cNvPr>
@@ -6726,7 +6726,7 @@
           <p:cNvPr id="12" name="">
             <a:extLst xmlns:a="http://schemas.openxmlformats.org/drawingml/2006/main">
               <a:ext uri="{FF2B5EF4-FFF2-40B4-BE49-F238E27FC236}">
-                <a16:creationId xmlns:a16="http://schemas.microsoft.com/office/drawing/2014/main" id="{8EEADD8C-41A5-47E6-A7E3-25A4118EFE90}"/>
+                <a16:creationId xmlns:a16="http://schemas.microsoft.com/office/drawing/2014/main" id="{B3A35271-5E6C-46E0-97CD-9FF2FA41820E}"/>
               </a:ext>
             </a:extLst>
           </p:cNvPr>
@@ -6757,7 +6757,7 @@
           <p:cNvPr id="13" name="">
             <a:extLst xmlns:a="http://schemas.openxmlformats.org/drawingml/2006/main">
               <a:ext uri="{FF2B5EF4-FFF2-40B4-BE49-F238E27FC236}">
-                <a16:creationId xmlns:a16="http://schemas.microsoft.com/office/drawing/2014/main" id="{1821F338-C189-4E29-A5C1-BFF05D0FA2C5}"/>
+                <a16:creationId xmlns:a16="http://schemas.microsoft.com/office/drawing/2014/main" id="{76BA7231-B0BC-4AFD-A82E-1DFC425103D9}"/>
               </a:ext>
             </a:extLst>
           </p:cNvPr>
@@ -6792,7 +6792,7 @@
           <p:cNvPr id="14" name="">
             <a:extLst xmlns:a="http://schemas.openxmlformats.org/drawingml/2006/main">
               <a:ext uri="{FF2B5EF4-FFF2-40B4-BE49-F238E27FC236}">
-                <a16:creationId xmlns:a16="http://schemas.microsoft.com/office/drawing/2014/main" id="{128412A7-B6FA-4EF8-A8DB-E6057FBAF4B0}"/>
+                <a16:creationId xmlns:a16="http://schemas.microsoft.com/office/drawing/2014/main" id="{F3174038-A0B9-4526-9262-4C4BAE1EB3FC}"/>
               </a:ext>
             </a:extLst>
           </p:cNvPr>
@@ -6982,7 +6982,7 @@
           <p:cNvPr id="15" name="">
             <a:extLst xmlns:a="http://schemas.openxmlformats.org/drawingml/2006/main">
               <a:ext uri="{FF2B5EF4-FFF2-40B4-BE49-F238E27FC236}">
-                <a16:creationId xmlns:a16="http://schemas.microsoft.com/office/drawing/2014/main" id="{92B44729-F424-4FC9-A855-6EBEE0ECC3FF}"/>
+                <a16:creationId xmlns:a16="http://schemas.microsoft.com/office/drawing/2014/main" id="{137610C6-D594-49FC-8B8B-66FEC81CF105}"/>
               </a:ext>
             </a:extLst>
           </p:cNvPr>
@@ -7145,7 +7145,7 @@
           <p:cNvPr id="16" name="">
             <a:extLst xmlns:a="http://schemas.openxmlformats.org/drawingml/2006/main">
               <a:ext uri="{FF2B5EF4-FFF2-40B4-BE49-F238E27FC236}">
-                <a16:creationId xmlns:a16="http://schemas.microsoft.com/office/drawing/2014/main" id="{64A6E7ED-1AF5-42D1-9A3D-F6C44A9B558E}"/>
+                <a16:creationId xmlns:a16="http://schemas.microsoft.com/office/drawing/2014/main" id="{805B51BD-029F-4EFC-B5C0-EA397A6E5EFB}"/>
               </a:ext>
             </a:extLst>
           </p:cNvPr>
@@ -7178,7 +7178,7 @@
           <p:cNvPr id="17" name="">
             <a:extLst xmlns:a="http://schemas.openxmlformats.org/drawingml/2006/main">
               <a:ext uri="{FF2B5EF4-FFF2-40B4-BE49-F238E27FC236}">
-                <a16:creationId xmlns:a16="http://schemas.microsoft.com/office/drawing/2014/main" id="{7D531959-9DE1-466A-98EB-78EE1415399A}"/>
+                <a16:creationId xmlns:a16="http://schemas.microsoft.com/office/drawing/2014/main" id="{63E633E5-3CB7-4501-9F4E-FBE1741796F9}"/>
               </a:ext>
             </a:extLst>
           </p:cNvPr>
@@ -7331,7 +7331,7 @@
                 <a:ea typeface="Segoe UI"/>
                 <a:cs typeface="Segoe UI"/>
               </a:rPr>
-              <a:t>Alias đã ở main. Bộ lọc categoryTerm trong Search/UI đang ở PR #27.</a:t>
+              <a:t>Alias đã ở main; bộ lọc và màn quản trị Alias ở nhánh Tuấn.</a:t>
             </a:r>
           </a:p>
         </p:txBody>
@@ -7339,7 +7339,7 @@
     </p:spTree>
     <p:extLst>
       <p:ext uri="{BB962C8B-B14F-4D97-AF65-F5344CB8AC3E}">
-        <p14:creationId xmlns:p14="http://schemas.microsoft.com/office/powerpoint/2010/main" val="1059955502"/>
+        <p14:creationId xmlns:p14="http://schemas.microsoft.com/office/powerpoint/2010/main" val="1156163918"/>
       </p:ext>
     </p:extLst>
   </p:cSld>
@@ -7370,7 +7370,7 @@
           <p:cNvPr id="21" name="">
             <a:extLst xmlns:a="http://schemas.openxmlformats.org/drawingml/2006/main">
               <a:ext uri="{FF2B5EF4-FFF2-40B4-BE49-F238E27FC236}">
-                <a16:creationId xmlns:a16="http://schemas.microsoft.com/office/drawing/2014/main" id="{8AB824CF-F124-47E4-AE15-030F9E95FF05}"/>
+                <a16:creationId xmlns:a16="http://schemas.microsoft.com/office/drawing/2014/main" id="{943AE021-35E6-42D5-8F7C-D490BB71DC3F}"/>
               </a:ext>
             </a:extLst>
           </p:cNvPr>
@@ -7533,7 +7533,7 @@
           <p:cNvPr id="2" name="">
             <a:extLst xmlns:a="http://schemas.openxmlformats.org/drawingml/2006/main">
               <a:ext uri="{FF2B5EF4-FFF2-40B4-BE49-F238E27FC236}">
-                <a16:creationId xmlns:a16="http://schemas.microsoft.com/office/drawing/2014/main" id="{7AAC9013-8832-47AB-AF2B-911FD8F7AD46}"/>
+                <a16:creationId xmlns:a16="http://schemas.microsoft.com/office/drawing/2014/main" id="{5C469A39-DA3A-4AD6-BBC4-29F79486A717}"/>
               </a:ext>
             </a:extLst>
           </p:cNvPr>
@@ -7696,7 +7696,7 @@
           <p:cNvPr id="3" name="">
             <a:extLst xmlns:a="http://schemas.openxmlformats.org/drawingml/2006/main">
               <a:ext uri="{FF2B5EF4-FFF2-40B4-BE49-F238E27FC236}">
-                <a16:creationId xmlns:a16="http://schemas.microsoft.com/office/drawing/2014/main" id="{39788459-6E09-400B-A758-90A863E85E38}"/>
+                <a16:creationId xmlns:a16="http://schemas.microsoft.com/office/drawing/2014/main" id="{4F51A009-6050-4584-AD8D-899A603BD255}"/>
               </a:ext>
             </a:extLst>
           </p:cNvPr>
@@ -7727,7 +7727,7 @@
           <p:cNvPr id="4" name="">
             <a:extLst xmlns:a="http://schemas.openxmlformats.org/drawingml/2006/main">
               <a:ext uri="{FF2B5EF4-FFF2-40B4-BE49-F238E27FC236}">
-                <a16:creationId xmlns:a16="http://schemas.microsoft.com/office/drawing/2014/main" id="{E2D315A6-C7EB-45F7-B60C-0346F19C0AAC}"/>
+                <a16:creationId xmlns:a16="http://schemas.microsoft.com/office/drawing/2014/main" id="{8D9BE206-4A5E-48BD-8795-8B38C34A3934}"/>
               </a:ext>
             </a:extLst>
           </p:cNvPr>
@@ -7890,7 +7890,7 @@
           <p:cNvPr id="5" name="">
             <a:extLst xmlns:a="http://schemas.openxmlformats.org/drawingml/2006/main">
               <a:ext uri="{FF2B5EF4-FFF2-40B4-BE49-F238E27FC236}">
-                <a16:creationId xmlns:a16="http://schemas.microsoft.com/office/drawing/2014/main" id="{8461D435-1658-4EB8-B8CF-81EA16AA9F8D}"/>
+                <a16:creationId xmlns:a16="http://schemas.microsoft.com/office/drawing/2014/main" id="{35D1BCED-8D01-4131-9F46-2B42D1D70558}"/>
               </a:ext>
             </a:extLst>
           </p:cNvPr>
@@ -8053,7 +8053,7 @@
           <p:cNvPr id="6" name="">
             <a:extLst xmlns:a="http://schemas.openxmlformats.org/drawingml/2006/main">
               <a:ext uri="{FF2B5EF4-FFF2-40B4-BE49-F238E27FC236}">
-                <a16:creationId xmlns:a16="http://schemas.microsoft.com/office/drawing/2014/main" id="{BA1EB14B-4548-4745-8875-DECC59B317AD}"/>
+                <a16:creationId xmlns:a16="http://schemas.microsoft.com/office/drawing/2014/main" id="{AF780F65-0D89-45DF-9B23-5CC854FBD4FC}"/>
               </a:ext>
             </a:extLst>
           </p:cNvPr>
@@ -8088,7 +8088,7 @@
           <p:cNvPr id="7" name="">
             <a:extLst xmlns:a="http://schemas.openxmlformats.org/drawingml/2006/main">
               <a:ext uri="{FF2B5EF4-FFF2-40B4-BE49-F238E27FC236}">
-                <a16:creationId xmlns:a16="http://schemas.microsoft.com/office/drawing/2014/main" id="{76FD89A1-4D0E-488B-BEE6-2B528CC302CD}"/>
+                <a16:creationId xmlns:a16="http://schemas.microsoft.com/office/drawing/2014/main" id="{353250F3-1C84-4075-97BA-F31868DA99F4}"/>
               </a:ext>
             </a:extLst>
           </p:cNvPr>
@@ -8278,7 +8278,7 @@
           <p:cNvPr id="8" name="">
             <a:extLst xmlns:a="http://schemas.openxmlformats.org/drawingml/2006/main">
               <a:ext uri="{FF2B5EF4-FFF2-40B4-BE49-F238E27FC236}">
-                <a16:creationId xmlns:a16="http://schemas.microsoft.com/office/drawing/2014/main" id="{D23BBD61-F1A7-4A0A-9ABD-62A281599D98}"/>
+                <a16:creationId xmlns:a16="http://schemas.microsoft.com/office/drawing/2014/main" id="{BCAA64F4-B173-4E0B-9EEC-8BAB4784909F}"/>
               </a:ext>
             </a:extLst>
           </p:cNvPr>
@@ -8313,7 +8313,7 @@
           <p:cNvPr id="9" name="">
             <a:extLst xmlns:a="http://schemas.openxmlformats.org/drawingml/2006/main">
               <a:ext uri="{FF2B5EF4-FFF2-40B4-BE49-F238E27FC236}">
-                <a16:creationId xmlns:a16="http://schemas.microsoft.com/office/drawing/2014/main" id="{9D71DD30-E047-4AB7-A52B-AB81FA815EB6}"/>
+                <a16:creationId xmlns:a16="http://schemas.microsoft.com/office/drawing/2014/main" id="{F36A6439-649E-40BB-BCBB-D74B255C9F53}"/>
               </a:ext>
             </a:extLst>
           </p:cNvPr>
@@ -8503,7 +8503,7 @@
           <p:cNvPr id="10" name="">
             <a:extLst xmlns:a="http://schemas.openxmlformats.org/drawingml/2006/main">
               <a:ext uri="{FF2B5EF4-FFF2-40B4-BE49-F238E27FC236}">
-                <a16:creationId xmlns:a16="http://schemas.microsoft.com/office/drawing/2014/main" id="{A9066D11-3E78-4754-BE95-0063AAFEBB5E}"/>
+                <a16:creationId xmlns:a16="http://schemas.microsoft.com/office/drawing/2014/main" id="{A260AAC6-3D1A-4D41-999D-F9DB3FE2921D}"/>
               </a:ext>
             </a:extLst>
           </p:cNvPr>
@@ -8538,7 +8538,7 @@
           <p:cNvPr id="11" name="">
             <a:extLst xmlns:a="http://schemas.openxmlformats.org/drawingml/2006/main">
               <a:ext uri="{FF2B5EF4-FFF2-40B4-BE49-F238E27FC236}">
-                <a16:creationId xmlns:a16="http://schemas.microsoft.com/office/drawing/2014/main" id="{D7F622CF-D141-42A9-9634-C620BE25EEFF}"/>
+                <a16:creationId xmlns:a16="http://schemas.microsoft.com/office/drawing/2014/main" id="{09A212E8-A530-499C-A4EF-C4A6C4913A7A}"/>
               </a:ext>
             </a:extLst>
           </p:cNvPr>
@@ -8701,7 +8701,7 @@
           <p:cNvPr id="12" name="">
             <a:extLst xmlns:a="http://schemas.openxmlformats.org/drawingml/2006/main">
               <a:ext uri="{FF2B5EF4-FFF2-40B4-BE49-F238E27FC236}">
-                <a16:creationId xmlns:a16="http://schemas.microsoft.com/office/drawing/2014/main" id="{EE8B76E2-315D-416C-A14A-902B38E5A441}"/>
+                <a16:creationId xmlns:a16="http://schemas.microsoft.com/office/drawing/2014/main" id="{2AA9B953-F088-420C-A5B2-4577B70A5028}"/>
               </a:ext>
             </a:extLst>
           </p:cNvPr>
@@ -8736,7 +8736,7 @@
           <p:cNvPr id="13" name="">
             <a:extLst xmlns:a="http://schemas.openxmlformats.org/drawingml/2006/main">
               <a:ext uri="{FF2B5EF4-FFF2-40B4-BE49-F238E27FC236}">
-                <a16:creationId xmlns:a16="http://schemas.microsoft.com/office/drawing/2014/main" id="{71C8297F-3C69-43A5-AC10-5A8C0B159EAE}"/>
+                <a16:creationId xmlns:a16="http://schemas.microsoft.com/office/drawing/2014/main" id="{64303462-4CEF-4859-BE26-194BC9D48E1A}"/>
               </a:ext>
             </a:extLst>
           </p:cNvPr>
@@ -8926,7 +8926,7 @@
           <p:cNvPr id="14" name="">
             <a:extLst xmlns:a="http://schemas.openxmlformats.org/drawingml/2006/main">
               <a:ext uri="{FF2B5EF4-FFF2-40B4-BE49-F238E27FC236}">
-                <a16:creationId xmlns:a16="http://schemas.microsoft.com/office/drawing/2014/main" id="{23744884-9BF9-4AAD-A59D-75CE286E9F43}"/>
+                <a16:creationId xmlns:a16="http://schemas.microsoft.com/office/drawing/2014/main" id="{F6EE1142-2B70-48F0-8BAD-EABBA9F1E1BD}"/>
               </a:ext>
             </a:extLst>
           </p:cNvPr>
@@ -8957,7 +8957,7 @@
           <p:cNvPr id="15" name="">
             <a:extLst xmlns:a="http://schemas.openxmlformats.org/drawingml/2006/main">
               <a:ext uri="{FF2B5EF4-FFF2-40B4-BE49-F238E27FC236}">
-                <a16:creationId xmlns:a16="http://schemas.microsoft.com/office/drawing/2014/main" id="{845CA39C-0DAC-4E60-8BEB-14C47FEFB541}"/>
+                <a16:creationId xmlns:a16="http://schemas.microsoft.com/office/drawing/2014/main" id="{B504A233-DAED-4283-9D25-4F10A1AF0534}"/>
               </a:ext>
             </a:extLst>
           </p:cNvPr>
@@ -8988,7 +8988,7 @@
           <p:cNvPr id="16" name="">
             <a:extLst xmlns:a="http://schemas.openxmlformats.org/drawingml/2006/main">
               <a:ext uri="{FF2B5EF4-FFF2-40B4-BE49-F238E27FC236}">
-                <a16:creationId xmlns:a16="http://schemas.microsoft.com/office/drawing/2014/main" id="{C23C9390-5941-430D-9AA4-D3B7954DDDBE}"/>
+                <a16:creationId xmlns:a16="http://schemas.microsoft.com/office/drawing/2014/main" id="{6039BCF8-1339-427B-866C-00FADB2DCF3A}"/>
               </a:ext>
             </a:extLst>
           </p:cNvPr>
@@ -9019,7 +9019,7 @@
           <p:cNvPr id="17" name="">
             <a:extLst xmlns:a="http://schemas.openxmlformats.org/drawingml/2006/main">
               <a:ext uri="{FF2B5EF4-FFF2-40B4-BE49-F238E27FC236}">
-                <a16:creationId xmlns:a16="http://schemas.microsoft.com/office/drawing/2014/main" id="{F5DC7C62-D981-42A9-8570-4221C5B6D805}"/>
+                <a16:creationId xmlns:a16="http://schemas.microsoft.com/office/drawing/2014/main" id="{5FA53847-FF76-489A-B58F-48E6DD808A7A}"/>
               </a:ext>
             </a:extLst>
           </p:cNvPr>
@@ -9172,7 +9172,7 @@
                 <a:ea typeface="Segoe UI"/>
                 <a:cs typeface="Segoe UI"/>
               </a:rPr>
-              <a:t>Đã có trên PR #27</a:t>
+              <a:t>Đã có trên nhánh Tuấn</a:t>
             </a:r>
           </a:p>
         </p:txBody>
@@ -9182,7 +9182,7 @@
           <p:cNvPr id="18" name="">
             <a:extLst xmlns:a="http://schemas.openxmlformats.org/drawingml/2006/main">
               <a:ext uri="{FF2B5EF4-FFF2-40B4-BE49-F238E27FC236}">
-                <a16:creationId xmlns:a16="http://schemas.microsoft.com/office/drawing/2014/main" id="{74E6CD84-8DCB-47DD-A6EB-1C49F0899052}"/>
+                <a16:creationId xmlns:a16="http://schemas.microsoft.com/office/drawing/2014/main" id="{3EDFBFCD-9FDF-43E2-B277-6A3293E08C46}"/>
               </a:ext>
             </a:extLst>
           </p:cNvPr>
@@ -9335,7 +9335,7 @@
                 <a:ea typeface="Segoe UI"/>
                 <a:cs typeface="Segoe UI"/>
               </a:rPr>
-              <a:t>Điểm và bằng chứng, lưu DRAFT, API/UI xem và duyệt nội bộ.</a:t>
+              <a:t>Core đọc Copy, Hold, Loan; Insight tính điểm, lưu DRAFT và xuất CSV.</a:t>
             </a:r>
           </a:p>
         </p:txBody>
@@ -9345,7 +9345,7 @@
           <p:cNvPr id="19" name="">
             <a:extLst xmlns:a="http://schemas.openxmlformats.org/drawingml/2006/main">
               <a:ext uri="{FF2B5EF4-FFF2-40B4-BE49-F238E27FC236}">
-                <a16:creationId xmlns:a16="http://schemas.microsoft.com/office/drawing/2014/main" id="{0265C41A-18EC-4CBF-89DB-15024A6880C5}"/>
+                <a16:creationId xmlns:a16="http://schemas.microsoft.com/office/drawing/2014/main" id="{8308EEAD-F05F-4AC2-81E2-5A8D33E91B7C}"/>
               </a:ext>
             </a:extLst>
           </p:cNvPr>
@@ -9498,7 +9498,7 @@
                 <a:ea typeface="Segoe UI"/>
                 <a:cs typeface="Segoe UI"/>
               </a:rPr>
-              <a:t>Còn thiếu để demo trọn luồng</a:t>
+              <a:t>Chưa có bằng chứng đầy đủ</a:t>
             </a:r>
           </a:p>
         </p:txBody>
@@ -9508,7 +9508,7 @@
           <p:cNvPr id="20" name="">
             <a:extLst xmlns:a="http://schemas.openxmlformats.org/drawingml/2006/main">
               <a:ext uri="{FF2B5EF4-FFF2-40B4-BE49-F238E27FC236}">
-                <a16:creationId xmlns:a16="http://schemas.microsoft.com/office/drawing/2014/main" id="{8DA3BAEB-BEE7-47A6-B8B9-33DB452D336F}"/>
+                <a16:creationId xmlns:a16="http://schemas.microsoft.com/office/drawing/2014/main" id="{0D07E10E-BF31-459E-A2A0-1D36443F53B2}"/>
               </a:ext>
             </a:extLst>
           </p:cNvPr>
@@ -9661,7 +9661,7 @@
                 <a:ea typeface="Segoe UI"/>
                 <a:cs typeface="Segoe UI"/>
               </a:rPr>
-              <a:t>Nguồn Core thật, tạo đề xuất từ dữ liệu thật, báo cáo/CSV và E2E liên dịch vụ.</a:t>
+              <a:t>Chưa có E2E tạo đề xuất xuyên hai service; thiếu lịch sử Favorite và tìm kiếm rỗng.</a:t>
             </a:r>
           </a:p>
         </p:txBody>
@@ -9669,7 +9669,7 @@
     </p:spTree>
     <p:extLst>
       <p:ext uri="{BB962C8B-B14F-4D97-AF65-F5344CB8AC3E}">
-        <p14:creationId xmlns:p14="http://schemas.microsoft.com/office/powerpoint/2010/main" val="1675026842"/>
+        <p14:creationId xmlns:p14="http://schemas.microsoft.com/office/powerpoint/2010/main" val="1140946063"/>
       </p:ext>
     </p:extLst>
   </p:cSld>
@@ -9700,7 +9700,7 @@
           <p:cNvPr id="18" name="">
             <a:extLst xmlns:a="http://schemas.openxmlformats.org/drawingml/2006/main">
               <a:ext uri="{FF2B5EF4-FFF2-40B4-BE49-F238E27FC236}">
-                <a16:creationId xmlns:a16="http://schemas.microsoft.com/office/drawing/2014/main" id="{567F967D-635B-4EE8-9066-78BDA814DE19}"/>
+                <a16:creationId xmlns:a16="http://schemas.microsoft.com/office/drawing/2014/main" id="{5D13411E-3072-4EAE-9D05-CA996C168F19}"/>
               </a:ext>
             </a:extLst>
           </p:cNvPr>
@@ -9863,7 +9863,7 @@
           <p:cNvPr id="2" name="">
             <a:extLst xmlns:a="http://schemas.openxmlformats.org/drawingml/2006/main">
               <a:ext uri="{FF2B5EF4-FFF2-40B4-BE49-F238E27FC236}">
-                <a16:creationId xmlns:a16="http://schemas.microsoft.com/office/drawing/2014/main" id="{73C3C687-7E63-4200-8829-624482E0710C}"/>
+                <a16:creationId xmlns:a16="http://schemas.microsoft.com/office/drawing/2014/main" id="{188E4977-FBA9-49F3-AD59-5DCA49506067}"/>
               </a:ext>
             </a:extLst>
           </p:cNvPr>
@@ -10016,7 +10016,7 @@
                 <a:ea typeface="Segoe UI"/>
                 <a:cs typeface="Segoe UI"/>
               </a:rPr>
-              <a:t>Bằng chứng tại commit 6e03c9a</a:t>
+              <a:t>Bằng chứng theo từng mốc</a:t>
             </a:r>
           </a:p>
         </p:txBody>
@@ -10026,7 +10026,7 @@
           <p:cNvPr id="3" name="">
             <a:extLst xmlns:a="http://schemas.openxmlformats.org/drawingml/2006/main">
               <a:ext uri="{FF2B5EF4-FFF2-40B4-BE49-F238E27FC236}">
-                <a16:creationId xmlns:a16="http://schemas.microsoft.com/office/drawing/2014/main" id="{9AD456C0-90D1-4878-87D1-9A90A774D464}"/>
+                <a16:creationId xmlns:a16="http://schemas.microsoft.com/office/drawing/2014/main" id="{9E474BE5-1964-4556-8D31-749FFC877196}"/>
               </a:ext>
             </a:extLst>
           </p:cNvPr>
@@ -10057,7 +10057,7 @@
           <p:cNvPr id="4" name="">
             <a:extLst xmlns:a="http://schemas.openxmlformats.org/drawingml/2006/main">
               <a:ext uri="{FF2B5EF4-FFF2-40B4-BE49-F238E27FC236}">
-                <a16:creationId xmlns:a16="http://schemas.microsoft.com/office/drawing/2014/main" id="{B6D73B1C-12CE-4B30-9BC5-3A74C48B7A07}"/>
+                <a16:creationId xmlns:a16="http://schemas.microsoft.com/office/drawing/2014/main" id="{1A3A03F8-7054-44DA-A289-5B54743930D8}"/>
               </a:ext>
             </a:extLst>
           </p:cNvPr>
@@ -10220,7 +10220,7 @@
           <p:cNvPr id="5" name="">
             <a:extLst xmlns:a="http://schemas.openxmlformats.org/drawingml/2006/main">
               <a:ext uri="{FF2B5EF4-FFF2-40B4-BE49-F238E27FC236}">
-                <a16:creationId xmlns:a16="http://schemas.microsoft.com/office/drawing/2014/main" id="{60E3153F-6C05-4AF6-A7D1-66715BFAA10B}"/>
+                <a16:creationId xmlns:a16="http://schemas.microsoft.com/office/drawing/2014/main" id="{D83629D3-F6C4-48E6-9224-09A4FB1DC5BE}"/>
               </a:ext>
             </a:extLst>
           </p:cNvPr>
@@ -10383,7 +10383,7 @@
           <p:cNvPr id="6" name="">
             <a:extLst xmlns:a="http://schemas.openxmlformats.org/drawingml/2006/main">
               <a:ext uri="{FF2B5EF4-FFF2-40B4-BE49-F238E27FC236}">
-                <a16:creationId xmlns:a16="http://schemas.microsoft.com/office/drawing/2014/main" id="{0B8C644E-D6A3-4AFB-BD7E-BC7E65CA4B4A}"/>
+                <a16:creationId xmlns:a16="http://schemas.microsoft.com/office/drawing/2014/main" id="{C9DDDFD8-B621-48C0-B331-AC62F63F1A61}"/>
               </a:ext>
             </a:extLst>
           </p:cNvPr>
@@ -10546,7 +10546,7 @@
           <p:cNvPr id="7" name="">
             <a:extLst xmlns:a="http://schemas.openxmlformats.org/drawingml/2006/main">
               <a:ext uri="{FF2B5EF4-FFF2-40B4-BE49-F238E27FC236}">
-                <a16:creationId xmlns:a16="http://schemas.microsoft.com/office/drawing/2014/main" id="{A34541B3-6C2F-4B9C-9EBD-5DE5EFE84BEE}"/>
+                <a16:creationId xmlns:a16="http://schemas.microsoft.com/office/drawing/2014/main" id="{7C832EBF-C99B-4570-A8A5-DD69C63FCACB}"/>
               </a:ext>
             </a:extLst>
           </p:cNvPr>
@@ -10736,7 +10736,7 @@
           <p:cNvPr id="8" name="">
             <a:extLst xmlns:a="http://schemas.openxmlformats.org/drawingml/2006/main">
               <a:ext uri="{FF2B5EF4-FFF2-40B4-BE49-F238E27FC236}">
-                <a16:creationId xmlns:a16="http://schemas.microsoft.com/office/drawing/2014/main" id="{73E73720-0A77-4D42-BA2A-488613247506}"/>
+                <a16:creationId xmlns:a16="http://schemas.microsoft.com/office/drawing/2014/main" id="{046C333F-5AE5-4C4B-AAFE-46A3A8EF86A0}"/>
               </a:ext>
             </a:extLst>
           </p:cNvPr>
@@ -10767,7 +10767,7 @@
           <p:cNvPr id="9" name="">
             <a:extLst xmlns:a="http://schemas.openxmlformats.org/drawingml/2006/main">
               <a:ext uri="{FF2B5EF4-FFF2-40B4-BE49-F238E27FC236}">
-                <a16:creationId xmlns:a16="http://schemas.microsoft.com/office/drawing/2014/main" id="{C2C2154A-B16B-46CD-A0C2-E33CF523DF5D}"/>
+                <a16:creationId xmlns:a16="http://schemas.microsoft.com/office/drawing/2014/main" id="{86EECB93-9D00-44F5-B817-E9C23CD7C5C1}"/>
               </a:ext>
             </a:extLst>
           </p:cNvPr>
@@ -10930,7 +10930,7 @@
           <p:cNvPr id="10" name="">
             <a:extLst xmlns:a="http://schemas.openxmlformats.org/drawingml/2006/main">
               <a:ext uri="{FF2B5EF4-FFF2-40B4-BE49-F238E27FC236}">
-                <a16:creationId xmlns:a16="http://schemas.microsoft.com/office/drawing/2014/main" id="{CCBE1C83-9DCC-4F62-A930-FF57636D22F1}"/>
+                <a16:creationId xmlns:a16="http://schemas.microsoft.com/office/drawing/2014/main" id="{9956E115-3F35-4B7F-A480-F6BBC9AF496E}"/>
               </a:ext>
             </a:extLst>
           </p:cNvPr>
@@ -11093,7 +11093,7 @@
           <p:cNvPr id="11" name="">
             <a:extLst xmlns:a="http://schemas.openxmlformats.org/drawingml/2006/main">
               <a:ext uri="{FF2B5EF4-FFF2-40B4-BE49-F238E27FC236}">
-                <a16:creationId xmlns:a16="http://schemas.microsoft.com/office/drawing/2014/main" id="{4F64EA4E-1818-4B1C-B154-AF5AEEF0E152}"/>
+                <a16:creationId xmlns:a16="http://schemas.microsoft.com/office/drawing/2014/main" id="{2532DACA-FDE4-4242-AC55-C33D7DA36B2F}"/>
               </a:ext>
             </a:extLst>
           </p:cNvPr>
@@ -11256,7 +11256,7 @@
           <p:cNvPr id="12" name="">
             <a:extLst xmlns:a="http://schemas.openxmlformats.org/drawingml/2006/main">
               <a:ext uri="{FF2B5EF4-FFF2-40B4-BE49-F238E27FC236}">
-                <a16:creationId xmlns:a16="http://schemas.microsoft.com/office/drawing/2014/main" id="{A7FF1DB0-8EBF-4F78-80D1-BC4B68AFC0CC}"/>
+                <a16:creationId xmlns:a16="http://schemas.microsoft.com/office/drawing/2014/main" id="{F6E88255-56D0-4DC1-B68F-7C06E54ADE1E}"/>
               </a:ext>
             </a:extLst>
           </p:cNvPr>
@@ -11419,7 +11419,7 @@
           <p:cNvPr id="13" name="">
             <a:extLst xmlns:a="http://schemas.openxmlformats.org/drawingml/2006/main">
               <a:ext uri="{FF2B5EF4-FFF2-40B4-BE49-F238E27FC236}">
-                <a16:creationId xmlns:a16="http://schemas.microsoft.com/office/drawing/2014/main" id="{4844CF96-5BE3-46A6-AC39-E81AAB84C62E}"/>
+                <a16:creationId xmlns:a16="http://schemas.microsoft.com/office/drawing/2014/main" id="{D427E189-4709-43DE-8A2C-4AF577F618F9}"/>
               </a:ext>
             </a:extLst>
           </p:cNvPr>
@@ -11582,7 +11582,7 @@
           <p:cNvPr id="14" name="">
             <a:extLst xmlns:a="http://schemas.openxmlformats.org/drawingml/2006/main">
               <a:ext uri="{FF2B5EF4-FFF2-40B4-BE49-F238E27FC236}">
-                <a16:creationId xmlns:a16="http://schemas.microsoft.com/office/drawing/2014/main" id="{565CB883-51E4-4E30-AE4C-14D35C420A47}"/>
+                <a16:creationId xmlns:a16="http://schemas.microsoft.com/office/drawing/2014/main" id="{FDE8B132-49D7-42AA-81D6-43FEA3EAE911}"/>
               </a:ext>
             </a:extLst>
           </p:cNvPr>
@@ -11745,7 +11745,7 @@
           <p:cNvPr id="15" name="">
             <a:extLst xmlns:a="http://schemas.openxmlformats.org/drawingml/2006/main">
               <a:ext uri="{FF2B5EF4-FFF2-40B4-BE49-F238E27FC236}">
-                <a16:creationId xmlns:a16="http://schemas.microsoft.com/office/drawing/2014/main" id="{00A6F62C-5E59-4AF8-AE7E-02A0162438F1}"/>
+                <a16:creationId xmlns:a16="http://schemas.microsoft.com/office/drawing/2014/main" id="{5BBD6F06-8AAB-4393-8880-97E376404004}"/>
               </a:ext>
             </a:extLst>
           </p:cNvPr>
@@ -11908,7 +11908,7 @@
           <p:cNvPr id="16" name="">
             <a:extLst xmlns:a="http://schemas.openxmlformats.org/drawingml/2006/main">
               <a:ext uri="{FF2B5EF4-FFF2-40B4-BE49-F238E27FC236}">
-                <a16:creationId xmlns:a16="http://schemas.microsoft.com/office/drawing/2014/main" id="{8C7A0F65-62A2-45D1-8260-F30D2FC02C0E}"/>
+                <a16:creationId xmlns:a16="http://schemas.microsoft.com/office/drawing/2014/main" id="{D7296C86-AA19-43B7-84DE-8E7B7E5F6A4E}"/>
               </a:ext>
             </a:extLst>
           </p:cNvPr>
@@ -12071,7 +12071,7 @@
           <p:cNvPr id="17" name="">
             <a:extLst xmlns:a="http://schemas.openxmlformats.org/drawingml/2006/main">
               <a:ext uri="{FF2B5EF4-FFF2-40B4-BE49-F238E27FC236}">
-                <a16:creationId xmlns:a16="http://schemas.microsoft.com/office/drawing/2014/main" id="{9E7C463A-26B2-45F0-856D-4D3333BCFC77}"/>
+                <a16:creationId xmlns:a16="http://schemas.microsoft.com/office/drawing/2014/main" id="{76783B12-44DB-460D-9ED1-C55D530CF3B6}"/>
               </a:ext>
             </a:extLst>
           </p:cNvPr>
@@ -12224,7 +12224,7 @@
                 <a:ea typeface="Segoe UI"/>
                 <a:cs typeface="Segoe UI"/>
               </a:rPr>
-              <a:t>CI build Windows và E2E EXE local là hai loại bằng chứng khác nhau.</a:t>
+              <a:t>Bản đang sửa: Web và EXE E2E local 15/15; chờ CI của commit bàn giao.</a:t>
             </a:r>
           </a:p>
         </p:txBody>
@@ -12232,7 +12232,7 @@
     </p:spTree>
     <p:extLst>
       <p:ext uri="{BB962C8B-B14F-4D97-AF65-F5344CB8AC3E}">
-        <p14:creationId xmlns:p14="http://schemas.microsoft.com/office/powerpoint/2010/main" val="1995837011"/>
+        <p14:creationId xmlns:p14="http://schemas.microsoft.com/office/powerpoint/2010/main" val="278731808"/>
       </p:ext>
     </p:extLst>
   </p:cSld>
@@ -12263,7 +12263,7 @@
           <p:cNvPr id="17" name="">
             <a:extLst xmlns:a="http://schemas.openxmlformats.org/drawingml/2006/main">
               <a:ext uri="{FF2B5EF4-FFF2-40B4-BE49-F238E27FC236}">
-                <a16:creationId xmlns:a16="http://schemas.microsoft.com/office/drawing/2014/main" id="{268834D6-C557-4014-8B0F-EA6E4411A39B}"/>
+                <a16:creationId xmlns:a16="http://schemas.microsoft.com/office/drawing/2014/main" id="{C485460C-BA42-4650-8AF1-78CEA316424E}"/>
               </a:ext>
             </a:extLst>
           </p:cNvPr>
@@ -12426,7 +12426,7 @@
           <p:cNvPr id="2" name="">
             <a:extLst xmlns:a="http://schemas.openxmlformats.org/drawingml/2006/main">
               <a:ext uri="{FF2B5EF4-FFF2-40B4-BE49-F238E27FC236}">
-                <a16:creationId xmlns:a16="http://schemas.microsoft.com/office/drawing/2014/main" id="{C0F4DF77-A6EC-40A1-A0B3-0F93784CE11D}"/>
+                <a16:creationId xmlns:a16="http://schemas.microsoft.com/office/drawing/2014/main" id="{9538950D-8460-4240-AAD2-B657F7163378}"/>
               </a:ext>
             </a:extLst>
           </p:cNvPr>
@@ -12589,7 +12589,7 @@
           <p:cNvPr id="3" name="">
             <a:extLst xmlns:a="http://schemas.openxmlformats.org/drawingml/2006/main">
               <a:ext uri="{FF2B5EF4-FFF2-40B4-BE49-F238E27FC236}">
-                <a16:creationId xmlns:a16="http://schemas.microsoft.com/office/drawing/2014/main" id="{D3CE4A1C-1C5F-4A1F-8389-7B1FF1ED57A8}"/>
+                <a16:creationId xmlns:a16="http://schemas.microsoft.com/office/drawing/2014/main" id="{BBB1A258-0180-465B-814A-7CF70D5B53EB}"/>
               </a:ext>
             </a:extLst>
           </p:cNvPr>
@@ -12620,7 +12620,7 @@
           <p:cNvPr id="4" name="">
             <a:extLst xmlns:a="http://schemas.openxmlformats.org/drawingml/2006/main">
               <a:ext uri="{FF2B5EF4-FFF2-40B4-BE49-F238E27FC236}">
-                <a16:creationId xmlns:a16="http://schemas.microsoft.com/office/drawing/2014/main" id="{A62FD737-FD2C-44D5-BD18-BB1E543C28EC}"/>
+                <a16:creationId xmlns:a16="http://schemas.microsoft.com/office/drawing/2014/main" id="{B2BB2BF8-3471-4A38-8983-1B3B9C389D5C}"/>
               </a:ext>
             </a:extLst>
           </p:cNvPr>
@@ -12783,7 +12783,7 @@
           <p:cNvPr id="5" name="">
             <a:extLst xmlns:a="http://schemas.openxmlformats.org/drawingml/2006/main">
               <a:ext uri="{FF2B5EF4-FFF2-40B4-BE49-F238E27FC236}">
-                <a16:creationId xmlns:a16="http://schemas.microsoft.com/office/drawing/2014/main" id="{EE73C733-041E-4910-BF2A-ACCD3797BC78}"/>
+                <a16:creationId xmlns:a16="http://schemas.microsoft.com/office/drawing/2014/main" id="{EF55A425-55C9-43DE-8AF6-7593BE5F9242}"/>
               </a:ext>
             </a:extLst>
           </p:cNvPr>
@@ -12946,7 +12946,7 @@
           <p:cNvPr id="6" name="">
             <a:extLst xmlns:a="http://schemas.openxmlformats.org/drawingml/2006/main">
               <a:ext uri="{FF2B5EF4-FFF2-40B4-BE49-F238E27FC236}">
-                <a16:creationId xmlns:a16="http://schemas.microsoft.com/office/drawing/2014/main" id="{87B234CD-D32A-4F50-BCF8-7E37FD0E86A7}"/>
+                <a16:creationId xmlns:a16="http://schemas.microsoft.com/office/drawing/2014/main" id="{7A91F0ED-969C-4FEC-B57C-E98E4A1D4D26}"/>
               </a:ext>
             </a:extLst>
           </p:cNvPr>
@@ -13109,7 +13109,7 @@
           <p:cNvPr id="7" name="">
             <a:extLst xmlns:a="http://schemas.openxmlformats.org/drawingml/2006/main">
               <a:ext uri="{FF2B5EF4-FFF2-40B4-BE49-F238E27FC236}">
-                <a16:creationId xmlns:a16="http://schemas.microsoft.com/office/drawing/2014/main" id="{0C11BDB7-E133-4C91-A1C1-5FF3FF074CA2}"/>
+                <a16:creationId xmlns:a16="http://schemas.microsoft.com/office/drawing/2014/main" id="{42F99ED6-9515-48F9-8227-9BD620808ABA}"/>
               </a:ext>
             </a:extLst>
           </p:cNvPr>
@@ -13272,7 +13272,7 @@
           <p:cNvPr id="8" name="">
             <a:extLst xmlns:a="http://schemas.openxmlformats.org/drawingml/2006/main">
               <a:ext uri="{FF2B5EF4-FFF2-40B4-BE49-F238E27FC236}">
-                <a16:creationId xmlns:a16="http://schemas.microsoft.com/office/drawing/2014/main" id="{819A00F5-F2F4-469A-B965-6C54B56D33E9}"/>
+                <a16:creationId xmlns:a16="http://schemas.microsoft.com/office/drawing/2014/main" id="{4696D0CA-0783-4DCB-8241-6ADB35D58B12}"/>
               </a:ext>
             </a:extLst>
           </p:cNvPr>
@@ -13425,7 +13425,7 @@
                 <a:ea typeface="Segoe UI"/>
                 <a:cs typeface="Segoe UI"/>
               </a:rPr>
-              <a:t>Có UI; cần chuẩn bị database demo cô lập.</a:t>
+              <a:t>Có UI; cần chuẩn bị phiên trên database demo.</a:t>
             </a:r>
           </a:p>
         </p:txBody>
@@ -13435,7 +13435,7 @@
           <p:cNvPr id="9" name="">
             <a:extLst xmlns:a="http://schemas.openxmlformats.org/drawingml/2006/main">
               <a:ext uri="{FF2B5EF4-FFF2-40B4-BE49-F238E27FC236}">
-                <a16:creationId xmlns:a16="http://schemas.microsoft.com/office/drawing/2014/main" id="{A8E9C259-5F3C-4CE2-8F45-F0E761CC3CD8}"/>
+                <a16:creationId xmlns:a16="http://schemas.microsoft.com/office/drawing/2014/main" id="{92B83AD0-0745-438E-B85C-E9A76A8F33EF}"/>
               </a:ext>
             </a:extLst>
           </p:cNvPr>
@@ -13466,7 +13466,7 @@
           <p:cNvPr id="10" name="">
             <a:extLst xmlns:a="http://schemas.openxmlformats.org/drawingml/2006/main">
               <a:ext uri="{FF2B5EF4-FFF2-40B4-BE49-F238E27FC236}">
-                <a16:creationId xmlns:a16="http://schemas.microsoft.com/office/drawing/2014/main" id="{7E9959BF-C8A2-4A22-84FC-A265DC8853FA}"/>
+                <a16:creationId xmlns:a16="http://schemas.microsoft.com/office/drawing/2014/main" id="{92789ECC-82A0-4901-8408-A88853836351}"/>
               </a:ext>
             </a:extLst>
           </p:cNvPr>
@@ -13629,7 +13629,7 @@
           <p:cNvPr id="11" name="">
             <a:extLst xmlns:a="http://schemas.openxmlformats.org/drawingml/2006/main">
               <a:ext uri="{FF2B5EF4-FFF2-40B4-BE49-F238E27FC236}">
-                <a16:creationId xmlns:a16="http://schemas.microsoft.com/office/drawing/2014/main" id="{720F59AD-8F74-4682-B8E1-85CF27B854D2}"/>
+                <a16:creationId xmlns:a16="http://schemas.microsoft.com/office/drawing/2014/main" id="{E90770E8-D7B1-4D82-848F-79D7E889EDB4}"/>
               </a:ext>
             </a:extLst>
           </p:cNvPr>
@@ -13782,7 +13782,7 @@
                 <a:ea typeface="Segoe UI"/>
                 <a:cs typeface="Segoe UI"/>
               </a:rPr>
-              <a:t>Tìm tên/ISBN, lọc thể loại và thử alias trên nhánh DEV1.</a:t>
+              <a:t>Tìm tên, tác giả và thể loại; thử alias trên nhánh Tuấn.</a:t>
             </a:r>
           </a:p>
         </p:txBody>
@@ -13792,7 +13792,7 @@
           <p:cNvPr id="12" name="">
             <a:extLst xmlns:a="http://schemas.openxmlformats.org/drawingml/2006/main">
               <a:ext uri="{FF2B5EF4-FFF2-40B4-BE49-F238E27FC236}">
-                <a16:creationId xmlns:a16="http://schemas.microsoft.com/office/drawing/2014/main" id="{428ADCE1-7E62-46D7-A217-B775313408D2}"/>
+                <a16:creationId xmlns:a16="http://schemas.microsoft.com/office/drawing/2014/main" id="{F2CD6B2C-ABCE-48EC-B045-003C514DF807}"/>
               </a:ext>
             </a:extLst>
           </p:cNvPr>
@@ -13955,7 +13955,7 @@
           <p:cNvPr id="13" name="">
             <a:extLst xmlns:a="http://schemas.openxmlformats.org/drawingml/2006/main">
               <a:ext uri="{FF2B5EF4-FFF2-40B4-BE49-F238E27FC236}">
-                <a16:creationId xmlns:a16="http://schemas.microsoft.com/office/drawing/2014/main" id="{3E4E76DF-6CD1-4D55-9E34-566309C4F5DD}"/>
+                <a16:creationId xmlns:a16="http://schemas.microsoft.com/office/drawing/2014/main" id="{FB61036B-A428-43B0-937A-6B021BE86D80}"/>
               </a:ext>
             </a:extLst>
           </p:cNvPr>
@@ -13986,7 +13986,7 @@
           <p:cNvPr id="14" name="">
             <a:extLst xmlns:a="http://schemas.openxmlformats.org/drawingml/2006/main">
               <a:ext uri="{FF2B5EF4-FFF2-40B4-BE49-F238E27FC236}">
-                <a16:creationId xmlns:a16="http://schemas.microsoft.com/office/drawing/2014/main" id="{1947B75F-0F13-44AE-9DF6-FB3696A90F4F}"/>
+                <a16:creationId xmlns:a16="http://schemas.microsoft.com/office/drawing/2014/main" id="{F8528D27-24D8-418F-87D0-E2753DD15C99}"/>
               </a:ext>
             </a:extLst>
           </p:cNvPr>
@@ -14149,7 +14149,7 @@
           <p:cNvPr id="15" name="">
             <a:extLst xmlns:a="http://schemas.openxmlformats.org/drawingml/2006/main">
               <a:ext uri="{FF2B5EF4-FFF2-40B4-BE49-F238E27FC236}">
-                <a16:creationId xmlns:a16="http://schemas.microsoft.com/office/drawing/2014/main" id="{144783EB-6DD6-4FCB-9AFD-5619486B4DAE}"/>
+                <a16:creationId xmlns:a16="http://schemas.microsoft.com/office/drawing/2014/main" id="{405B0733-C243-4501-AAA0-D33D42B511B4}"/>
               </a:ext>
             </a:extLst>
           </p:cNvPr>
@@ -14302,7 +14302,7 @@
                 <a:ea typeface="Segoe UI"/>
                 <a:cs typeface="Segoe UI"/>
               </a:rPr>
-              <a:t>Xem bằng chứng và duyệt nội bộ trên UI khi có bản ghi.</a:t>
+              <a:t>Phân tích Book/chi nhánh từ Core rồi xem bằng chứng tại Insight.</a:t>
             </a:r>
           </a:p>
         </p:txBody>
@@ -14312,7 +14312,7 @@
           <p:cNvPr id="16" name="">
             <a:extLst xmlns:a="http://schemas.openxmlformats.org/drawingml/2006/main">
               <a:ext uri="{FF2B5EF4-FFF2-40B4-BE49-F238E27FC236}">
-                <a16:creationId xmlns:a16="http://schemas.microsoft.com/office/drawing/2014/main" id="{014816A8-72F1-47BC-B2CF-C193F6EB6931}"/>
+                <a16:creationId xmlns:a16="http://schemas.microsoft.com/office/drawing/2014/main" id="{F3C66450-CC4A-458C-A6CD-D8532A4CC5C9}"/>
               </a:ext>
             </a:extLst>
           </p:cNvPr>
@@ -14465,7 +14465,7 @@
                 <a:ea typeface="Segoe UI"/>
                 <a:cs typeface="Segoe UI"/>
               </a:rPr>
-              <a:t>Nguồn tạo đề xuất từ Core chưa bàn giao.</a:t>
+              <a:t>Chưa có E2E tạo đề xuất xuyên hai service.</a:t>
             </a:r>
           </a:p>
         </p:txBody>
@@ -14473,7 +14473,7 @@
     </p:spTree>
     <p:extLst>
       <p:ext uri="{BB962C8B-B14F-4D97-AF65-F5344CB8AC3E}">
-        <p14:creationId xmlns:p14="http://schemas.microsoft.com/office/powerpoint/2010/main" val="199810109"/>
+        <p14:creationId xmlns:p14="http://schemas.microsoft.com/office/powerpoint/2010/main" val="1797034366"/>
       </p:ext>
     </p:extLst>
   </p:cSld>
@@ -14504,7 +14504,7 @@
           <p:cNvPr id="14" name="">
             <a:extLst xmlns:a="http://schemas.openxmlformats.org/drawingml/2006/main">
               <a:ext uri="{FF2B5EF4-FFF2-40B4-BE49-F238E27FC236}">
-                <a16:creationId xmlns:a16="http://schemas.microsoft.com/office/drawing/2014/main" id="{331CD6F6-FBAB-49EC-8DF2-DA8BC70BD189}"/>
+                <a16:creationId xmlns:a16="http://schemas.microsoft.com/office/drawing/2014/main" id="{5C0F373D-4947-4F00-A6F8-2D079C590D38}"/>
               </a:ext>
             </a:extLst>
           </p:cNvPr>
@@ -14667,7 +14667,7 @@
           <p:cNvPr id="2" name="">
             <a:extLst xmlns:a="http://schemas.openxmlformats.org/drawingml/2006/main">
               <a:ext uri="{FF2B5EF4-FFF2-40B4-BE49-F238E27FC236}">
-                <a16:creationId xmlns:a16="http://schemas.microsoft.com/office/drawing/2014/main" id="{F9A5DEB0-B075-40D7-80C3-ED0840DC36D5}"/>
+                <a16:creationId xmlns:a16="http://schemas.microsoft.com/office/drawing/2014/main" id="{A27DCEFF-2C7C-4F51-BD60-3FBCC37B8603}"/>
               </a:ext>
             </a:extLst>
           </p:cNvPr>
@@ -14830,7 +14830,7 @@
           <p:cNvPr id="3" name="">
             <a:extLst xmlns:a="http://schemas.openxmlformats.org/drawingml/2006/main">
               <a:ext uri="{FF2B5EF4-FFF2-40B4-BE49-F238E27FC236}">
-                <a16:creationId xmlns:a16="http://schemas.microsoft.com/office/drawing/2014/main" id="{4A2A45D3-999D-4109-A9FE-CB59AC10652F}"/>
+                <a16:creationId xmlns:a16="http://schemas.microsoft.com/office/drawing/2014/main" id="{37366AA8-BE5A-4247-A71D-30DF52205D7F}"/>
               </a:ext>
             </a:extLst>
           </p:cNvPr>
@@ -14861,7 +14861,7 @@
           <p:cNvPr id="4" name="">
             <a:extLst xmlns:a="http://schemas.openxmlformats.org/drawingml/2006/main">
               <a:ext uri="{FF2B5EF4-FFF2-40B4-BE49-F238E27FC236}">
-                <a16:creationId xmlns:a16="http://schemas.microsoft.com/office/drawing/2014/main" id="{59A34A1E-115D-4DA9-89D6-419140B66393}"/>
+                <a16:creationId xmlns:a16="http://schemas.microsoft.com/office/drawing/2014/main" id="{16A8D20B-933B-471A-B17E-F35341376D29}"/>
               </a:ext>
             </a:extLst>
           </p:cNvPr>
@@ -15024,7 +15024,7 @@
           <p:cNvPr id="5" name="">
             <a:extLst xmlns:a="http://schemas.openxmlformats.org/drawingml/2006/main">
               <a:ext uri="{FF2B5EF4-FFF2-40B4-BE49-F238E27FC236}">
-                <a16:creationId xmlns:a16="http://schemas.microsoft.com/office/drawing/2014/main" id="{36FD007C-84BA-45F7-BCDD-B2A075BE9A10}"/>
+                <a16:creationId xmlns:a16="http://schemas.microsoft.com/office/drawing/2014/main" id="{F43BA2E4-CD86-496F-A61B-5C736147024D}"/>
               </a:ext>
             </a:extLst>
           </p:cNvPr>
@@ -15187,7 +15187,7 @@
           <p:cNvPr id="6" name="">
             <a:extLst xmlns:a="http://schemas.openxmlformats.org/drawingml/2006/main">
               <a:ext uri="{FF2B5EF4-FFF2-40B4-BE49-F238E27FC236}">
-                <a16:creationId xmlns:a16="http://schemas.microsoft.com/office/drawing/2014/main" id="{8A1A8BA6-C83C-4F18-9091-0752DE7C738F}"/>
+                <a16:creationId xmlns:a16="http://schemas.microsoft.com/office/drawing/2014/main" id="{12AF4932-5E25-4594-A51E-828EC8441D4B}"/>
               </a:ext>
             </a:extLst>
           </p:cNvPr>
@@ -15350,7 +15350,7 @@
           <p:cNvPr id="7" name="">
             <a:extLst xmlns:a="http://schemas.openxmlformats.org/drawingml/2006/main">
               <a:ext uri="{FF2B5EF4-FFF2-40B4-BE49-F238E27FC236}">
-                <a16:creationId xmlns:a16="http://schemas.microsoft.com/office/drawing/2014/main" id="{5EFAD7C9-C46F-42D1-A413-D2110E4B8C7F}"/>
+                <a16:creationId xmlns:a16="http://schemas.microsoft.com/office/drawing/2014/main" id="{2F14AC20-5D03-4496-9189-B8145DDF6EEE}"/>
               </a:ext>
             </a:extLst>
           </p:cNvPr>
@@ -15557,7 +15557,7 @@
                 <a:ea typeface="Segoe UI"/>
                 <a:cs typeface="Segoe UI"/>
               </a:rPr>
-              <a:t>Kiểm kê và tìm kiếm trên main</a:t>
+              <a:t>Kiểm kê, Search trên main</a:t>
             </a:r>
           </a:p>
         </p:txBody>
@@ -15567,7 +15567,7 @@
           <p:cNvPr id="8" name="">
             <a:extLst xmlns:a="http://schemas.openxmlformats.org/drawingml/2006/main">
               <a:ext uri="{FF2B5EF4-FFF2-40B4-BE49-F238E27FC236}">
-                <a16:creationId xmlns:a16="http://schemas.microsoft.com/office/drawing/2014/main" id="{F63F8DE6-FCDC-4371-9DF2-80D64FE45211}"/>
+                <a16:creationId xmlns:a16="http://schemas.microsoft.com/office/drawing/2014/main" id="{FCAFE1EC-2DEE-47B8-BCA0-90E778053AB3}"/>
               </a:ext>
             </a:extLst>
           </p:cNvPr>
@@ -15598,7 +15598,7 @@
           <p:cNvPr id="9" name="">
             <a:extLst xmlns:a="http://schemas.openxmlformats.org/drawingml/2006/main">
               <a:ext uri="{FF2B5EF4-FFF2-40B4-BE49-F238E27FC236}">
-                <a16:creationId xmlns:a16="http://schemas.microsoft.com/office/drawing/2014/main" id="{2ACCC8C4-F7C1-43DD-81FD-F184FB22147A}"/>
+                <a16:creationId xmlns:a16="http://schemas.microsoft.com/office/drawing/2014/main" id="{70D54489-02FE-4FC6-BAF7-E786BDAF8F86}"/>
               </a:ext>
             </a:extLst>
           </p:cNvPr>
@@ -15761,7 +15761,7 @@
           <p:cNvPr id="10" name="">
             <a:extLst xmlns:a="http://schemas.openxmlformats.org/drawingml/2006/main">
               <a:ext uri="{FF2B5EF4-FFF2-40B4-BE49-F238E27FC236}">
-                <a16:creationId xmlns:a16="http://schemas.microsoft.com/office/drawing/2014/main" id="{D61FCF78-D823-417A-B03C-39A0AB398226}"/>
+                <a16:creationId xmlns:a16="http://schemas.microsoft.com/office/drawing/2014/main" id="{B89B8E4D-A9AF-408B-863B-9470B3641893}"/>
               </a:ext>
             </a:extLst>
           </p:cNvPr>
@@ -15941,7 +15941,7 @@
                 <a:ea typeface="Segoe UI"/>
                 <a:cs typeface="Segoe UI"/>
               </a:rPr>
-              <a:t>PR #27: lọc Alias, đề xuất nội bộ</a:t>
+              <a:t>PR #27: Alias UI, Acquisition</a:t>
             </a:r>
           </a:p>
           <a:p xmlns:a="http://schemas.openxmlformats.org/drawingml/2006/main">
@@ -15978,7 +15978,7 @@
           <p:cNvPr id="11" name="">
             <a:extLst xmlns:a="http://schemas.openxmlformats.org/drawingml/2006/main">
               <a:ext uri="{FF2B5EF4-FFF2-40B4-BE49-F238E27FC236}">
-                <a16:creationId xmlns:a16="http://schemas.microsoft.com/office/drawing/2014/main" id="{6F059C0A-CBCD-43EE-A95C-A41DD375B8AD}"/>
+                <a16:creationId xmlns:a16="http://schemas.microsoft.com/office/drawing/2014/main" id="{8682B886-1180-4B44-AF05-70F484795158}"/>
               </a:ext>
             </a:extLst>
           </p:cNvPr>
@@ -16009,7 +16009,7 @@
           <p:cNvPr id="12" name="">
             <a:extLst xmlns:a="http://schemas.openxmlformats.org/drawingml/2006/main">
               <a:ext uri="{FF2B5EF4-FFF2-40B4-BE49-F238E27FC236}">
-                <a16:creationId xmlns:a16="http://schemas.microsoft.com/office/drawing/2014/main" id="{A5D9FADA-48DD-42A8-A250-920D6FCB1588}"/>
+                <a16:creationId xmlns:a16="http://schemas.microsoft.com/office/drawing/2014/main" id="{31B89999-D3DA-4B9B-8B22-4526D4D070B1}"/>
               </a:ext>
             </a:extLst>
           </p:cNvPr>
@@ -16172,7 +16172,7 @@
           <p:cNvPr id="13" name="">
             <a:extLst xmlns:a="http://schemas.openxmlformats.org/drawingml/2006/main">
               <a:ext uri="{FF2B5EF4-FFF2-40B4-BE49-F238E27FC236}">
-                <a16:creationId xmlns:a16="http://schemas.microsoft.com/office/drawing/2014/main" id="{8E06B7DE-1B0E-4BBA-94E7-B5F8C586C5DD}"/>
+                <a16:creationId xmlns:a16="http://schemas.microsoft.com/office/drawing/2014/main" id="{0BE4E59F-9399-48CA-9F87-82AE1921601B}"/>
               </a:ext>
             </a:extLst>
           </p:cNvPr>
@@ -16387,7 +16387,7 @@
     </p:spTree>
     <p:extLst>
       <p:ext uri="{BB962C8B-B14F-4D97-AF65-F5344CB8AC3E}">
-        <p14:creationId xmlns:p14="http://schemas.microsoft.com/office/powerpoint/2010/main" val="824792472"/>
+        <p14:creationId xmlns:p14="http://schemas.microsoft.com/office/powerpoint/2010/main" val="530117063"/>
       </p:ext>
     </p:extLst>
   </p:cSld>
@@ -16418,7 +16418,7 @@
           <p:cNvPr id="7" name="">
             <a:extLst xmlns:a="http://schemas.openxmlformats.org/drawingml/2006/main">
               <a:ext uri="{FF2B5EF4-FFF2-40B4-BE49-F238E27FC236}">
-                <a16:creationId xmlns:a16="http://schemas.microsoft.com/office/drawing/2014/main" id="{E379BFED-0100-4CEA-80AC-2A08AE809CC5}"/>
+                <a16:creationId xmlns:a16="http://schemas.microsoft.com/office/drawing/2014/main" id="{D37A5AA8-15EE-4716-85B0-D2D347BF48B3}"/>
               </a:ext>
             </a:extLst>
           </p:cNvPr>
@@ -16581,7 +16581,7 @@
           <p:cNvPr id="2" name="">
             <a:extLst xmlns:a="http://schemas.openxmlformats.org/drawingml/2006/main">
               <a:ext uri="{FF2B5EF4-FFF2-40B4-BE49-F238E27FC236}">
-                <a16:creationId xmlns:a16="http://schemas.microsoft.com/office/drawing/2014/main" id="{CEF878C5-A175-4435-86E3-7F9BE5951B41}"/>
+                <a16:creationId xmlns:a16="http://schemas.microsoft.com/office/drawing/2014/main" id="{E2A6EEA7-80AA-4963-81F8-5951105BB390}"/>
               </a:ext>
             </a:extLst>
           </p:cNvPr>
@@ -16744,7 +16744,7 @@
           <p:cNvPr id="3" name="">
             <a:extLst xmlns:a="http://schemas.openxmlformats.org/drawingml/2006/main">
               <a:ext uri="{FF2B5EF4-FFF2-40B4-BE49-F238E27FC236}">
-                <a16:creationId xmlns:a16="http://schemas.microsoft.com/office/drawing/2014/main" id="{E7F0076E-469E-457B-88B8-D0D237D95CBC}"/>
+                <a16:creationId xmlns:a16="http://schemas.microsoft.com/office/drawing/2014/main" id="{078ECBB0-DFC4-43BF-B603-5BE5D621393A}"/>
               </a:ext>
             </a:extLst>
           </p:cNvPr>
@@ -16775,7 +16775,7 @@
           <p:cNvPr id="4" name="">
             <a:extLst xmlns:a="http://schemas.openxmlformats.org/drawingml/2006/main">
               <a:ext uri="{FF2B5EF4-FFF2-40B4-BE49-F238E27FC236}">
-                <a16:creationId xmlns:a16="http://schemas.microsoft.com/office/drawing/2014/main" id="{62FFF7BF-757C-4424-963A-281A29092085}"/>
+                <a16:creationId xmlns:a16="http://schemas.microsoft.com/office/drawing/2014/main" id="{DB9492F5-6FF5-4EBE-8384-69489D407382}"/>
               </a:ext>
             </a:extLst>
           </p:cNvPr>
@@ -16938,7 +16938,7 @@
           <p:cNvPr id="5" name="">
             <a:extLst xmlns:a="http://schemas.openxmlformats.org/drawingml/2006/main">
               <a:ext uri="{FF2B5EF4-FFF2-40B4-BE49-F238E27FC236}">
-                <a16:creationId xmlns:a16="http://schemas.microsoft.com/office/drawing/2014/main" id="{29550CA8-1562-4D8B-9F4A-B23A5972ACA3}"/>
+                <a16:creationId xmlns:a16="http://schemas.microsoft.com/office/drawing/2014/main" id="{084173AD-D101-4F99-8474-97064026A29C}"/>
               </a:ext>
             </a:extLst>
           </p:cNvPr>
@@ -17091,7 +17091,7 @@
                 <a:ea typeface="Segoe UI"/>
                 <a:cs typeface="Segoe UI"/>
               </a:rPr>
-              <a:t>Tuấn: phiên kiểm kê/UI, tích hợp Search, workflow đề xuất.</a:t>
+              <a:t>Tuấn: giao diện, phiên kiểm kê, Search và đề xuất bổ sung.</a:t>
             </a:r>
           </a:p>
           <a:p xmlns:a="http://schemas.openxmlformats.org/drawingml/2006/main">
@@ -17118,7 +17118,7 @@
                 <a:ea typeface="Segoe UI"/>
                 <a:cs typeface="Segoe UI"/>
               </a:rPr>
-              <a:t>Toàn: truy vấn kiểm kê, Category Alias, nguồn báo cáo/CSV.</a:t>
+              <a:t>Toàn: truy vấn kiểm kê và Category Alias; hiện tạm dừng Phase 7.</a:t>
             </a:r>
           </a:p>
         </p:txBody>
@@ -17128,7 +17128,7 @@
           <p:cNvPr id="6" name="">
             <a:extLst xmlns:a="http://schemas.openxmlformats.org/drawingml/2006/main">
               <a:ext uri="{FF2B5EF4-FFF2-40B4-BE49-F238E27FC236}">
-                <a16:creationId xmlns:a16="http://schemas.microsoft.com/office/drawing/2014/main" id="{68E15CF3-2D1B-49BC-A1B4-B9A9DBE19C04}"/>
+                <a16:creationId xmlns:a16="http://schemas.microsoft.com/office/drawing/2014/main" id="{94BB1581-57B9-4DF8-B001-55749030C09B}"/>
               </a:ext>
             </a:extLst>
           </p:cNvPr>
@@ -17281,7 +17281,7 @@
                 <a:ea typeface="Segoe UI"/>
                 <a:cs typeface="Segoe UI"/>
               </a:rPr>
-              <a:t>Bước tiếp theo: khép PR #25 và #27, kiểm demo và CI trên main.</a:t>
+              <a:t>Tiếp theo: ba tài khoản demo, duyệt ảnh, review PR và kiểm CI trên commit cuối.</a:t>
             </a:r>
           </a:p>
         </p:txBody>
@@ -17289,7 +17289,7 @@
     </p:spTree>
     <p:extLst>
       <p:ext uri="{BB962C8B-B14F-4D97-AF65-F5344CB8AC3E}">
-        <p14:creationId xmlns:p14="http://schemas.microsoft.com/office/powerpoint/2010/main" val="695790631"/>
+        <p14:creationId xmlns:p14="http://schemas.microsoft.com/office/powerpoint/2010/main" val="711051965"/>
       </p:ext>
     </p:extLst>
   </p:cSld>
@@ -17320,7 +17320,7 @@
           <p:cNvPr id="22" name="">
             <a:extLst xmlns:a="http://schemas.openxmlformats.org/drawingml/2006/main">
               <a:ext uri="{FF2B5EF4-FFF2-40B4-BE49-F238E27FC236}">
-                <a16:creationId xmlns:a16="http://schemas.microsoft.com/office/drawing/2014/main" id="{1304548C-6B1B-48C7-86EE-807A43FA3F57}"/>
+                <a16:creationId xmlns:a16="http://schemas.microsoft.com/office/drawing/2014/main" id="{B7CEFAB2-162A-4383-8E94-32A71BEF1C4A}"/>
               </a:ext>
             </a:extLst>
           </p:cNvPr>
@@ -17483,7 +17483,7 @@
           <p:cNvPr id="2" name="">
             <a:extLst xmlns:a="http://schemas.openxmlformats.org/drawingml/2006/main">
               <a:ext uri="{FF2B5EF4-FFF2-40B4-BE49-F238E27FC236}">
-                <a16:creationId xmlns:a16="http://schemas.microsoft.com/office/drawing/2014/main" id="{8CB83A3E-F2A0-48C0-8C4D-C67EC5711DC4}"/>
+                <a16:creationId xmlns:a16="http://schemas.microsoft.com/office/drawing/2014/main" id="{EDDB8DFD-6B2F-4635-9AAD-ACAB97AB33DC}"/>
               </a:ext>
             </a:extLst>
           </p:cNvPr>
@@ -17646,7 +17646,7 @@
           <p:cNvPr id="3" name="">
             <a:extLst xmlns:a="http://schemas.openxmlformats.org/drawingml/2006/main">
               <a:ext uri="{FF2B5EF4-FFF2-40B4-BE49-F238E27FC236}">
-                <a16:creationId xmlns:a16="http://schemas.microsoft.com/office/drawing/2014/main" id="{BCCF0B9A-08A3-4F9A-80B4-CD767F584762}"/>
+                <a16:creationId xmlns:a16="http://schemas.microsoft.com/office/drawing/2014/main" id="{D2690778-44A8-4A75-BC39-4A509F2167FD}"/>
               </a:ext>
             </a:extLst>
           </p:cNvPr>
@@ -17677,7 +17677,7 @@
           <p:cNvPr id="4" name="">
             <a:extLst xmlns:a="http://schemas.openxmlformats.org/drawingml/2006/main">
               <a:ext uri="{FF2B5EF4-FFF2-40B4-BE49-F238E27FC236}">
-                <a16:creationId xmlns:a16="http://schemas.microsoft.com/office/drawing/2014/main" id="{215C9E54-BE8F-4DF7-9E1E-CB6D8F383848}"/>
+                <a16:creationId xmlns:a16="http://schemas.microsoft.com/office/drawing/2014/main" id="{785197F4-358E-464D-9ED6-73A77657C65C}"/>
               </a:ext>
             </a:extLst>
           </p:cNvPr>
@@ -17840,7 +17840,7 @@
           <p:cNvPr id="5" name="">
             <a:extLst xmlns:a="http://schemas.openxmlformats.org/drawingml/2006/main">
               <a:ext uri="{FF2B5EF4-FFF2-40B4-BE49-F238E27FC236}">
-                <a16:creationId xmlns:a16="http://schemas.microsoft.com/office/drawing/2014/main" id="{82F58FD3-E611-4B02-BFCF-E8571AAC8C01}"/>
+                <a16:creationId xmlns:a16="http://schemas.microsoft.com/office/drawing/2014/main" id="{FABAA9B6-4B43-4101-9FD9-E798E9165E81}"/>
               </a:ext>
             </a:extLst>
           </p:cNvPr>
@@ -18003,7 +18003,7 @@
           <p:cNvPr id="6" name="">
             <a:extLst xmlns:a="http://schemas.openxmlformats.org/drawingml/2006/main">
               <a:ext uri="{FF2B5EF4-FFF2-40B4-BE49-F238E27FC236}">
-                <a16:creationId xmlns:a16="http://schemas.microsoft.com/office/drawing/2014/main" id="{3136E930-1513-480C-B743-BEEDF48532B6}"/>
+                <a16:creationId xmlns:a16="http://schemas.microsoft.com/office/drawing/2014/main" id="{69E685DA-77E5-41C5-A32E-17E895E43E37}"/>
               </a:ext>
             </a:extLst>
           </p:cNvPr>
@@ -18166,7 +18166,7 @@
           <p:cNvPr id="7" name="">
             <a:extLst xmlns:a="http://schemas.openxmlformats.org/drawingml/2006/main">
               <a:ext uri="{FF2B5EF4-FFF2-40B4-BE49-F238E27FC236}">
-                <a16:creationId xmlns:a16="http://schemas.microsoft.com/office/drawing/2014/main" id="{1A35AD6E-E50C-476F-9120-C852BD346191}"/>
+                <a16:creationId xmlns:a16="http://schemas.microsoft.com/office/drawing/2014/main" id="{7B1565A1-FFD3-4F2D-8FA7-2D62149E1DCE}"/>
               </a:ext>
             </a:extLst>
           </p:cNvPr>
@@ -18329,7 +18329,7 @@
           <p:cNvPr id="8" name="">
             <a:extLst xmlns:a="http://schemas.openxmlformats.org/drawingml/2006/main">
               <a:ext uri="{FF2B5EF4-FFF2-40B4-BE49-F238E27FC236}">
-                <a16:creationId xmlns:a16="http://schemas.microsoft.com/office/drawing/2014/main" id="{B2489F16-EC8B-470C-8A22-4F70B839DF4E}"/>
+                <a16:creationId xmlns:a16="http://schemas.microsoft.com/office/drawing/2014/main" id="{B8A65D06-1DEA-4B4F-ADBE-D6D684CDFA83}"/>
               </a:ext>
             </a:extLst>
           </p:cNvPr>
@@ -18492,7 +18492,7 @@
           <p:cNvPr id="9" name="">
             <a:extLst xmlns:a="http://schemas.openxmlformats.org/drawingml/2006/main">
               <a:ext uri="{FF2B5EF4-FFF2-40B4-BE49-F238E27FC236}">
-                <a16:creationId xmlns:a16="http://schemas.microsoft.com/office/drawing/2014/main" id="{9700D7FD-02C4-401C-B158-175195BD245A}"/>
+                <a16:creationId xmlns:a16="http://schemas.microsoft.com/office/drawing/2014/main" id="{6D8DC5CA-A8F9-4558-AB8B-54A6DF4EE933}"/>
               </a:ext>
             </a:extLst>
           </p:cNvPr>
@@ -18655,7 +18655,7 @@
           <p:cNvPr id="10" name="">
             <a:extLst xmlns:a="http://schemas.openxmlformats.org/drawingml/2006/main">
               <a:ext uri="{FF2B5EF4-FFF2-40B4-BE49-F238E27FC236}">
-                <a16:creationId xmlns:a16="http://schemas.microsoft.com/office/drawing/2014/main" id="{1BE76F62-D3CB-4A54-9BCC-A0B8D2A19DF1}"/>
+                <a16:creationId xmlns:a16="http://schemas.microsoft.com/office/drawing/2014/main" id="{D39B1101-09B3-45A3-A4CB-69CD1F27A646}"/>
               </a:ext>
             </a:extLst>
           </p:cNvPr>
@@ -18686,7 +18686,7 @@
           <p:cNvPr id="11" name="">
             <a:extLst xmlns:a="http://schemas.openxmlformats.org/drawingml/2006/main">
               <a:ext uri="{FF2B5EF4-FFF2-40B4-BE49-F238E27FC236}">
-                <a16:creationId xmlns:a16="http://schemas.microsoft.com/office/drawing/2014/main" id="{33988411-7821-40E7-BC72-FC3566BDD670}"/>
+                <a16:creationId xmlns:a16="http://schemas.microsoft.com/office/drawing/2014/main" id="{191FE5EC-7BC8-4FA6-AFC8-7FD1EB72C56C}"/>
               </a:ext>
             </a:extLst>
           </p:cNvPr>
@@ -18849,7 +18849,7 @@
           <p:cNvPr id="12" name="">
             <a:extLst xmlns:a="http://schemas.openxmlformats.org/drawingml/2006/main">
               <a:ext uri="{FF2B5EF4-FFF2-40B4-BE49-F238E27FC236}">
-                <a16:creationId xmlns:a16="http://schemas.microsoft.com/office/drawing/2014/main" id="{1105709B-473D-4E80-8ACB-347524A34BCD}"/>
+                <a16:creationId xmlns:a16="http://schemas.microsoft.com/office/drawing/2014/main" id="{7FC5DC79-C6B2-423D-BC59-DE066190591A}"/>
               </a:ext>
             </a:extLst>
           </p:cNvPr>
@@ -19012,7 +19012,7 @@
           <p:cNvPr id="13" name="">
             <a:extLst xmlns:a="http://schemas.openxmlformats.org/drawingml/2006/main">
               <a:ext uri="{FF2B5EF4-FFF2-40B4-BE49-F238E27FC236}">
-                <a16:creationId xmlns:a16="http://schemas.microsoft.com/office/drawing/2014/main" id="{91B099CF-0F95-4261-9304-B757CCC7CC37}"/>
+                <a16:creationId xmlns:a16="http://schemas.microsoft.com/office/drawing/2014/main" id="{BC2E9865-BE85-4325-BAA2-62DC16875A13}"/>
               </a:ext>
             </a:extLst>
           </p:cNvPr>
@@ -19175,7 +19175,7 @@
           <p:cNvPr id="14" name="">
             <a:extLst xmlns:a="http://schemas.openxmlformats.org/drawingml/2006/main">
               <a:ext uri="{FF2B5EF4-FFF2-40B4-BE49-F238E27FC236}">
-                <a16:creationId xmlns:a16="http://schemas.microsoft.com/office/drawing/2014/main" id="{96616E7F-F40F-4EEF-B927-43F53A92D131}"/>
+                <a16:creationId xmlns:a16="http://schemas.microsoft.com/office/drawing/2014/main" id="{66B7E38C-C852-44DD-834F-D24B50F33AEA}"/>
               </a:ext>
             </a:extLst>
           </p:cNvPr>
@@ -19206,7 +19206,7 @@
           <p:cNvPr id="15" name="">
             <a:extLst xmlns:a="http://schemas.openxmlformats.org/drawingml/2006/main">
               <a:ext uri="{FF2B5EF4-FFF2-40B4-BE49-F238E27FC236}">
-                <a16:creationId xmlns:a16="http://schemas.microsoft.com/office/drawing/2014/main" id="{2F451C38-5D26-4A07-929D-B93985BE5717}"/>
+                <a16:creationId xmlns:a16="http://schemas.microsoft.com/office/drawing/2014/main" id="{67086E4B-5535-40C8-80BD-770F31D91541}"/>
               </a:ext>
             </a:extLst>
           </p:cNvPr>
@@ -19369,7 +19369,7 @@
           <p:cNvPr id="16" name="">
             <a:extLst xmlns:a="http://schemas.openxmlformats.org/drawingml/2006/main">
               <a:ext uri="{FF2B5EF4-FFF2-40B4-BE49-F238E27FC236}">
-                <a16:creationId xmlns:a16="http://schemas.microsoft.com/office/drawing/2014/main" id="{03D31A48-4F1B-45BB-A1DC-A2699226C98E}"/>
+                <a16:creationId xmlns:a16="http://schemas.microsoft.com/office/drawing/2014/main" id="{A1758B18-D615-4ADD-93D0-2A3AF7D48D97}"/>
               </a:ext>
             </a:extLst>
           </p:cNvPr>
@@ -19532,7 +19532,7 @@
           <p:cNvPr id="17" name="">
             <a:extLst xmlns:a="http://schemas.openxmlformats.org/drawingml/2006/main">
               <a:ext uri="{FF2B5EF4-FFF2-40B4-BE49-F238E27FC236}">
-                <a16:creationId xmlns:a16="http://schemas.microsoft.com/office/drawing/2014/main" id="{7530045B-4D25-4B7E-9391-76382F930F98}"/>
+                <a16:creationId xmlns:a16="http://schemas.microsoft.com/office/drawing/2014/main" id="{F7EB3889-8933-49D8-A34F-79A5967F9788}"/>
               </a:ext>
             </a:extLst>
           </p:cNvPr>
@@ -19695,7 +19695,7 @@
           <p:cNvPr id="18" name="">
             <a:extLst xmlns:a="http://schemas.openxmlformats.org/drawingml/2006/main">
               <a:ext uri="{FF2B5EF4-FFF2-40B4-BE49-F238E27FC236}">
-                <a16:creationId xmlns:a16="http://schemas.microsoft.com/office/drawing/2014/main" id="{43D562E7-F5E2-496E-8039-56BF6BAD6C31}"/>
+                <a16:creationId xmlns:a16="http://schemas.microsoft.com/office/drawing/2014/main" id="{FC38E5F3-8017-41C5-BE57-065446C12EE4}"/>
               </a:ext>
             </a:extLst>
           </p:cNvPr>
@@ -19726,7 +19726,7 @@
           <p:cNvPr id="19" name="">
             <a:extLst xmlns:a="http://schemas.openxmlformats.org/drawingml/2006/main">
               <a:ext uri="{FF2B5EF4-FFF2-40B4-BE49-F238E27FC236}">
-                <a16:creationId xmlns:a16="http://schemas.microsoft.com/office/drawing/2014/main" id="{E967DC4D-1294-4454-8B64-A1EC16BF8EEF}"/>
+                <a16:creationId xmlns:a16="http://schemas.microsoft.com/office/drawing/2014/main" id="{6C734277-8588-43CD-8503-1B15FE52BC85}"/>
               </a:ext>
             </a:extLst>
           </p:cNvPr>
@@ -19889,7 +19889,7 @@
           <p:cNvPr id="20" name="">
             <a:extLst xmlns:a="http://schemas.openxmlformats.org/drawingml/2006/main">
               <a:ext uri="{FF2B5EF4-FFF2-40B4-BE49-F238E27FC236}">
-                <a16:creationId xmlns:a16="http://schemas.microsoft.com/office/drawing/2014/main" id="{2780313E-230C-4600-9085-625824BDC428}"/>
+                <a16:creationId xmlns:a16="http://schemas.microsoft.com/office/drawing/2014/main" id="{9261718B-0F33-489B-8EF9-954248130EC2}"/>
               </a:ext>
             </a:extLst>
           </p:cNvPr>
@@ -20052,7 +20052,7 @@
           <p:cNvPr id="21" name="">
             <a:extLst xmlns:a="http://schemas.openxmlformats.org/drawingml/2006/main">
               <a:ext uri="{FF2B5EF4-FFF2-40B4-BE49-F238E27FC236}">
-                <a16:creationId xmlns:a16="http://schemas.microsoft.com/office/drawing/2014/main" id="{A05A08A8-1AF0-42AE-AF14-9EC8A41F36E3}"/>
+                <a16:creationId xmlns:a16="http://schemas.microsoft.com/office/drawing/2014/main" id="{007E3466-8C2F-4E4A-A16A-E49494B00C97}"/>
               </a:ext>
             </a:extLst>
           </p:cNvPr>
@@ -20213,7 +20213,7 @@
     </p:spTree>
     <p:extLst>
       <p:ext uri="{BB962C8B-B14F-4D97-AF65-F5344CB8AC3E}">
-        <p14:creationId xmlns:p14="http://schemas.microsoft.com/office/powerpoint/2010/main" val="792659985"/>
+        <p14:creationId xmlns:p14="http://schemas.microsoft.com/office/powerpoint/2010/main" val="543574622"/>
       </p:ext>
     </p:extLst>
   </p:cSld>
@@ -20244,7 +20244,7 @@
           <p:cNvPr id="17" name="">
             <a:extLst xmlns:a="http://schemas.openxmlformats.org/drawingml/2006/main">
               <a:ext uri="{FF2B5EF4-FFF2-40B4-BE49-F238E27FC236}">
-                <a16:creationId xmlns:a16="http://schemas.microsoft.com/office/drawing/2014/main" id="{9DB1F8C1-E6E3-4BD9-B3E5-6C9B4332C245}"/>
+                <a16:creationId xmlns:a16="http://schemas.microsoft.com/office/drawing/2014/main" id="{F47B40C1-AB5E-4853-8A26-84A5E48AC617}"/>
               </a:ext>
             </a:extLst>
           </p:cNvPr>
@@ -20407,7 +20407,7 @@
           <p:cNvPr id="2" name="">
             <a:extLst xmlns:a="http://schemas.openxmlformats.org/drawingml/2006/main">
               <a:ext uri="{FF2B5EF4-FFF2-40B4-BE49-F238E27FC236}">
-                <a16:creationId xmlns:a16="http://schemas.microsoft.com/office/drawing/2014/main" id="{C1448AC4-9EBB-485A-A418-40A542EB6812}"/>
+                <a16:creationId xmlns:a16="http://schemas.microsoft.com/office/drawing/2014/main" id="{A80AC147-D24C-4D7B-B506-32CCEFD3FCCD}"/>
               </a:ext>
             </a:extLst>
           </p:cNvPr>
@@ -20570,7 +20570,7 @@
           <p:cNvPr id="3" name="">
             <a:extLst xmlns:a="http://schemas.openxmlformats.org/drawingml/2006/main">
               <a:ext uri="{FF2B5EF4-FFF2-40B4-BE49-F238E27FC236}">
-                <a16:creationId xmlns:a16="http://schemas.microsoft.com/office/drawing/2014/main" id="{430974EF-E52F-492E-BC7C-B5F239B5ADB0}"/>
+                <a16:creationId xmlns:a16="http://schemas.microsoft.com/office/drawing/2014/main" id="{CEA72CA3-216D-4B26-8FE0-D436C4D1F9E3}"/>
               </a:ext>
             </a:extLst>
           </p:cNvPr>
@@ -20601,7 +20601,7 @@
           <p:cNvPr id="4" name="">
             <a:extLst xmlns:a="http://schemas.openxmlformats.org/drawingml/2006/main">
               <a:ext uri="{FF2B5EF4-FFF2-40B4-BE49-F238E27FC236}">
-                <a16:creationId xmlns:a16="http://schemas.microsoft.com/office/drawing/2014/main" id="{F457435B-7EC8-4F8D-8D90-D0EC589EB607}"/>
+                <a16:creationId xmlns:a16="http://schemas.microsoft.com/office/drawing/2014/main" id="{A79B68BA-38C5-4081-9974-9137AF42034A}"/>
               </a:ext>
             </a:extLst>
           </p:cNvPr>
@@ -20764,7 +20764,7 @@
           <p:cNvPr id="5" name="">
             <a:extLst xmlns:a="http://schemas.openxmlformats.org/drawingml/2006/main">
               <a:ext uri="{FF2B5EF4-FFF2-40B4-BE49-F238E27FC236}">
-                <a16:creationId xmlns:a16="http://schemas.microsoft.com/office/drawing/2014/main" id="{9E75EE3D-1752-472A-B228-9C5F9DD43DBF}"/>
+                <a16:creationId xmlns:a16="http://schemas.microsoft.com/office/drawing/2014/main" id="{29E4E6AA-A5D3-4DB7-B7D3-BD7CB00415F2}"/>
               </a:ext>
             </a:extLst>
           </p:cNvPr>
@@ -20927,7 +20927,7 @@
           <p:cNvPr id="6" name="">
             <a:extLst xmlns:a="http://schemas.openxmlformats.org/drawingml/2006/main">
               <a:ext uri="{FF2B5EF4-FFF2-40B4-BE49-F238E27FC236}">
-                <a16:creationId xmlns:a16="http://schemas.microsoft.com/office/drawing/2014/main" id="{666EB9ED-3E18-43D8-B010-B9AFF1A7407D}"/>
+                <a16:creationId xmlns:a16="http://schemas.microsoft.com/office/drawing/2014/main" id="{1237944C-4CC7-45E5-A4EE-943D3512C5AC}"/>
               </a:ext>
             </a:extLst>
           </p:cNvPr>
@@ -20958,7 +20958,7 @@
           <p:cNvPr id="7" name="">
             <a:extLst xmlns:a="http://schemas.openxmlformats.org/drawingml/2006/main">
               <a:ext uri="{FF2B5EF4-FFF2-40B4-BE49-F238E27FC236}">
-                <a16:creationId xmlns:a16="http://schemas.microsoft.com/office/drawing/2014/main" id="{BD1D0106-FEA3-4E3D-8A5D-6DCAACAD3E66}"/>
+                <a16:creationId xmlns:a16="http://schemas.microsoft.com/office/drawing/2014/main" id="{559344B2-A7BC-4630-BD28-6B4A26230B8B}"/>
               </a:ext>
             </a:extLst>
           </p:cNvPr>
@@ -21121,7 +21121,7 @@
           <p:cNvPr id="8" name="">
             <a:extLst xmlns:a="http://schemas.openxmlformats.org/drawingml/2006/main">
               <a:ext uri="{FF2B5EF4-FFF2-40B4-BE49-F238E27FC236}">
-                <a16:creationId xmlns:a16="http://schemas.microsoft.com/office/drawing/2014/main" id="{572D4E44-8B45-4393-ADF9-11DF721B0B41}"/>
+                <a16:creationId xmlns:a16="http://schemas.microsoft.com/office/drawing/2014/main" id="{271AB67C-D6A2-4E19-89C0-E230B6A6D34C}"/>
               </a:ext>
             </a:extLst>
           </p:cNvPr>
@@ -21284,7 +21284,7 @@
           <p:cNvPr id="9" name="">
             <a:extLst xmlns:a="http://schemas.openxmlformats.org/drawingml/2006/main">
               <a:ext uri="{FF2B5EF4-FFF2-40B4-BE49-F238E27FC236}">
-                <a16:creationId xmlns:a16="http://schemas.microsoft.com/office/drawing/2014/main" id="{069B8931-7741-412C-8D8F-3172F9BDB387}"/>
+                <a16:creationId xmlns:a16="http://schemas.microsoft.com/office/drawing/2014/main" id="{2AE17375-A620-4213-82EE-68A9994EC7C3}"/>
               </a:ext>
             </a:extLst>
           </p:cNvPr>
@@ -21315,7 +21315,7 @@
           <p:cNvPr id="10" name="">
             <a:extLst xmlns:a="http://schemas.openxmlformats.org/drawingml/2006/main">
               <a:ext uri="{FF2B5EF4-FFF2-40B4-BE49-F238E27FC236}">
-                <a16:creationId xmlns:a16="http://schemas.microsoft.com/office/drawing/2014/main" id="{902361F1-4C6B-44CB-BD70-B9101AF3BE62}"/>
+                <a16:creationId xmlns:a16="http://schemas.microsoft.com/office/drawing/2014/main" id="{A7E49999-F5A2-42C2-85A8-29758574CA40}"/>
               </a:ext>
             </a:extLst>
           </p:cNvPr>
@@ -21346,7 +21346,7 @@
           <p:cNvPr id="11" name="">
             <a:extLst xmlns:a="http://schemas.openxmlformats.org/drawingml/2006/main">
               <a:ext uri="{FF2B5EF4-FFF2-40B4-BE49-F238E27FC236}">
-                <a16:creationId xmlns:a16="http://schemas.microsoft.com/office/drawing/2014/main" id="{4AD0B1C0-DEF6-496E-9A41-2180C95C2D80}"/>
+                <a16:creationId xmlns:a16="http://schemas.microsoft.com/office/drawing/2014/main" id="{CD2C9566-A6FD-4CBE-867E-DFCF33AE0E98}"/>
               </a:ext>
             </a:extLst>
           </p:cNvPr>
@@ -21509,7 +21509,7 @@
           <p:cNvPr id="12" name="">
             <a:extLst xmlns:a="http://schemas.openxmlformats.org/drawingml/2006/main">
               <a:ext uri="{FF2B5EF4-FFF2-40B4-BE49-F238E27FC236}">
-                <a16:creationId xmlns:a16="http://schemas.microsoft.com/office/drawing/2014/main" id="{8A1B5E8F-4C9A-42E8-899A-4E2FEDCBD046}"/>
+                <a16:creationId xmlns:a16="http://schemas.microsoft.com/office/drawing/2014/main" id="{1EE29ABC-FD7D-40D4-9B94-541C9BDA7233}"/>
               </a:ext>
             </a:extLst>
           </p:cNvPr>
@@ -21672,7 +21672,7 @@
           <p:cNvPr id="13" name="">
             <a:extLst xmlns:a="http://schemas.openxmlformats.org/drawingml/2006/main">
               <a:ext uri="{FF2B5EF4-FFF2-40B4-BE49-F238E27FC236}">
-                <a16:creationId xmlns:a16="http://schemas.microsoft.com/office/drawing/2014/main" id="{56E3228D-202D-4781-8A38-7FE5050BF840}"/>
+                <a16:creationId xmlns:a16="http://schemas.microsoft.com/office/drawing/2014/main" id="{538F4E42-CFB8-4FCD-BAD0-02D2A4736556}"/>
               </a:ext>
             </a:extLst>
           </p:cNvPr>
@@ -21703,7 +21703,7 @@
           <p:cNvPr id="14" name="">
             <a:extLst xmlns:a="http://schemas.openxmlformats.org/drawingml/2006/main">
               <a:ext uri="{FF2B5EF4-FFF2-40B4-BE49-F238E27FC236}">
-                <a16:creationId xmlns:a16="http://schemas.microsoft.com/office/drawing/2014/main" id="{52B02E03-EB07-489C-986C-BFD5285EA840}"/>
+                <a16:creationId xmlns:a16="http://schemas.microsoft.com/office/drawing/2014/main" id="{0C986273-3301-4873-AD83-3049C10AA68E}"/>
               </a:ext>
             </a:extLst>
           </p:cNvPr>
@@ -21734,7 +21734,7 @@
           <p:cNvPr id="15" name="">
             <a:extLst xmlns:a="http://schemas.openxmlformats.org/drawingml/2006/main">
               <a:ext uri="{FF2B5EF4-FFF2-40B4-BE49-F238E27FC236}">
-                <a16:creationId xmlns:a16="http://schemas.microsoft.com/office/drawing/2014/main" id="{F1F69A82-85AF-41A5-9D3C-4CC111C2E3E1}"/>
+                <a16:creationId xmlns:a16="http://schemas.microsoft.com/office/drawing/2014/main" id="{1E466AF7-4175-45B5-8790-5E3702AC8D2E}"/>
               </a:ext>
             </a:extLst>
           </p:cNvPr>
@@ -21897,7 +21897,7 @@
           <p:cNvPr id="16" name="">
             <a:extLst xmlns:a="http://schemas.openxmlformats.org/drawingml/2006/main">
               <a:ext uri="{FF2B5EF4-FFF2-40B4-BE49-F238E27FC236}">
-                <a16:creationId xmlns:a16="http://schemas.microsoft.com/office/drawing/2014/main" id="{828CA547-819C-4BF6-B419-42B7AB1FCB3E}"/>
+                <a16:creationId xmlns:a16="http://schemas.microsoft.com/office/drawing/2014/main" id="{DC36D4F8-85E6-4F3D-A6A9-26530CB6BD1F}"/>
               </a:ext>
             </a:extLst>
           </p:cNvPr>
@@ -22058,7 +22058,7 @@
     </p:spTree>
     <p:extLst>
       <p:ext uri="{BB962C8B-B14F-4D97-AF65-F5344CB8AC3E}">
-        <p14:creationId xmlns:p14="http://schemas.microsoft.com/office/powerpoint/2010/main" val="267696106"/>
+        <p14:creationId xmlns:p14="http://schemas.microsoft.com/office/powerpoint/2010/main" val="157037588"/>
       </p:ext>
     </p:extLst>
   </p:cSld>
@@ -22089,7 +22089,7 @@
           <p:cNvPr id="17" name="">
             <a:extLst xmlns:a="http://schemas.openxmlformats.org/drawingml/2006/main">
               <a:ext uri="{FF2B5EF4-FFF2-40B4-BE49-F238E27FC236}">
-                <a16:creationId xmlns:a16="http://schemas.microsoft.com/office/drawing/2014/main" id="{008CB4DC-3CB1-408D-90E1-DA04812E295D}"/>
+                <a16:creationId xmlns:a16="http://schemas.microsoft.com/office/drawing/2014/main" id="{464A7485-80D2-4024-9E26-3E41346FA34C}"/>
               </a:ext>
             </a:extLst>
           </p:cNvPr>
@@ -22252,7 +22252,7 @@
           <p:cNvPr id="2" name="">
             <a:extLst xmlns:a="http://schemas.openxmlformats.org/drawingml/2006/main">
               <a:ext uri="{FF2B5EF4-FFF2-40B4-BE49-F238E27FC236}">
-                <a16:creationId xmlns:a16="http://schemas.microsoft.com/office/drawing/2014/main" id="{91BBA875-00D9-47C6-9334-AC77E66E5FC2}"/>
+                <a16:creationId xmlns:a16="http://schemas.microsoft.com/office/drawing/2014/main" id="{4085062D-BE44-4E6C-9A0D-FF1078EF43A9}"/>
               </a:ext>
             </a:extLst>
           </p:cNvPr>
@@ -22415,7 +22415,7 @@
           <p:cNvPr id="3" name="">
             <a:extLst xmlns:a="http://schemas.openxmlformats.org/drawingml/2006/main">
               <a:ext uri="{FF2B5EF4-FFF2-40B4-BE49-F238E27FC236}">
-                <a16:creationId xmlns:a16="http://schemas.microsoft.com/office/drawing/2014/main" id="{FEAD823D-028E-4168-8E06-605ED081E5B5}"/>
+                <a16:creationId xmlns:a16="http://schemas.microsoft.com/office/drawing/2014/main" id="{2C74E77F-8267-424C-A252-CF66585F6B72}"/>
               </a:ext>
             </a:extLst>
           </p:cNvPr>
@@ -22446,7 +22446,7 @@
           <p:cNvPr id="4" name="">
             <a:extLst xmlns:a="http://schemas.openxmlformats.org/drawingml/2006/main">
               <a:ext uri="{FF2B5EF4-FFF2-40B4-BE49-F238E27FC236}">
-                <a16:creationId xmlns:a16="http://schemas.microsoft.com/office/drawing/2014/main" id="{56B002B0-E53B-4FEE-9EC5-FF64BE0311CD}"/>
+                <a16:creationId xmlns:a16="http://schemas.microsoft.com/office/drawing/2014/main" id="{3E4A4002-FA18-4FA6-8CC6-2DF6443BDA43}"/>
               </a:ext>
             </a:extLst>
           </p:cNvPr>
@@ -22609,7 +22609,7 @@
           <p:cNvPr id="5" name="">
             <a:extLst xmlns:a="http://schemas.openxmlformats.org/drawingml/2006/main">
               <a:ext uri="{FF2B5EF4-FFF2-40B4-BE49-F238E27FC236}">
-                <a16:creationId xmlns:a16="http://schemas.microsoft.com/office/drawing/2014/main" id="{80EB6666-2778-4FAB-956F-2EDE54F5E8F1}"/>
+                <a16:creationId xmlns:a16="http://schemas.microsoft.com/office/drawing/2014/main" id="{2FC39254-3DE9-40C2-8360-194EC0487C18}"/>
               </a:ext>
             </a:extLst>
           </p:cNvPr>
@@ -22772,7 +22772,7 @@
           <p:cNvPr id="6" name="">
             <a:extLst xmlns:a="http://schemas.openxmlformats.org/drawingml/2006/main">
               <a:ext uri="{FF2B5EF4-FFF2-40B4-BE49-F238E27FC236}">
-                <a16:creationId xmlns:a16="http://schemas.microsoft.com/office/drawing/2014/main" id="{FAE144ED-AD9C-469D-84BD-10DA31D69CBE}"/>
+                <a16:creationId xmlns:a16="http://schemas.microsoft.com/office/drawing/2014/main" id="{90D5CA68-E1D5-4DBF-B77F-F4D51DD8AE87}"/>
               </a:ext>
             </a:extLst>
           </p:cNvPr>
@@ -22935,7 +22935,7 @@
           <p:cNvPr id="7" name="">
             <a:extLst xmlns:a="http://schemas.openxmlformats.org/drawingml/2006/main">
               <a:ext uri="{FF2B5EF4-FFF2-40B4-BE49-F238E27FC236}">
-                <a16:creationId xmlns:a16="http://schemas.microsoft.com/office/drawing/2014/main" id="{6E0688D3-FD87-485F-A1C8-B66911A5301D}"/>
+                <a16:creationId xmlns:a16="http://schemas.microsoft.com/office/drawing/2014/main" id="{41019033-040E-4B04-B564-66410BD00F20}"/>
               </a:ext>
             </a:extLst>
           </p:cNvPr>
@@ -22966,7 +22966,7 @@
           <p:cNvPr id="8" name="">
             <a:extLst xmlns:a="http://schemas.openxmlformats.org/drawingml/2006/main">
               <a:ext uri="{FF2B5EF4-FFF2-40B4-BE49-F238E27FC236}">
-                <a16:creationId xmlns:a16="http://schemas.microsoft.com/office/drawing/2014/main" id="{2FA83674-E17F-42BD-B3B0-CBBB65068AC5}"/>
+                <a16:creationId xmlns:a16="http://schemas.microsoft.com/office/drawing/2014/main" id="{E128D29B-2F55-4F75-BCAA-5DBB79EC9CF4}"/>
               </a:ext>
             </a:extLst>
           </p:cNvPr>
@@ -23156,7 +23156,7 @@
           <p:cNvPr id="9" name="">
             <a:extLst xmlns:a="http://schemas.openxmlformats.org/drawingml/2006/main">
               <a:ext uri="{FF2B5EF4-FFF2-40B4-BE49-F238E27FC236}">
-                <a16:creationId xmlns:a16="http://schemas.microsoft.com/office/drawing/2014/main" id="{94C1DC3C-5EB6-4EDF-ACA8-B15D931A46AD}"/>
+                <a16:creationId xmlns:a16="http://schemas.microsoft.com/office/drawing/2014/main" id="{82D3080E-04B1-4571-A566-0B9D5EAFEBA8}"/>
               </a:ext>
             </a:extLst>
           </p:cNvPr>
@@ -23319,7 +23319,7 @@
           <p:cNvPr id="10" name="">
             <a:extLst xmlns:a="http://schemas.openxmlformats.org/drawingml/2006/main">
               <a:ext uri="{FF2B5EF4-FFF2-40B4-BE49-F238E27FC236}">
-                <a16:creationId xmlns:a16="http://schemas.microsoft.com/office/drawing/2014/main" id="{45433F08-EB9D-41CE-AD24-1736B7C6EB13}"/>
+                <a16:creationId xmlns:a16="http://schemas.microsoft.com/office/drawing/2014/main" id="{811FBEE7-A134-4B8B-BD01-A47A1AD9993A}"/>
               </a:ext>
             </a:extLst>
           </p:cNvPr>
@@ -23350,7 +23350,7 @@
           <p:cNvPr id="11" name="">
             <a:extLst xmlns:a="http://schemas.openxmlformats.org/drawingml/2006/main">
               <a:ext uri="{FF2B5EF4-FFF2-40B4-BE49-F238E27FC236}">
-                <a16:creationId xmlns:a16="http://schemas.microsoft.com/office/drawing/2014/main" id="{4064CA3E-BE2E-4CFA-896B-6F8D19F78ED6}"/>
+                <a16:creationId xmlns:a16="http://schemas.microsoft.com/office/drawing/2014/main" id="{7CC25F5D-1FCF-4B41-95DE-A5A750FBA80F}"/>
               </a:ext>
             </a:extLst>
           </p:cNvPr>
@@ -23540,7 +23540,7 @@
           <p:cNvPr id="12" name="">
             <a:extLst xmlns:a="http://schemas.openxmlformats.org/drawingml/2006/main">
               <a:ext uri="{FF2B5EF4-FFF2-40B4-BE49-F238E27FC236}">
-                <a16:creationId xmlns:a16="http://schemas.microsoft.com/office/drawing/2014/main" id="{64A6F1CE-1244-45FE-8F54-438EA9899604}"/>
+                <a16:creationId xmlns:a16="http://schemas.microsoft.com/office/drawing/2014/main" id="{857F23DF-62A6-4643-B817-F62AF0227AC7}"/>
               </a:ext>
             </a:extLst>
           </p:cNvPr>
@@ -23703,7 +23703,7 @@
           <p:cNvPr id="13" name="">
             <a:extLst xmlns:a="http://schemas.openxmlformats.org/drawingml/2006/main">
               <a:ext uri="{FF2B5EF4-FFF2-40B4-BE49-F238E27FC236}">
-                <a16:creationId xmlns:a16="http://schemas.microsoft.com/office/drawing/2014/main" id="{06AE634C-E9FF-4B07-8437-A00CEBB4B557}"/>
+                <a16:creationId xmlns:a16="http://schemas.microsoft.com/office/drawing/2014/main" id="{8E7AFBF4-C70B-4BB5-A031-89CB7C0E54F0}"/>
               </a:ext>
             </a:extLst>
           </p:cNvPr>
@@ -23734,7 +23734,7 @@
           <p:cNvPr id="14" name="">
             <a:extLst xmlns:a="http://schemas.openxmlformats.org/drawingml/2006/main">
               <a:ext uri="{FF2B5EF4-FFF2-40B4-BE49-F238E27FC236}">
-                <a16:creationId xmlns:a16="http://schemas.microsoft.com/office/drawing/2014/main" id="{E27A15FC-CCAC-4D5B-8448-733F7EB2BE4D}"/>
+                <a16:creationId xmlns:a16="http://schemas.microsoft.com/office/drawing/2014/main" id="{9A0C5F3B-EF99-4EE7-BE7D-DCEC32684983}"/>
               </a:ext>
             </a:extLst>
           </p:cNvPr>
@@ -23924,7 +23924,7 @@
           <p:cNvPr id="15" name="">
             <a:extLst xmlns:a="http://schemas.openxmlformats.org/drawingml/2006/main">
               <a:ext uri="{FF2B5EF4-FFF2-40B4-BE49-F238E27FC236}">
-                <a16:creationId xmlns:a16="http://schemas.microsoft.com/office/drawing/2014/main" id="{24F920FA-EC76-4455-A618-FAE5E7609026}"/>
+                <a16:creationId xmlns:a16="http://schemas.microsoft.com/office/drawing/2014/main" id="{264BACF8-C6F7-42D4-8287-B64A94F756D4}"/>
               </a:ext>
             </a:extLst>
           </p:cNvPr>
@@ -23957,7 +23957,7 @@
           <p:cNvPr id="16" name="">
             <a:extLst xmlns:a="http://schemas.openxmlformats.org/drawingml/2006/main">
               <a:ext uri="{FF2B5EF4-FFF2-40B4-BE49-F238E27FC236}">
-                <a16:creationId xmlns:a16="http://schemas.microsoft.com/office/drawing/2014/main" id="{1975A2F2-FD10-41C9-A12A-FBFC93F24D68}"/>
+                <a16:creationId xmlns:a16="http://schemas.microsoft.com/office/drawing/2014/main" id="{AFB7D795-F87A-4A2B-A00C-AA6C6FD3E5DD}"/>
               </a:ext>
             </a:extLst>
           </p:cNvPr>
@@ -24118,7 +24118,7 @@
     </p:spTree>
     <p:extLst>
       <p:ext uri="{BB962C8B-B14F-4D97-AF65-F5344CB8AC3E}">
-        <p14:creationId xmlns:p14="http://schemas.microsoft.com/office/powerpoint/2010/main" val="673830161"/>
+        <p14:creationId xmlns:p14="http://schemas.microsoft.com/office/powerpoint/2010/main" val="790206475"/>
       </p:ext>
     </p:extLst>
   </p:cSld>
@@ -24149,7 +24149,7 @@
           <p:cNvPr id="25" name="">
             <a:extLst xmlns:a="http://schemas.openxmlformats.org/drawingml/2006/main">
               <a:ext uri="{FF2B5EF4-FFF2-40B4-BE49-F238E27FC236}">
-                <a16:creationId xmlns:a16="http://schemas.microsoft.com/office/drawing/2014/main" id="{EC9E22B6-93DF-4C7A-B395-4596DE945AEA}"/>
+                <a16:creationId xmlns:a16="http://schemas.microsoft.com/office/drawing/2014/main" id="{739FB2F6-16BD-40B3-928D-0852BA59BA77}"/>
               </a:ext>
             </a:extLst>
           </p:cNvPr>
@@ -24312,7 +24312,7 @@
           <p:cNvPr id="2" name="">
             <a:extLst xmlns:a="http://schemas.openxmlformats.org/drawingml/2006/main">
               <a:ext uri="{FF2B5EF4-FFF2-40B4-BE49-F238E27FC236}">
-                <a16:creationId xmlns:a16="http://schemas.microsoft.com/office/drawing/2014/main" id="{BE8FA6D3-47A2-4FBC-A092-5F096B1652BB}"/>
+                <a16:creationId xmlns:a16="http://schemas.microsoft.com/office/drawing/2014/main" id="{CBFBF7C2-FD31-4781-A116-528229646CE4}"/>
               </a:ext>
             </a:extLst>
           </p:cNvPr>
@@ -24475,7 +24475,7 @@
           <p:cNvPr id="3" name="">
             <a:extLst xmlns:a="http://schemas.openxmlformats.org/drawingml/2006/main">
               <a:ext uri="{FF2B5EF4-FFF2-40B4-BE49-F238E27FC236}">
-                <a16:creationId xmlns:a16="http://schemas.microsoft.com/office/drawing/2014/main" id="{D25933B1-F66D-4887-9BE1-902C27A98341}"/>
+                <a16:creationId xmlns:a16="http://schemas.microsoft.com/office/drawing/2014/main" id="{EA9E4E2E-9B27-4905-8D61-62EF0983AD2B}"/>
               </a:ext>
             </a:extLst>
           </p:cNvPr>
@@ -24506,7 +24506,7 @@
           <p:cNvPr id="4" name="">
             <a:extLst xmlns:a="http://schemas.openxmlformats.org/drawingml/2006/main">
               <a:ext uri="{FF2B5EF4-FFF2-40B4-BE49-F238E27FC236}">
-                <a16:creationId xmlns:a16="http://schemas.microsoft.com/office/drawing/2014/main" id="{A059D910-3E52-460F-A7E8-45870183EDD9}"/>
+                <a16:creationId xmlns:a16="http://schemas.microsoft.com/office/drawing/2014/main" id="{CD1115C2-A79D-4090-B432-11A93CB74BDD}"/>
               </a:ext>
             </a:extLst>
           </p:cNvPr>
@@ -24669,7 +24669,7 @@
           <p:cNvPr id="5" name="">
             <a:extLst xmlns:a="http://schemas.openxmlformats.org/drawingml/2006/main">
               <a:ext uri="{FF2B5EF4-FFF2-40B4-BE49-F238E27FC236}">
-                <a16:creationId xmlns:a16="http://schemas.microsoft.com/office/drawing/2014/main" id="{D0B2DC55-2628-431E-A1EA-899FB06E9430}"/>
+                <a16:creationId xmlns:a16="http://schemas.microsoft.com/office/drawing/2014/main" id="{2DF1A8B0-BF4D-4C05-9938-32C71ED141E6}"/>
               </a:ext>
             </a:extLst>
           </p:cNvPr>
@@ -24832,7 +24832,7 @@
           <p:cNvPr id="6" name="">
             <a:extLst xmlns:a="http://schemas.openxmlformats.org/drawingml/2006/main">
               <a:ext uri="{FF2B5EF4-FFF2-40B4-BE49-F238E27FC236}">
-                <a16:creationId xmlns:a16="http://schemas.microsoft.com/office/drawing/2014/main" id="{5EFC622D-A743-43C3-AFED-6B0588590ECC}"/>
+                <a16:creationId xmlns:a16="http://schemas.microsoft.com/office/drawing/2014/main" id="{828BE78F-7AE4-4CCB-B164-5AB848E44BF9}"/>
               </a:ext>
             </a:extLst>
           </p:cNvPr>
@@ -24867,7 +24867,7 @@
           <p:cNvPr id="7" name="">
             <a:extLst xmlns:a="http://schemas.openxmlformats.org/drawingml/2006/main">
               <a:ext uri="{FF2B5EF4-FFF2-40B4-BE49-F238E27FC236}">
-                <a16:creationId xmlns:a16="http://schemas.microsoft.com/office/drawing/2014/main" id="{626879E4-7B0A-4C37-A2B0-777DA9E655A3}"/>
+                <a16:creationId xmlns:a16="http://schemas.microsoft.com/office/drawing/2014/main" id="{56A19288-C0FB-4B3D-8900-5B9094D4975C}"/>
               </a:ext>
             </a:extLst>
           </p:cNvPr>
@@ -25057,7 +25057,7 @@
           <p:cNvPr id="8" name="">
             <a:extLst xmlns:a="http://schemas.openxmlformats.org/drawingml/2006/main">
               <a:ext uri="{FF2B5EF4-FFF2-40B4-BE49-F238E27FC236}">
-                <a16:creationId xmlns:a16="http://schemas.microsoft.com/office/drawing/2014/main" id="{A21F20B2-E332-4D90-80DD-82E02B07CB5B}"/>
+                <a16:creationId xmlns:a16="http://schemas.microsoft.com/office/drawing/2014/main" id="{662DA132-625A-4104-9ACE-7EA63073D73F}"/>
               </a:ext>
             </a:extLst>
           </p:cNvPr>
@@ -25092,7 +25092,7 @@
           <p:cNvPr id="9" name="">
             <a:extLst xmlns:a="http://schemas.openxmlformats.org/drawingml/2006/main">
               <a:ext uri="{FF2B5EF4-FFF2-40B4-BE49-F238E27FC236}">
-                <a16:creationId xmlns:a16="http://schemas.microsoft.com/office/drawing/2014/main" id="{FE1340E5-A6B9-4883-A6A0-FB24ACE13DF2}"/>
+                <a16:creationId xmlns:a16="http://schemas.microsoft.com/office/drawing/2014/main" id="{57487CD7-5DCE-4ACA-AB9D-5A019C6F600C}"/>
               </a:ext>
             </a:extLst>
           </p:cNvPr>
@@ -25282,7 +25282,7 @@
           <p:cNvPr id="10" name="">
             <a:extLst xmlns:a="http://schemas.openxmlformats.org/drawingml/2006/main">
               <a:ext uri="{FF2B5EF4-FFF2-40B4-BE49-F238E27FC236}">
-                <a16:creationId xmlns:a16="http://schemas.microsoft.com/office/drawing/2014/main" id="{A8770766-9527-4469-BE0A-509985720125}"/>
+                <a16:creationId xmlns:a16="http://schemas.microsoft.com/office/drawing/2014/main" id="{AFDE15A9-15C8-4959-AB24-960F7DD21630}"/>
               </a:ext>
             </a:extLst>
           </p:cNvPr>
@@ -25317,7 +25317,7 @@
           <p:cNvPr id="11" name="">
             <a:extLst xmlns:a="http://schemas.openxmlformats.org/drawingml/2006/main">
               <a:ext uri="{FF2B5EF4-FFF2-40B4-BE49-F238E27FC236}">
-                <a16:creationId xmlns:a16="http://schemas.microsoft.com/office/drawing/2014/main" id="{02E8A89B-13C1-4C1E-8661-A6B76C3A6828}"/>
+                <a16:creationId xmlns:a16="http://schemas.microsoft.com/office/drawing/2014/main" id="{619EB808-8A33-4F99-AF6F-CEBE76579032}"/>
               </a:ext>
             </a:extLst>
           </p:cNvPr>
@@ -25507,7 +25507,7 @@
           <p:cNvPr id="12" name="">
             <a:extLst xmlns:a="http://schemas.openxmlformats.org/drawingml/2006/main">
               <a:ext uri="{FF2B5EF4-FFF2-40B4-BE49-F238E27FC236}">
-                <a16:creationId xmlns:a16="http://schemas.microsoft.com/office/drawing/2014/main" id="{4094DB5A-6158-4640-9CE6-7C3A8BDCA029}"/>
+                <a16:creationId xmlns:a16="http://schemas.microsoft.com/office/drawing/2014/main" id="{A8935822-9BC7-426C-9AA4-BBBDF46D2E80}"/>
               </a:ext>
             </a:extLst>
           </p:cNvPr>
@@ -25542,7 +25542,7 @@
           <p:cNvPr id="13" name="">
             <a:extLst xmlns:a="http://schemas.openxmlformats.org/drawingml/2006/main">
               <a:ext uri="{FF2B5EF4-FFF2-40B4-BE49-F238E27FC236}">
-                <a16:creationId xmlns:a16="http://schemas.microsoft.com/office/drawing/2014/main" id="{A195F36B-BDD9-46A8-A47A-9CF77CE36613}"/>
+                <a16:creationId xmlns:a16="http://schemas.microsoft.com/office/drawing/2014/main" id="{352E21BB-3023-4F27-B3D0-1D2D1F66B8D3}"/>
               </a:ext>
             </a:extLst>
           </p:cNvPr>
@@ -25732,7 +25732,7 @@
           <p:cNvPr id="14" name="">
             <a:extLst xmlns:a="http://schemas.openxmlformats.org/drawingml/2006/main">
               <a:ext uri="{FF2B5EF4-FFF2-40B4-BE49-F238E27FC236}">
-                <a16:creationId xmlns:a16="http://schemas.microsoft.com/office/drawing/2014/main" id="{48677E60-64EA-4C2E-9DC6-4DF0B1033B99}"/>
+                <a16:creationId xmlns:a16="http://schemas.microsoft.com/office/drawing/2014/main" id="{06FDE7CD-91A3-44A2-8FFF-107C6116297B}"/>
               </a:ext>
             </a:extLst>
           </p:cNvPr>
@@ -25763,7 +25763,7 @@
           <p:cNvPr id="15" name="">
             <a:extLst xmlns:a="http://schemas.openxmlformats.org/drawingml/2006/main">
               <a:ext uri="{FF2B5EF4-FFF2-40B4-BE49-F238E27FC236}">
-                <a16:creationId xmlns:a16="http://schemas.microsoft.com/office/drawing/2014/main" id="{E647C2EA-EFF0-4A3A-9E60-507FD079B16B}"/>
+                <a16:creationId xmlns:a16="http://schemas.microsoft.com/office/drawing/2014/main" id="{42CDC1CC-2DAF-43FB-8D49-3ABFF69B5ABC}"/>
               </a:ext>
             </a:extLst>
           </p:cNvPr>
@@ -25794,7 +25794,7 @@
           <p:cNvPr id="16" name="">
             <a:extLst xmlns:a="http://schemas.openxmlformats.org/drawingml/2006/main">
               <a:ext uri="{FF2B5EF4-FFF2-40B4-BE49-F238E27FC236}">
-                <a16:creationId xmlns:a16="http://schemas.microsoft.com/office/drawing/2014/main" id="{5D08326C-FA24-4195-9538-2992AAF90DC8}"/>
+                <a16:creationId xmlns:a16="http://schemas.microsoft.com/office/drawing/2014/main" id="{FEAA56B4-9133-4772-89EC-7B68B31F700C}"/>
               </a:ext>
             </a:extLst>
           </p:cNvPr>
@@ -25825,7 +25825,7 @@
           <p:cNvPr id="17" name="">
             <a:extLst xmlns:a="http://schemas.openxmlformats.org/drawingml/2006/main">
               <a:ext uri="{FF2B5EF4-FFF2-40B4-BE49-F238E27FC236}">
-                <a16:creationId xmlns:a16="http://schemas.microsoft.com/office/drawing/2014/main" id="{08F488D2-3420-4D12-B4B7-8ABBF7B0C135}"/>
+                <a16:creationId xmlns:a16="http://schemas.microsoft.com/office/drawing/2014/main" id="{9DC788D8-84F8-4B8B-92E6-0C0E176DDF1C}"/>
               </a:ext>
             </a:extLst>
           </p:cNvPr>
@@ -25856,7 +25856,7 @@
           <p:cNvPr id="18" name="">
             <a:extLst xmlns:a="http://schemas.openxmlformats.org/drawingml/2006/main">
               <a:ext uri="{FF2B5EF4-FFF2-40B4-BE49-F238E27FC236}">
-                <a16:creationId xmlns:a16="http://schemas.microsoft.com/office/drawing/2014/main" id="{391EE782-347C-4466-A6A6-17BAE0A33969}"/>
+                <a16:creationId xmlns:a16="http://schemas.microsoft.com/office/drawing/2014/main" id="{5AF41C71-3103-4A9F-8D49-874E46E68C14}"/>
               </a:ext>
             </a:extLst>
           </p:cNvPr>
@@ -25887,7 +25887,7 @@
           <p:cNvPr id="19" name="">
             <a:extLst xmlns:a="http://schemas.openxmlformats.org/drawingml/2006/main">
               <a:ext uri="{FF2B5EF4-FFF2-40B4-BE49-F238E27FC236}">
-                <a16:creationId xmlns:a16="http://schemas.microsoft.com/office/drawing/2014/main" id="{8E6C19E2-D9DF-447B-96D2-86F79D9DE82C}"/>
+                <a16:creationId xmlns:a16="http://schemas.microsoft.com/office/drawing/2014/main" id="{80D8D4B9-80A4-4D71-8788-D66425367428}"/>
               </a:ext>
             </a:extLst>
           </p:cNvPr>
@@ -25918,7 +25918,7 @@
           <p:cNvPr id="20" name="">
             <a:extLst xmlns:a="http://schemas.openxmlformats.org/drawingml/2006/main">
               <a:ext uri="{FF2B5EF4-FFF2-40B4-BE49-F238E27FC236}">
-                <a16:creationId xmlns:a16="http://schemas.microsoft.com/office/drawing/2014/main" id="{CB569062-CF24-41EC-86C2-076B9A13AEDD}"/>
+                <a16:creationId xmlns:a16="http://schemas.microsoft.com/office/drawing/2014/main" id="{033060EC-ADCD-44ED-9279-1613D236F97A}"/>
               </a:ext>
             </a:extLst>
           </p:cNvPr>
@@ -25949,7 +25949,7 @@
           <p:cNvPr id="21" name="">
             <a:extLst xmlns:a="http://schemas.openxmlformats.org/drawingml/2006/main">
               <a:ext uri="{FF2B5EF4-FFF2-40B4-BE49-F238E27FC236}">
-                <a16:creationId xmlns:a16="http://schemas.microsoft.com/office/drawing/2014/main" id="{9B215B82-768D-466A-8716-8A235CB5D1E3}"/>
+                <a16:creationId xmlns:a16="http://schemas.microsoft.com/office/drawing/2014/main" id="{EE27C839-C23B-40F4-AF3E-DD59B54EF541}"/>
               </a:ext>
             </a:extLst>
           </p:cNvPr>
@@ -25980,7 +25980,7 @@
           <p:cNvPr id="22" name="">
             <a:extLst xmlns:a="http://schemas.openxmlformats.org/drawingml/2006/main">
               <a:ext uri="{FF2B5EF4-FFF2-40B4-BE49-F238E27FC236}">
-                <a16:creationId xmlns:a16="http://schemas.microsoft.com/office/drawing/2014/main" id="{5080A62E-31AD-45E6-B2FD-02A661A748C6}"/>
+                <a16:creationId xmlns:a16="http://schemas.microsoft.com/office/drawing/2014/main" id="{710C5790-62E5-417E-8BE7-AD42DC88E716}"/>
               </a:ext>
             </a:extLst>
           </p:cNvPr>
@@ -26143,7 +26143,7 @@
           <p:cNvPr id="23" name="">
             <a:extLst xmlns:a="http://schemas.openxmlformats.org/drawingml/2006/main">
               <a:ext uri="{FF2B5EF4-FFF2-40B4-BE49-F238E27FC236}">
-                <a16:creationId xmlns:a16="http://schemas.microsoft.com/office/drawing/2014/main" id="{CB701C98-7B9C-4C0F-99F3-C7B617DFE88F}"/>
+                <a16:creationId xmlns:a16="http://schemas.microsoft.com/office/drawing/2014/main" id="{4C39F60D-7BB6-421B-B602-C4ADD544400B}"/>
               </a:ext>
             </a:extLst>
           </p:cNvPr>
@@ -26306,7 +26306,7 @@
           <p:cNvPr id="24" name="">
             <a:extLst xmlns:a="http://schemas.openxmlformats.org/drawingml/2006/main">
               <a:ext uri="{FF2B5EF4-FFF2-40B4-BE49-F238E27FC236}">
-                <a16:creationId xmlns:a16="http://schemas.microsoft.com/office/drawing/2014/main" id="{F6EED8D5-0269-41D3-BE83-C9867472AB0E}"/>
+                <a16:creationId xmlns:a16="http://schemas.microsoft.com/office/drawing/2014/main" id="{4C224A35-E5AB-47C4-A36C-EB7CFE0190C3}"/>
               </a:ext>
             </a:extLst>
           </p:cNvPr>
@@ -26467,7 +26467,7 @@
     </p:spTree>
     <p:extLst>
       <p:ext uri="{BB962C8B-B14F-4D97-AF65-F5344CB8AC3E}">
-        <p14:creationId xmlns:p14="http://schemas.microsoft.com/office/powerpoint/2010/main" val="1579842291"/>
+        <p14:creationId xmlns:p14="http://schemas.microsoft.com/office/powerpoint/2010/main" val="1478300668"/>
       </p:ext>
     </p:extLst>
   </p:cSld>
@@ -26498,7 +26498,7 @@
           <p:cNvPr id="22" name="">
             <a:extLst xmlns:a="http://schemas.openxmlformats.org/drawingml/2006/main">
               <a:ext uri="{FF2B5EF4-FFF2-40B4-BE49-F238E27FC236}">
-                <a16:creationId xmlns:a16="http://schemas.microsoft.com/office/drawing/2014/main" id="{161E409D-4D45-4540-88E6-D02BAFC01BFF}"/>
+                <a16:creationId xmlns:a16="http://schemas.microsoft.com/office/drawing/2014/main" id="{C7A820E9-ECE2-4445-8862-7C693F94738D}"/>
               </a:ext>
             </a:extLst>
           </p:cNvPr>
@@ -26661,7 +26661,7 @@
           <p:cNvPr id="2" name="">
             <a:extLst xmlns:a="http://schemas.openxmlformats.org/drawingml/2006/main">
               <a:ext uri="{FF2B5EF4-FFF2-40B4-BE49-F238E27FC236}">
-                <a16:creationId xmlns:a16="http://schemas.microsoft.com/office/drawing/2014/main" id="{B005A17E-948A-464D-83E9-4CC72B0EFF93}"/>
+                <a16:creationId xmlns:a16="http://schemas.microsoft.com/office/drawing/2014/main" id="{E4684101-26BF-45DB-9150-D62721D40530}"/>
               </a:ext>
             </a:extLst>
           </p:cNvPr>
@@ -26824,7 +26824,7 @@
           <p:cNvPr id="3" name="">
             <a:extLst xmlns:a="http://schemas.openxmlformats.org/drawingml/2006/main">
               <a:ext uri="{FF2B5EF4-FFF2-40B4-BE49-F238E27FC236}">
-                <a16:creationId xmlns:a16="http://schemas.microsoft.com/office/drawing/2014/main" id="{384F09E1-98E5-4A5A-AAF3-CD161299A6C1}"/>
+                <a16:creationId xmlns:a16="http://schemas.microsoft.com/office/drawing/2014/main" id="{0E24433B-4882-42B9-8E22-74F212065831}"/>
               </a:ext>
             </a:extLst>
           </p:cNvPr>
@@ -26855,7 +26855,7 @@
           <p:cNvPr id="4" name="">
             <a:extLst xmlns:a="http://schemas.openxmlformats.org/drawingml/2006/main">
               <a:ext uri="{FF2B5EF4-FFF2-40B4-BE49-F238E27FC236}">
-                <a16:creationId xmlns:a16="http://schemas.microsoft.com/office/drawing/2014/main" id="{15FC28DB-4E5F-43EE-B1C6-7612C189E2C2}"/>
+                <a16:creationId xmlns:a16="http://schemas.microsoft.com/office/drawing/2014/main" id="{4AF389CC-2604-4A26-8CA6-14277126C670}"/>
               </a:ext>
             </a:extLst>
           </p:cNvPr>
@@ -27018,7 +27018,7 @@
           <p:cNvPr id="5" name="">
             <a:extLst xmlns:a="http://schemas.openxmlformats.org/drawingml/2006/main">
               <a:ext uri="{FF2B5EF4-FFF2-40B4-BE49-F238E27FC236}">
-                <a16:creationId xmlns:a16="http://schemas.microsoft.com/office/drawing/2014/main" id="{3F51CAC0-38D2-49A4-A4E7-5F5557D081CA}"/>
+                <a16:creationId xmlns:a16="http://schemas.microsoft.com/office/drawing/2014/main" id="{3FEDA16A-45BA-4CE6-A1F8-FFE8BF7BFC18}"/>
               </a:ext>
             </a:extLst>
           </p:cNvPr>
@@ -27181,7 +27181,7 @@
           <p:cNvPr id="6" name="">
             <a:extLst xmlns:a="http://schemas.openxmlformats.org/drawingml/2006/main">
               <a:ext uri="{FF2B5EF4-FFF2-40B4-BE49-F238E27FC236}">
-                <a16:creationId xmlns:a16="http://schemas.microsoft.com/office/drawing/2014/main" id="{5226D44D-431E-40BF-8E73-26F40899098F}"/>
+                <a16:creationId xmlns:a16="http://schemas.microsoft.com/office/drawing/2014/main" id="{03C4BBFD-45B3-4F40-B57E-6CD83D974414}"/>
               </a:ext>
             </a:extLst>
           </p:cNvPr>
@@ -27216,7 +27216,7 @@
           <p:cNvPr id="7" name="">
             <a:extLst xmlns:a="http://schemas.openxmlformats.org/drawingml/2006/main">
               <a:ext uri="{FF2B5EF4-FFF2-40B4-BE49-F238E27FC236}">
-                <a16:creationId xmlns:a16="http://schemas.microsoft.com/office/drawing/2014/main" id="{041C114D-F85B-4E10-AF7C-43B3A5C810C2}"/>
+                <a16:creationId xmlns:a16="http://schemas.microsoft.com/office/drawing/2014/main" id="{3866BB51-1C58-4ABC-9DA4-120EF546B5D9}"/>
               </a:ext>
             </a:extLst>
           </p:cNvPr>
@@ -27379,7 +27379,7 @@
           <p:cNvPr id="8" name="">
             <a:extLst xmlns:a="http://schemas.openxmlformats.org/drawingml/2006/main">
               <a:ext uri="{FF2B5EF4-FFF2-40B4-BE49-F238E27FC236}">
-                <a16:creationId xmlns:a16="http://schemas.microsoft.com/office/drawing/2014/main" id="{A1003DF6-BC37-497E-A775-F0B891064E84}"/>
+                <a16:creationId xmlns:a16="http://schemas.microsoft.com/office/drawing/2014/main" id="{FA5AA2FC-9BC9-4B59-8903-EF9DBAB32F37}"/>
               </a:ext>
             </a:extLst>
           </p:cNvPr>
@@ -27414,7 +27414,7 @@
           <p:cNvPr id="9" name="">
             <a:extLst xmlns:a="http://schemas.openxmlformats.org/drawingml/2006/main">
               <a:ext uri="{FF2B5EF4-FFF2-40B4-BE49-F238E27FC236}">
-                <a16:creationId xmlns:a16="http://schemas.microsoft.com/office/drawing/2014/main" id="{9FD7D6F3-4943-42A1-8D7B-B9FF54D7DE99}"/>
+                <a16:creationId xmlns:a16="http://schemas.microsoft.com/office/drawing/2014/main" id="{B93C0034-83EE-4F79-9F7C-46B3F5303611}"/>
               </a:ext>
             </a:extLst>
           </p:cNvPr>
@@ -27577,7 +27577,7 @@
           <p:cNvPr id="10" name="">
             <a:extLst xmlns:a="http://schemas.openxmlformats.org/drawingml/2006/main">
               <a:ext uri="{FF2B5EF4-FFF2-40B4-BE49-F238E27FC236}">
-                <a16:creationId xmlns:a16="http://schemas.microsoft.com/office/drawing/2014/main" id="{44B7F7A1-1CC6-41F2-B7F2-1FA9F57105A9}"/>
+                <a16:creationId xmlns:a16="http://schemas.microsoft.com/office/drawing/2014/main" id="{0DE8CE8A-10E3-451F-A8B7-7184772DEB66}"/>
               </a:ext>
             </a:extLst>
           </p:cNvPr>
@@ -27612,7 +27612,7 @@
           <p:cNvPr id="11" name="">
             <a:extLst xmlns:a="http://schemas.openxmlformats.org/drawingml/2006/main">
               <a:ext uri="{FF2B5EF4-FFF2-40B4-BE49-F238E27FC236}">
-                <a16:creationId xmlns:a16="http://schemas.microsoft.com/office/drawing/2014/main" id="{0F504C1D-C0C1-4278-AE73-4CFB8A1E1CCE}"/>
+                <a16:creationId xmlns:a16="http://schemas.microsoft.com/office/drawing/2014/main" id="{9DACEAD8-AA5B-451A-A540-A918A99C2493}"/>
               </a:ext>
             </a:extLst>
           </p:cNvPr>
@@ -27775,7 +27775,7 @@
           <p:cNvPr id="12" name="">
             <a:extLst xmlns:a="http://schemas.openxmlformats.org/drawingml/2006/main">
               <a:ext uri="{FF2B5EF4-FFF2-40B4-BE49-F238E27FC236}">
-                <a16:creationId xmlns:a16="http://schemas.microsoft.com/office/drawing/2014/main" id="{53C3F52F-5F13-416B-BCFA-00FF40C8E246}"/>
+                <a16:creationId xmlns:a16="http://schemas.microsoft.com/office/drawing/2014/main" id="{E3785897-BC48-47A9-839A-21F3D66F7091}"/>
               </a:ext>
             </a:extLst>
           </p:cNvPr>
@@ -27806,7 +27806,7 @@
           <p:cNvPr id="13" name="">
             <a:extLst xmlns:a="http://schemas.openxmlformats.org/drawingml/2006/main">
               <a:ext uri="{FF2B5EF4-FFF2-40B4-BE49-F238E27FC236}">
-                <a16:creationId xmlns:a16="http://schemas.microsoft.com/office/drawing/2014/main" id="{00A0857D-B64A-4BDC-96FC-B05E161CE5D2}"/>
+                <a16:creationId xmlns:a16="http://schemas.microsoft.com/office/drawing/2014/main" id="{CE303933-69EB-4746-B85A-23F2CFBCDE40}"/>
               </a:ext>
             </a:extLst>
           </p:cNvPr>
@@ -27837,7 +27837,7 @@
           <p:cNvPr id="14" name="">
             <a:extLst xmlns:a="http://schemas.openxmlformats.org/drawingml/2006/main">
               <a:ext uri="{FF2B5EF4-FFF2-40B4-BE49-F238E27FC236}">
-                <a16:creationId xmlns:a16="http://schemas.microsoft.com/office/drawing/2014/main" id="{BC0DE26E-7046-4889-9F7F-6336474ACE2B}"/>
+                <a16:creationId xmlns:a16="http://schemas.microsoft.com/office/drawing/2014/main" id="{D267FE6C-5A76-4A5C-BFE5-32E6E54A3B41}"/>
               </a:ext>
             </a:extLst>
           </p:cNvPr>
@@ -27872,7 +27872,7 @@
           <p:cNvPr id="15" name="">
             <a:extLst xmlns:a="http://schemas.openxmlformats.org/drawingml/2006/main">
               <a:ext uri="{FF2B5EF4-FFF2-40B4-BE49-F238E27FC236}">
-                <a16:creationId xmlns:a16="http://schemas.microsoft.com/office/drawing/2014/main" id="{49533184-3521-4903-A174-3B221BB6857A}"/>
+                <a16:creationId xmlns:a16="http://schemas.microsoft.com/office/drawing/2014/main" id="{5D4D6EC5-94A3-4C60-8668-850794A3DC46}"/>
               </a:ext>
             </a:extLst>
           </p:cNvPr>
@@ -28035,7 +28035,7 @@
           <p:cNvPr id="16" name="">
             <a:extLst xmlns:a="http://schemas.openxmlformats.org/drawingml/2006/main">
               <a:ext uri="{FF2B5EF4-FFF2-40B4-BE49-F238E27FC236}">
-                <a16:creationId xmlns:a16="http://schemas.microsoft.com/office/drawing/2014/main" id="{392C6ADD-91F6-446F-BCC0-CD579599D593}"/>
+                <a16:creationId xmlns:a16="http://schemas.microsoft.com/office/drawing/2014/main" id="{0E867A23-EB57-4AC1-BCDF-D80864C69C08}"/>
               </a:ext>
             </a:extLst>
           </p:cNvPr>
@@ -28070,7 +28070,7 @@
           <p:cNvPr id="17" name="">
             <a:extLst xmlns:a="http://schemas.openxmlformats.org/drawingml/2006/main">
               <a:ext uri="{FF2B5EF4-FFF2-40B4-BE49-F238E27FC236}">
-                <a16:creationId xmlns:a16="http://schemas.microsoft.com/office/drawing/2014/main" id="{1B3F1EB1-2680-49D8-800F-5D6F54B65A5D}"/>
+                <a16:creationId xmlns:a16="http://schemas.microsoft.com/office/drawing/2014/main" id="{92EE4568-7D23-44F1-AFE6-C1C7627AF453}"/>
               </a:ext>
             </a:extLst>
           </p:cNvPr>
@@ -28233,7 +28233,7 @@
           <p:cNvPr id="18" name="">
             <a:extLst xmlns:a="http://schemas.openxmlformats.org/drawingml/2006/main">
               <a:ext uri="{FF2B5EF4-FFF2-40B4-BE49-F238E27FC236}">
-                <a16:creationId xmlns:a16="http://schemas.microsoft.com/office/drawing/2014/main" id="{38A2B7B3-F0EF-459A-A7D0-446631B4491A}"/>
+                <a16:creationId xmlns:a16="http://schemas.microsoft.com/office/drawing/2014/main" id="{E28D0605-83E7-45A8-9B27-6BD9D921B218}"/>
               </a:ext>
             </a:extLst>
           </p:cNvPr>
@@ -28268,7 +28268,7 @@
           <p:cNvPr id="19" name="">
             <a:extLst xmlns:a="http://schemas.openxmlformats.org/drawingml/2006/main">
               <a:ext uri="{FF2B5EF4-FFF2-40B4-BE49-F238E27FC236}">
-                <a16:creationId xmlns:a16="http://schemas.microsoft.com/office/drawing/2014/main" id="{BF153A0C-FDDD-4ECE-A38F-C7E893AF8772}"/>
+                <a16:creationId xmlns:a16="http://schemas.microsoft.com/office/drawing/2014/main" id="{9D3AED3F-B304-4349-A032-2AEBE908143E}"/>
               </a:ext>
             </a:extLst>
           </p:cNvPr>
@@ -28431,7 +28431,7 @@
           <p:cNvPr id="20" name="">
             <a:extLst xmlns:a="http://schemas.openxmlformats.org/drawingml/2006/main">
               <a:ext uri="{FF2B5EF4-FFF2-40B4-BE49-F238E27FC236}">
-                <a16:creationId xmlns:a16="http://schemas.microsoft.com/office/drawing/2014/main" id="{9B0FDB2D-2D7B-48F5-AB13-C26B14E75FBF}"/>
+                <a16:creationId xmlns:a16="http://schemas.microsoft.com/office/drawing/2014/main" id="{A0BFAD92-A8A8-492A-918C-4C280DD2CB40}"/>
               </a:ext>
             </a:extLst>
           </p:cNvPr>
@@ -28462,7 +28462,7 @@
           <p:cNvPr id="21" name="">
             <a:extLst xmlns:a="http://schemas.openxmlformats.org/drawingml/2006/main">
               <a:ext uri="{FF2B5EF4-FFF2-40B4-BE49-F238E27FC236}">
-                <a16:creationId xmlns:a16="http://schemas.microsoft.com/office/drawing/2014/main" id="{BF89588D-9B14-488C-8EB0-EBC5E1A20275}"/>
+                <a16:creationId xmlns:a16="http://schemas.microsoft.com/office/drawing/2014/main" id="{B5579870-CCCA-4192-83D4-13C8CBD4B263}"/>
               </a:ext>
             </a:extLst>
           </p:cNvPr>
@@ -28623,7 +28623,7 @@
     </p:spTree>
     <p:extLst>
       <p:ext uri="{BB962C8B-B14F-4D97-AF65-F5344CB8AC3E}">
-        <p14:creationId xmlns:p14="http://schemas.microsoft.com/office/powerpoint/2010/main" val="504674255"/>
+        <p14:creationId xmlns:p14="http://schemas.microsoft.com/office/powerpoint/2010/main" val="1703875876"/>
       </p:ext>
     </p:extLst>
   </p:cSld>
@@ -28654,7 +28654,7 @@
           <p:cNvPr id="9" name="">
             <a:extLst xmlns:a="http://schemas.openxmlformats.org/drawingml/2006/main">
               <a:ext uri="{FF2B5EF4-FFF2-40B4-BE49-F238E27FC236}">
-                <a16:creationId xmlns:a16="http://schemas.microsoft.com/office/drawing/2014/main" id="{40429943-3D8D-42A5-89A1-1A4B73CA5639}"/>
+                <a16:creationId xmlns:a16="http://schemas.microsoft.com/office/drawing/2014/main" id="{DA4FE94B-597A-453E-B876-32F16CE9D7BB}"/>
               </a:ext>
             </a:extLst>
           </p:cNvPr>
@@ -28817,7 +28817,7 @@
           <p:cNvPr id="2" name="">
             <a:extLst xmlns:a="http://schemas.openxmlformats.org/drawingml/2006/main">
               <a:ext uri="{FF2B5EF4-FFF2-40B4-BE49-F238E27FC236}">
-                <a16:creationId xmlns:a16="http://schemas.microsoft.com/office/drawing/2014/main" id="{F814BC11-2ADF-4702-AF0E-AF3FC46A414C}"/>
+                <a16:creationId xmlns:a16="http://schemas.microsoft.com/office/drawing/2014/main" id="{E7E322A5-CADD-456A-82CE-CBB555E6EE14}"/>
               </a:ext>
             </a:extLst>
           </p:cNvPr>
@@ -28980,7 +28980,7 @@
           <p:cNvPr id="3" name="">
             <a:extLst xmlns:a="http://schemas.openxmlformats.org/drawingml/2006/main">
               <a:ext uri="{FF2B5EF4-FFF2-40B4-BE49-F238E27FC236}">
-                <a16:creationId xmlns:a16="http://schemas.microsoft.com/office/drawing/2014/main" id="{ABCDAB1B-F61C-46C4-9EDE-0C750C2C042D}"/>
+                <a16:creationId xmlns:a16="http://schemas.microsoft.com/office/drawing/2014/main" id="{35F5FE32-38DC-49D9-AAFC-F02429FC2CDA}"/>
               </a:ext>
             </a:extLst>
           </p:cNvPr>
@@ -29011,7 +29011,7 @@
           <p:cNvPr id="4" name="">
             <a:extLst xmlns:a="http://schemas.openxmlformats.org/drawingml/2006/main">
               <a:ext uri="{FF2B5EF4-FFF2-40B4-BE49-F238E27FC236}">
-                <a16:creationId xmlns:a16="http://schemas.microsoft.com/office/drawing/2014/main" id="{667B70F8-97AE-454C-8257-6B0E045C77DD}"/>
+                <a16:creationId xmlns:a16="http://schemas.microsoft.com/office/drawing/2014/main" id="{F77FEF75-F4D8-40FC-932E-62AD61522210}"/>
               </a:ext>
             </a:extLst>
           </p:cNvPr>
@@ -29174,7 +29174,7 @@
           <p:cNvPr id="5" name="">
             <a:extLst xmlns:a="http://schemas.openxmlformats.org/drawingml/2006/main">
               <a:ext uri="{FF2B5EF4-FFF2-40B4-BE49-F238E27FC236}">
-                <a16:creationId xmlns:a16="http://schemas.microsoft.com/office/drawing/2014/main" id="{BD23762B-BC3E-4F50-9A78-7305ADDAF76A}"/>
+                <a16:creationId xmlns:a16="http://schemas.microsoft.com/office/drawing/2014/main" id="{8A449E88-0989-4B8E-B729-C779C13FC3B0}"/>
               </a:ext>
             </a:extLst>
           </p:cNvPr>
@@ -29337,7 +29337,7 @@
           <p:cNvPr id="6" name="">
             <a:extLst xmlns:a="http://schemas.openxmlformats.org/drawingml/2006/main">
               <a:ext uri="{FF2B5EF4-FFF2-40B4-BE49-F238E27FC236}">
-                <a16:creationId xmlns:a16="http://schemas.microsoft.com/office/drawing/2014/main" id="{1E5E73BD-B646-4F16-B66E-3D969D75B796}"/>
+                <a16:creationId xmlns:a16="http://schemas.microsoft.com/office/drawing/2014/main" id="{584B6719-77A1-4C28-8D7F-F1B534381C6D}"/>
               </a:ext>
             </a:extLst>
           </p:cNvPr>
@@ -29500,7 +29500,7 @@
           <p:cNvPr id="7" name="">
             <a:extLst xmlns:a="http://schemas.openxmlformats.org/drawingml/2006/main">
               <a:ext uri="{FF2B5EF4-FFF2-40B4-BE49-F238E27FC236}">
-                <a16:creationId xmlns:a16="http://schemas.microsoft.com/office/drawing/2014/main" id="{D305ADCB-1E62-48C1-9851-AB3BF276F8C2}"/>
+                <a16:creationId xmlns:a16="http://schemas.microsoft.com/office/drawing/2014/main" id="{985FEE75-D3A1-49E6-89BF-C924A4F540D9}"/>
               </a:ext>
             </a:extLst>
           </p:cNvPr>
@@ -29510,7 +29510,7 @@
           <p:nvPr/>
         </p:nvPicPr>
         <p:blipFill>
-          <a:blip xmlns:r="http://schemas.openxmlformats.org/officeDocument/2006/relationships" xmlns:a="http://schemas.openxmlformats.org/drawingml/2006/main" r:embed="R03d47e1b46fa4ba4"/>
+          <a:blip xmlns:r="http://schemas.openxmlformats.org/officeDocument/2006/relationships" xmlns:a="http://schemas.openxmlformats.org/drawingml/2006/main" r:embed="R31bac32deb0a4441"/>
           <a:srcRect xmlns:a="http://schemas.openxmlformats.org/drawingml/2006/main" l="0" t="33859" r="0" b="33859"/>
           <a:stretch xmlns:a="http://schemas.openxmlformats.org/drawingml/2006/main">
             <a:fillRect l="0" t="0" r="0" b="0"/>
@@ -29531,7 +29531,7 @@
           <p:cNvPr id="8" name="">
             <a:extLst xmlns:a="http://schemas.openxmlformats.org/drawingml/2006/main">
               <a:ext uri="{FF2B5EF4-FFF2-40B4-BE49-F238E27FC236}">
-                <a16:creationId xmlns:a16="http://schemas.microsoft.com/office/drawing/2014/main" id="{689FA79C-9A9B-49AE-A71A-644BDB743D71}"/>
+                <a16:creationId xmlns:a16="http://schemas.microsoft.com/office/drawing/2014/main" id="{5E4D5349-3A3F-4EC8-96E9-ADD719840274}"/>
               </a:ext>
             </a:extLst>
           </p:cNvPr>
@@ -29692,7 +29692,7 @@
     </p:spTree>
     <p:extLst>
       <p:ext uri="{BB962C8B-B14F-4D97-AF65-F5344CB8AC3E}">
-        <p14:creationId xmlns:p14="http://schemas.microsoft.com/office/powerpoint/2010/main" val="583966149"/>
+        <p14:creationId xmlns:p14="http://schemas.microsoft.com/office/powerpoint/2010/main" val="338219347"/>
       </p:ext>
     </p:extLst>
   </p:cSld>
@@ -29723,7 +29723,7 @@
           <p:cNvPr id="24" name="">
             <a:extLst xmlns:a="http://schemas.openxmlformats.org/drawingml/2006/main">
               <a:ext uri="{FF2B5EF4-FFF2-40B4-BE49-F238E27FC236}">
-                <a16:creationId xmlns:a16="http://schemas.microsoft.com/office/drawing/2014/main" id="{C0B6C555-69F9-45DD-A698-E2F796E590D1}"/>
+                <a16:creationId xmlns:a16="http://schemas.microsoft.com/office/drawing/2014/main" id="{4A304AF4-9555-4E3A-8F33-70F5E30C39FE}"/>
               </a:ext>
             </a:extLst>
           </p:cNvPr>
@@ -29886,7 +29886,7 @@
           <p:cNvPr id="2" name="">
             <a:extLst xmlns:a="http://schemas.openxmlformats.org/drawingml/2006/main">
               <a:ext uri="{FF2B5EF4-FFF2-40B4-BE49-F238E27FC236}">
-                <a16:creationId xmlns:a16="http://schemas.microsoft.com/office/drawing/2014/main" id="{CD4AE7B6-4F0E-49C4-871C-181AB84835DD}"/>
+                <a16:creationId xmlns:a16="http://schemas.microsoft.com/office/drawing/2014/main" id="{FF21B236-62B7-425A-A44E-44F7BF623D95}"/>
               </a:ext>
             </a:extLst>
           </p:cNvPr>
@@ -30049,7 +30049,7 @@
           <p:cNvPr id="3" name="">
             <a:extLst xmlns:a="http://schemas.openxmlformats.org/drawingml/2006/main">
               <a:ext uri="{FF2B5EF4-FFF2-40B4-BE49-F238E27FC236}">
-                <a16:creationId xmlns:a16="http://schemas.microsoft.com/office/drawing/2014/main" id="{11957FDA-345F-436D-989B-D68C97D569D1}"/>
+                <a16:creationId xmlns:a16="http://schemas.microsoft.com/office/drawing/2014/main" id="{E09A648A-552D-4496-80B7-3E66EFF9D223}"/>
               </a:ext>
             </a:extLst>
           </p:cNvPr>
@@ -30080,7 +30080,7 @@
           <p:cNvPr id="4" name="">
             <a:extLst xmlns:a="http://schemas.openxmlformats.org/drawingml/2006/main">
               <a:ext uri="{FF2B5EF4-FFF2-40B4-BE49-F238E27FC236}">
-                <a16:creationId xmlns:a16="http://schemas.microsoft.com/office/drawing/2014/main" id="{5137EBD6-291A-4A5C-9DD9-12E4C2A50019}"/>
+                <a16:creationId xmlns:a16="http://schemas.microsoft.com/office/drawing/2014/main" id="{7285486E-C5B8-45FB-9172-8DD8F4C1189B}"/>
               </a:ext>
             </a:extLst>
           </p:cNvPr>
@@ -30243,7 +30243,7 @@
           <p:cNvPr id="5" name="">
             <a:extLst xmlns:a="http://schemas.openxmlformats.org/drawingml/2006/main">
               <a:ext uri="{FF2B5EF4-FFF2-40B4-BE49-F238E27FC236}">
-                <a16:creationId xmlns:a16="http://schemas.microsoft.com/office/drawing/2014/main" id="{778AE480-AC0E-4539-945A-C188A6A700E4}"/>
+                <a16:creationId xmlns:a16="http://schemas.microsoft.com/office/drawing/2014/main" id="{BAB2365F-EC21-4615-8DC4-EEC2E84BBF27}"/>
               </a:ext>
             </a:extLst>
           </p:cNvPr>
@@ -30406,7 +30406,7 @@
           <p:cNvPr id="6" name="">
             <a:extLst xmlns:a="http://schemas.openxmlformats.org/drawingml/2006/main">
               <a:ext uri="{FF2B5EF4-FFF2-40B4-BE49-F238E27FC236}">
-                <a16:creationId xmlns:a16="http://schemas.microsoft.com/office/drawing/2014/main" id="{F2E0DE16-97E1-4D66-BA87-8910ED029FEF}"/>
+                <a16:creationId xmlns:a16="http://schemas.microsoft.com/office/drawing/2014/main" id="{7685E531-1F03-4D77-87C1-06F5102FFD04}"/>
               </a:ext>
             </a:extLst>
           </p:cNvPr>
@@ -30569,7 +30569,7 @@
           <p:cNvPr id="7" name="">
             <a:extLst xmlns:a="http://schemas.openxmlformats.org/drawingml/2006/main">
               <a:ext uri="{FF2B5EF4-FFF2-40B4-BE49-F238E27FC236}">
-                <a16:creationId xmlns:a16="http://schemas.microsoft.com/office/drawing/2014/main" id="{7A873802-8327-414E-81B3-0CEF4D57AB30}"/>
+                <a16:creationId xmlns:a16="http://schemas.microsoft.com/office/drawing/2014/main" id="{208104A4-EFDA-4B58-B0CB-C088DC400A3C}"/>
               </a:ext>
             </a:extLst>
           </p:cNvPr>
@@ -30732,7 +30732,7 @@
           <p:cNvPr id="8" name="">
             <a:extLst xmlns:a="http://schemas.openxmlformats.org/drawingml/2006/main">
               <a:ext uri="{FF2B5EF4-FFF2-40B4-BE49-F238E27FC236}">
-                <a16:creationId xmlns:a16="http://schemas.microsoft.com/office/drawing/2014/main" id="{89005405-F4BD-4B83-AD3C-190F8946DB94}"/>
+                <a16:creationId xmlns:a16="http://schemas.microsoft.com/office/drawing/2014/main" id="{667B38B3-8DE3-4A0B-A24F-86F97E3AD1D4}"/>
               </a:ext>
             </a:extLst>
           </p:cNvPr>
@@ -30763,7 +30763,7 @@
           <p:cNvPr id="9" name="">
             <a:extLst xmlns:a="http://schemas.openxmlformats.org/drawingml/2006/main">
               <a:ext uri="{FF2B5EF4-FFF2-40B4-BE49-F238E27FC236}">
-                <a16:creationId xmlns:a16="http://schemas.microsoft.com/office/drawing/2014/main" id="{8CF26B30-C871-4B6E-83B5-18C87B1C101A}"/>
+                <a16:creationId xmlns:a16="http://schemas.microsoft.com/office/drawing/2014/main" id="{EBEDD651-0AE4-45BC-8D60-91C98DE2A4F8}"/>
               </a:ext>
             </a:extLst>
           </p:cNvPr>
@@ -30926,7 +30926,7 @@
           <p:cNvPr id="10" name="">
             <a:extLst xmlns:a="http://schemas.openxmlformats.org/drawingml/2006/main">
               <a:ext uri="{FF2B5EF4-FFF2-40B4-BE49-F238E27FC236}">
-                <a16:creationId xmlns:a16="http://schemas.microsoft.com/office/drawing/2014/main" id="{F53B3841-2E45-4B08-B5D9-500D85421099}"/>
+                <a16:creationId xmlns:a16="http://schemas.microsoft.com/office/drawing/2014/main" id="{BB2F9694-D895-4E28-B9DD-D5B0267D20A4}"/>
               </a:ext>
             </a:extLst>
           </p:cNvPr>
@@ -31089,7 +31089,7 @@
           <p:cNvPr id="11" name="">
             <a:extLst xmlns:a="http://schemas.openxmlformats.org/drawingml/2006/main">
               <a:ext uri="{FF2B5EF4-FFF2-40B4-BE49-F238E27FC236}">
-                <a16:creationId xmlns:a16="http://schemas.microsoft.com/office/drawing/2014/main" id="{0DCDCAE5-DD63-4074-BA15-2457A2EC4A4C}"/>
+                <a16:creationId xmlns:a16="http://schemas.microsoft.com/office/drawing/2014/main" id="{8516E342-7861-4023-82FB-C29B4E3CCEFD}"/>
               </a:ext>
             </a:extLst>
           </p:cNvPr>
@@ -31252,7 +31252,7 @@
           <p:cNvPr id="12" name="">
             <a:extLst xmlns:a="http://schemas.openxmlformats.org/drawingml/2006/main">
               <a:ext uri="{FF2B5EF4-FFF2-40B4-BE49-F238E27FC236}">
-                <a16:creationId xmlns:a16="http://schemas.microsoft.com/office/drawing/2014/main" id="{B4B3E95E-CBCE-4C68-A308-0A73D8081F8B}"/>
+                <a16:creationId xmlns:a16="http://schemas.microsoft.com/office/drawing/2014/main" id="{46334F1E-D00C-40AB-BF53-741F31B0EEEE}"/>
               </a:ext>
             </a:extLst>
           </p:cNvPr>
@@ -31283,7 +31283,7 @@
           <p:cNvPr id="13" name="">
             <a:extLst xmlns:a="http://schemas.openxmlformats.org/drawingml/2006/main">
               <a:ext uri="{FF2B5EF4-FFF2-40B4-BE49-F238E27FC236}">
-                <a16:creationId xmlns:a16="http://schemas.microsoft.com/office/drawing/2014/main" id="{BBEB7193-572B-49AE-96BD-73F9C4D3519D}"/>
+                <a16:creationId xmlns:a16="http://schemas.microsoft.com/office/drawing/2014/main" id="{B3BFE96F-B01B-4ADE-91AA-876AF311D642}"/>
               </a:ext>
             </a:extLst>
           </p:cNvPr>
@@ -31446,7 +31446,7 @@
           <p:cNvPr id="14" name="">
             <a:extLst xmlns:a="http://schemas.openxmlformats.org/drawingml/2006/main">
               <a:ext uri="{FF2B5EF4-FFF2-40B4-BE49-F238E27FC236}">
-                <a16:creationId xmlns:a16="http://schemas.microsoft.com/office/drawing/2014/main" id="{F28C18E1-2EAE-4DEF-8160-9EF5E4004E6F}"/>
+                <a16:creationId xmlns:a16="http://schemas.microsoft.com/office/drawing/2014/main" id="{67C3826E-0673-4865-8FE0-DBA5690E862D}"/>
               </a:ext>
             </a:extLst>
           </p:cNvPr>
@@ -31609,7 +31609,7 @@
           <p:cNvPr id="15" name="">
             <a:extLst xmlns:a="http://schemas.openxmlformats.org/drawingml/2006/main">
               <a:ext uri="{FF2B5EF4-FFF2-40B4-BE49-F238E27FC236}">
-                <a16:creationId xmlns:a16="http://schemas.microsoft.com/office/drawing/2014/main" id="{ACD0CEC8-4FBA-4125-B3F6-F89ECB7358B9}"/>
+                <a16:creationId xmlns:a16="http://schemas.microsoft.com/office/drawing/2014/main" id="{605BE6DE-DCE2-45BC-8902-A68E1A5E6CD3}"/>
               </a:ext>
             </a:extLst>
           </p:cNvPr>
@@ -31772,7 +31772,7 @@
           <p:cNvPr id="16" name="">
             <a:extLst xmlns:a="http://schemas.openxmlformats.org/drawingml/2006/main">
               <a:ext uri="{FF2B5EF4-FFF2-40B4-BE49-F238E27FC236}">
-                <a16:creationId xmlns:a16="http://schemas.microsoft.com/office/drawing/2014/main" id="{70681942-DCBB-4CE3-9029-4E59A1FDAC8C}"/>
+                <a16:creationId xmlns:a16="http://schemas.microsoft.com/office/drawing/2014/main" id="{BD130FAA-BDC8-4578-A5D1-1AAD29BD9EC0}"/>
               </a:ext>
             </a:extLst>
           </p:cNvPr>
@@ -31803,7 +31803,7 @@
           <p:cNvPr id="17" name="">
             <a:extLst xmlns:a="http://schemas.openxmlformats.org/drawingml/2006/main">
               <a:ext uri="{FF2B5EF4-FFF2-40B4-BE49-F238E27FC236}">
-                <a16:creationId xmlns:a16="http://schemas.microsoft.com/office/drawing/2014/main" id="{DAEC3D80-1934-4566-A457-4701A61CEC2E}"/>
+                <a16:creationId xmlns:a16="http://schemas.microsoft.com/office/drawing/2014/main" id="{632388D9-AF12-4FCA-BB52-7831C9ED7D9B}"/>
               </a:ext>
             </a:extLst>
           </p:cNvPr>
@@ -31966,7 +31966,7 @@
           <p:cNvPr id="18" name="">
             <a:extLst xmlns:a="http://schemas.openxmlformats.org/drawingml/2006/main">
               <a:ext uri="{FF2B5EF4-FFF2-40B4-BE49-F238E27FC236}">
-                <a16:creationId xmlns:a16="http://schemas.microsoft.com/office/drawing/2014/main" id="{C06E6CD3-B4E5-40B7-A3A1-ADFB744D3F0A}"/>
+                <a16:creationId xmlns:a16="http://schemas.microsoft.com/office/drawing/2014/main" id="{072F5BBA-04C0-4DFF-A06F-53D2242715FF}"/>
               </a:ext>
             </a:extLst>
           </p:cNvPr>
@@ -32129,7 +32129,7 @@
           <p:cNvPr id="19" name="">
             <a:extLst xmlns:a="http://schemas.openxmlformats.org/drawingml/2006/main">
               <a:ext uri="{FF2B5EF4-FFF2-40B4-BE49-F238E27FC236}">
-                <a16:creationId xmlns:a16="http://schemas.microsoft.com/office/drawing/2014/main" id="{AC57E3A8-232F-40CC-B693-E0F8685416A3}"/>
+                <a16:creationId xmlns:a16="http://schemas.microsoft.com/office/drawing/2014/main" id="{C1FABDF5-9B2D-4A0D-A70C-99C1B498D257}"/>
               </a:ext>
             </a:extLst>
           </p:cNvPr>
@@ -32292,7 +32292,7 @@
           <p:cNvPr id="20" name="">
             <a:extLst xmlns:a="http://schemas.openxmlformats.org/drawingml/2006/main">
               <a:ext uri="{FF2B5EF4-FFF2-40B4-BE49-F238E27FC236}">
-                <a16:creationId xmlns:a16="http://schemas.microsoft.com/office/drawing/2014/main" id="{137BC5D1-5777-41D1-AC86-DAD9883E0553}"/>
+                <a16:creationId xmlns:a16="http://schemas.microsoft.com/office/drawing/2014/main" id="{6F5C55AD-D085-45B4-B454-D0523B10D217}"/>
               </a:ext>
             </a:extLst>
           </p:cNvPr>
@@ -32323,7 +32323,7 @@
           <p:cNvPr id="21" name="">
             <a:extLst xmlns:a="http://schemas.openxmlformats.org/drawingml/2006/main">
               <a:ext uri="{FF2B5EF4-FFF2-40B4-BE49-F238E27FC236}">
-                <a16:creationId xmlns:a16="http://schemas.microsoft.com/office/drawing/2014/main" id="{826CC241-25D7-4F0B-889E-D791EC6C216C}"/>
+                <a16:creationId xmlns:a16="http://schemas.microsoft.com/office/drawing/2014/main" id="{51CA120A-6789-47FE-B8BB-52E3899C025F}"/>
               </a:ext>
             </a:extLst>
           </p:cNvPr>
@@ -32486,7 +32486,7 @@
           <p:cNvPr id="22" name="">
             <a:extLst xmlns:a="http://schemas.openxmlformats.org/drawingml/2006/main">
               <a:ext uri="{FF2B5EF4-FFF2-40B4-BE49-F238E27FC236}">
-                <a16:creationId xmlns:a16="http://schemas.microsoft.com/office/drawing/2014/main" id="{A495AB5E-917B-4C9F-AC74-5AD991E72D70}"/>
+                <a16:creationId xmlns:a16="http://schemas.microsoft.com/office/drawing/2014/main" id="{4A932B53-FAF2-44E0-9248-74013FC7A4C5}"/>
               </a:ext>
             </a:extLst>
           </p:cNvPr>
@@ -32519,7 +32519,7 @@
           <p:cNvPr id="23" name="">
             <a:extLst xmlns:a="http://schemas.openxmlformats.org/drawingml/2006/main">
               <a:ext uri="{FF2B5EF4-FFF2-40B4-BE49-F238E27FC236}">
-                <a16:creationId xmlns:a16="http://schemas.microsoft.com/office/drawing/2014/main" id="{324C6728-84D6-430A-BB2B-742128B51EAA}"/>
+                <a16:creationId xmlns:a16="http://schemas.microsoft.com/office/drawing/2014/main" id="{793DA935-F9C8-4741-A009-36673AE56933}"/>
               </a:ext>
             </a:extLst>
           </p:cNvPr>
@@ -32680,7 +32680,7 @@
     </p:spTree>
     <p:extLst>
       <p:ext uri="{BB962C8B-B14F-4D97-AF65-F5344CB8AC3E}">
-        <p14:creationId xmlns:p14="http://schemas.microsoft.com/office/powerpoint/2010/main" val="958072843"/>
+        <p14:creationId xmlns:p14="http://schemas.microsoft.com/office/powerpoint/2010/main" val="730661555"/>
       </p:ext>
     </p:extLst>
   </p:cSld>
@@ -32711,7 +32711,7 @@
           <p:cNvPr id="20" name="">
             <a:extLst xmlns:a="http://schemas.openxmlformats.org/drawingml/2006/main">
               <a:ext uri="{FF2B5EF4-FFF2-40B4-BE49-F238E27FC236}">
-                <a16:creationId xmlns:a16="http://schemas.microsoft.com/office/drawing/2014/main" id="{902A1B66-2AD8-4041-8AB6-3C47587D0742}"/>
+                <a16:creationId xmlns:a16="http://schemas.microsoft.com/office/drawing/2014/main" id="{3EFA7C4E-3D85-4009-976F-61B54E21982B}"/>
               </a:ext>
             </a:extLst>
           </p:cNvPr>
@@ -32874,7 +32874,7 @@
           <p:cNvPr id="2" name="">
             <a:extLst xmlns:a="http://schemas.openxmlformats.org/drawingml/2006/main">
               <a:ext uri="{FF2B5EF4-FFF2-40B4-BE49-F238E27FC236}">
-                <a16:creationId xmlns:a16="http://schemas.microsoft.com/office/drawing/2014/main" id="{7101C60D-8EF7-4CA9-9DF4-000E15B47657}"/>
+                <a16:creationId xmlns:a16="http://schemas.microsoft.com/office/drawing/2014/main" id="{2AB0F366-05E8-43B0-9E74-E1B6FB864C7F}"/>
               </a:ext>
             </a:extLst>
           </p:cNvPr>
@@ -33037,7 +33037,7 @@
           <p:cNvPr id="3" name="">
             <a:extLst xmlns:a="http://schemas.openxmlformats.org/drawingml/2006/main">
               <a:ext uri="{FF2B5EF4-FFF2-40B4-BE49-F238E27FC236}">
-                <a16:creationId xmlns:a16="http://schemas.microsoft.com/office/drawing/2014/main" id="{731E1EBE-958F-431C-AB2F-59516E7F6C63}"/>
+                <a16:creationId xmlns:a16="http://schemas.microsoft.com/office/drawing/2014/main" id="{B3B989B7-4A3A-4361-B59C-CBC6060C19DE}"/>
               </a:ext>
             </a:extLst>
           </p:cNvPr>
@@ -33068,7 +33068,7 @@
           <p:cNvPr id="4" name="">
             <a:extLst xmlns:a="http://schemas.openxmlformats.org/drawingml/2006/main">
               <a:ext uri="{FF2B5EF4-FFF2-40B4-BE49-F238E27FC236}">
-                <a16:creationId xmlns:a16="http://schemas.microsoft.com/office/drawing/2014/main" id="{A37CD8CC-4AD2-4EDD-95E3-66EF94A79838}"/>
+                <a16:creationId xmlns:a16="http://schemas.microsoft.com/office/drawing/2014/main" id="{649BBC00-F3EC-4FEA-98A3-E6F66D4763DD}"/>
               </a:ext>
             </a:extLst>
           </p:cNvPr>
@@ -33231,7 +33231,7 @@
           <p:cNvPr id="5" name="">
             <a:extLst xmlns:a="http://schemas.openxmlformats.org/drawingml/2006/main">
               <a:ext uri="{FF2B5EF4-FFF2-40B4-BE49-F238E27FC236}">
-                <a16:creationId xmlns:a16="http://schemas.microsoft.com/office/drawing/2014/main" id="{83ABC1F4-D270-4166-87A7-D209EE0D8068}"/>
+                <a16:creationId xmlns:a16="http://schemas.microsoft.com/office/drawing/2014/main" id="{9F90B51B-D356-4404-A9CE-9A75ABF20F33}"/>
               </a:ext>
             </a:extLst>
           </p:cNvPr>
@@ -33394,7 +33394,7 @@
           <p:cNvPr id="6" name="">
             <a:extLst xmlns:a="http://schemas.openxmlformats.org/drawingml/2006/main">
               <a:ext uri="{FF2B5EF4-FFF2-40B4-BE49-F238E27FC236}">
-                <a16:creationId xmlns:a16="http://schemas.microsoft.com/office/drawing/2014/main" id="{F3C59EFF-0027-4292-835E-C9CA192E0D74}"/>
+                <a16:creationId xmlns:a16="http://schemas.microsoft.com/office/drawing/2014/main" id="{FA0C0907-D004-4F45-A8A5-0E409E3617AD}"/>
               </a:ext>
             </a:extLst>
           </p:cNvPr>
@@ -33429,7 +33429,7 @@
           <p:cNvPr id="7" name="">
             <a:extLst xmlns:a="http://schemas.openxmlformats.org/drawingml/2006/main">
               <a:ext uri="{FF2B5EF4-FFF2-40B4-BE49-F238E27FC236}">
-                <a16:creationId xmlns:a16="http://schemas.microsoft.com/office/drawing/2014/main" id="{8BB74ED9-6E83-40BB-8ED3-E47B1111EFB1}"/>
+                <a16:creationId xmlns:a16="http://schemas.microsoft.com/office/drawing/2014/main" id="{7B088EF6-6E2E-4C84-A717-3A81DEB90AC6}"/>
               </a:ext>
             </a:extLst>
           </p:cNvPr>
@@ -33592,7 +33592,7 @@
           <p:cNvPr id="8" name="">
             <a:extLst xmlns:a="http://schemas.openxmlformats.org/drawingml/2006/main">
               <a:ext uri="{FF2B5EF4-FFF2-40B4-BE49-F238E27FC236}">
-                <a16:creationId xmlns:a16="http://schemas.microsoft.com/office/drawing/2014/main" id="{267C164A-A7C3-44FB-BA97-B8D5CAC54595}"/>
+                <a16:creationId xmlns:a16="http://schemas.microsoft.com/office/drawing/2014/main" id="{6FA4B5A9-AAC2-436C-B1E4-4613FA0F86F5}"/>
               </a:ext>
             </a:extLst>
           </p:cNvPr>
@@ -33623,7 +33623,7 @@
           <p:cNvPr id="9" name="">
             <a:extLst xmlns:a="http://schemas.openxmlformats.org/drawingml/2006/main">
               <a:ext uri="{FF2B5EF4-FFF2-40B4-BE49-F238E27FC236}">
-                <a16:creationId xmlns:a16="http://schemas.microsoft.com/office/drawing/2014/main" id="{E3BC816C-9A24-4E0C-8F40-13A0DCC58CC8}"/>
+                <a16:creationId xmlns:a16="http://schemas.microsoft.com/office/drawing/2014/main" id="{9E49A815-A65B-4C60-AC04-3B5766BE84EC}"/>
               </a:ext>
             </a:extLst>
           </p:cNvPr>
@@ -33658,7 +33658,7 @@
           <p:cNvPr id="10" name="">
             <a:extLst xmlns:a="http://schemas.openxmlformats.org/drawingml/2006/main">
               <a:ext uri="{FF2B5EF4-FFF2-40B4-BE49-F238E27FC236}">
-                <a16:creationId xmlns:a16="http://schemas.microsoft.com/office/drawing/2014/main" id="{34BCDA33-7995-4AC8-9858-20E32B0E9FA8}"/>
+                <a16:creationId xmlns:a16="http://schemas.microsoft.com/office/drawing/2014/main" id="{1F349C6C-BBD7-47B0-BEC3-AA97F05E3B9B}"/>
               </a:ext>
             </a:extLst>
           </p:cNvPr>
@@ -33821,7 +33821,7 @@
           <p:cNvPr id="11" name="">
             <a:extLst xmlns:a="http://schemas.openxmlformats.org/drawingml/2006/main">
               <a:ext uri="{FF2B5EF4-FFF2-40B4-BE49-F238E27FC236}">
-                <a16:creationId xmlns:a16="http://schemas.microsoft.com/office/drawing/2014/main" id="{AB2E4210-AD8B-4DDC-9823-C08616DD90E7}"/>
+                <a16:creationId xmlns:a16="http://schemas.microsoft.com/office/drawing/2014/main" id="{A1C91A9A-B290-4E72-AF0E-3717914DAB89}"/>
               </a:ext>
             </a:extLst>
           </p:cNvPr>
@@ -33852,7 +33852,7 @@
           <p:cNvPr id="12" name="">
             <a:extLst xmlns:a="http://schemas.openxmlformats.org/drawingml/2006/main">
               <a:ext uri="{FF2B5EF4-FFF2-40B4-BE49-F238E27FC236}">
-                <a16:creationId xmlns:a16="http://schemas.microsoft.com/office/drawing/2014/main" id="{0EB405E0-0F1F-49E3-ACC9-657C69BED658}"/>
+                <a16:creationId xmlns:a16="http://schemas.microsoft.com/office/drawing/2014/main" id="{EF45BA8F-C449-442E-8EB7-B1B166FE7E5C}"/>
               </a:ext>
             </a:extLst>
           </p:cNvPr>
@@ -33887,7 +33887,7 @@
           <p:cNvPr id="13" name="">
             <a:extLst xmlns:a="http://schemas.openxmlformats.org/drawingml/2006/main">
               <a:ext uri="{FF2B5EF4-FFF2-40B4-BE49-F238E27FC236}">
-                <a16:creationId xmlns:a16="http://schemas.microsoft.com/office/drawing/2014/main" id="{BF6D70EF-5E17-4288-9E66-F8400FB3E647}"/>
+                <a16:creationId xmlns:a16="http://schemas.microsoft.com/office/drawing/2014/main" id="{29D06BAC-54EB-438C-A380-7E763E6E659A}"/>
               </a:ext>
             </a:extLst>
           </p:cNvPr>
@@ -34050,7 +34050,7 @@
           <p:cNvPr id="14" name="">
             <a:extLst xmlns:a="http://schemas.openxmlformats.org/drawingml/2006/main">
               <a:ext uri="{FF2B5EF4-FFF2-40B4-BE49-F238E27FC236}">
-                <a16:creationId xmlns:a16="http://schemas.microsoft.com/office/drawing/2014/main" id="{70B43511-58DC-433B-88CA-4C39A1F8E0F2}"/>
+                <a16:creationId xmlns:a16="http://schemas.microsoft.com/office/drawing/2014/main" id="{868BC741-4666-4DAC-9DC9-8E115CB956F1}"/>
               </a:ext>
             </a:extLst>
           </p:cNvPr>
@@ -34081,7 +34081,7 @@
           <p:cNvPr id="15" name="">
             <a:extLst xmlns:a="http://schemas.openxmlformats.org/drawingml/2006/main">
               <a:ext uri="{FF2B5EF4-FFF2-40B4-BE49-F238E27FC236}">
-                <a16:creationId xmlns:a16="http://schemas.microsoft.com/office/drawing/2014/main" id="{69EB1CF6-44A6-4BF4-B795-668BD03F1AAF}"/>
+                <a16:creationId xmlns:a16="http://schemas.microsoft.com/office/drawing/2014/main" id="{50277121-9308-4E6F-854C-466F289D7EC2}"/>
               </a:ext>
             </a:extLst>
           </p:cNvPr>
@@ -34116,7 +34116,7 @@
           <p:cNvPr id="16" name="">
             <a:extLst xmlns:a="http://schemas.openxmlformats.org/drawingml/2006/main">
               <a:ext uri="{FF2B5EF4-FFF2-40B4-BE49-F238E27FC236}">
-                <a16:creationId xmlns:a16="http://schemas.microsoft.com/office/drawing/2014/main" id="{D1D26CA0-05B1-451D-872A-B4796D894055}"/>
+                <a16:creationId xmlns:a16="http://schemas.microsoft.com/office/drawing/2014/main" id="{6523152B-D0EF-4FA8-9F73-C0C05A0908BA}"/>
               </a:ext>
             </a:extLst>
           </p:cNvPr>
@@ -34279,7 +34279,7 @@
           <p:cNvPr id="17" name="">
             <a:extLst xmlns:a="http://schemas.openxmlformats.org/drawingml/2006/main">
               <a:ext uri="{FF2B5EF4-FFF2-40B4-BE49-F238E27FC236}">
-                <a16:creationId xmlns:a16="http://schemas.microsoft.com/office/drawing/2014/main" id="{09C6A534-E8A2-43C8-AF75-79F112A8CE95}"/>
+                <a16:creationId xmlns:a16="http://schemas.microsoft.com/office/drawing/2014/main" id="{4DB36D5A-9B73-4596-84DB-E14E6EF3391C}"/>
               </a:ext>
             </a:extLst>
           </p:cNvPr>
@@ -34442,7 +34442,7 @@
           <p:cNvPr id="18" name="">
             <a:extLst xmlns:a="http://schemas.openxmlformats.org/drawingml/2006/main">
               <a:ext uri="{FF2B5EF4-FFF2-40B4-BE49-F238E27FC236}">
-                <a16:creationId xmlns:a16="http://schemas.microsoft.com/office/drawing/2014/main" id="{28D44E12-00D5-496F-AF67-ABEECBC05FDD}"/>
+                <a16:creationId xmlns:a16="http://schemas.microsoft.com/office/drawing/2014/main" id="{44DE8C5B-7649-4AAC-964C-8656B81D89D1}"/>
               </a:ext>
             </a:extLst>
           </p:cNvPr>
@@ -34632,7 +34632,7 @@
           <p:cNvPr id="19" name="">
             <a:extLst xmlns:a="http://schemas.openxmlformats.org/drawingml/2006/main">
               <a:ext uri="{FF2B5EF4-FFF2-40B4-BE49-F238E27FC236}">
-                <a16:creationId xmlns:a16="http://schemas.microsoft.com/office/drawing/2014/main" id="{84D8C367-24D8-47E9-8923-AA95DAFB5F0D}"/>
+                <a16:creationId xmlns:a16="http://schemas.microsoft.com/office/drawing/2014/main" id="{434DDFD1-3159-43B4-9077-46C60E1A68F5}"/>
               </a:ext>
             </a:extLst>
           </p:cNvPr>
@@ -34785,7 +34785,7 @@
                 <a:ea typeface="Segoe UI"/>
                 <a:cs typeface="Segoe UI"/>
               </a:rPr>
-              <a:t>Truy vấn phạm vi và snapshot của Toàn còn ở PR #25, chưa tích hợp vào main.</a:t>
+              <a:t>Truy vấn của Toàn đã được đưa vào nhánh Tuấn; PR #25 chưa merge main.</a:t>
             </a:r>
           </a:p>
         </p:txBody>
@@ -34793,7 +34793,7 @@
     </p:spTree>
     <p:extLst>
       <p:ext uri="{BB962C8B-B14F-4D97-AF65-F5344CB8AC3E}">
-        <p14:creationId xmlns:p14="http://schemas.microsoft.com/office/powerpoint/2010/main" val="294354708"/>
+        <p14:creationId xmlns:p14="http://schemas.microsoft.com/office/powerpoint/2010/main" val="1223406830"/>
       </p:ext>
     </p:extLst>
   </p:cSld>

</xml_diff>